<commit_message>
fix: close evaluator artifact privacy boundary
</commit_message>
<xml_diff>
--- a/docs/Interview_2_Customer_Presentation.pptx
+++ b/docs/Interview_2_Customer_Presentation.pptx
@@ -2,24 +2,24 @@
 <file path=ppt/presentation.xml><?xml version="1.0" encoding="utf-8"?>
 <p:presentation xmlns:p="http://schemas.openxmlformats.org/presentationml/2006/main">
   <p:sldMasterIdLst>
-    <p:sldMasterId xmlns:r="http://schemas.openxmlformats.org/officeDocument/2006/relationships" id="2147483648" r:id="R922bd7b9619e44e6"/>
+    <p:sldMasterId xmlns:r="http://schemas.openxmlformats.org/officeDocument/2006/relationships" id="2147483648" r:id="R23d82f39609e4d26"/>
   </p:sldMasterIdLst>
   <p:notesMasterIdLst>
-    <p:notesMasterId xmlns:r="http://schemas.openxmlformats.org/officeDocument/2006/relationships" r:id="R65efac5b17c3497f"/>
+    <p:notesMasterId xmlns:r="http://schemas.openxmlformats.org/officeDocument/2006/relationships" r:id="Redb17f78a7854da5"/>
   </p:notesMasterIdLst>
   <p:sldIdLst>
-    <p:sldId xmlns:r="http://schemas.openxmlformats.org/officeDocument/2006/relationships" id="256" r:id="Ra4f7fbd8e35b44f3"/>
-    <p:sldId xmlns:r="http://schemas.openxmlformats.org/officeDocument/2006/relationships" id="257" r:id="R7fc874ba14cf4828"/>
-    <p:sldId xmlns:r="http://schemas.openxmlformats.org/officeDocument/2006/relationships" id="258" r:id="Rbd8c973338be40f9"/>
-    <p:sldId xmlns:r="http://schemas.openxmlformats.org/officeDocument/2006/relationships" id="259" r:id="R284c29fd42a04e5b"/>
-    <p:sldId xmlns:r="http://schemas.openxmlformats.org/officeDocument/2006/relationships" id="260" r:id="R5a895df41a004347"/>
-    <p:sldId xmlns:r="http://schemas.openxmlformats.org/officeDocument/2006/relationships" id="261" r:id="R2cf3a7f44fb24acb"/>
-    <p:sldId xmlns:r="http://schemas.openxmlformats.org/officeDocument/2006/relationships" id="262" r:id="R22e26ee66570407f"/>
-    <p:sldId xmlns:r="http://schemas.openxmlformats.org/officeDocument/2006/relationships" id="263" r:id="R3ba5b0d97e394683"/>
-    <p:sldId xmlns:r="http://schemas.openxmlformats.org/officeDocument/2006/relationships" id="264" r:id="R278d758cc2ce4d08"/>
-    <p:sldId xmlns:r="http://schemas.openxmlformats.org/officeDocument/2006/relationships" id="265" r:id="R220225dfce6d473a"/>
-    <p:sldId xmlns:r="http://schemas.openxmlformats.org/officeDocument/2006/relationships" id="266" r:id="Rcbb7f185bbf04b0b"/>
-    <p:sldId xmlns:r="http://schemas.openxmlformats.org/officeDocument/2006/relationships" id="267" r:id="Ra0931c6cbbdd4b5c"/>
+    <p:sldId xmlns:r="http://schemas.openxmlformats.org/officeDocument/2006/relationships" id="256" r:id="Rcd30c8bb72174990"/>
+    <p:sldId xmlns:r="http://schemas.openxmlformats.org/officeDocument/2006/relationships" id="257" r:id="Ra78d01fa8d594e56"/>
+    <p:sldId xmlns:r="http://schemas.openxmlformats.org/officeDocument/2006/relationships" id="258" r:id="Rc6869758d823432e"/>
+    <p:sldId xmlns:r="http://schemas.openxmlformats.org/officeDocument/2006/relationships" id="259" r:id="R00900a87356d4f20"/>
+    <p:sldId xmlns:r="http://schemas.openxmlformats.org/officeDocument/2006/relationships" id="260" r:id="R520cd8000f2f46f4"/>
+    <p:sldId xmlns:r="http://schemas.openxmlformats.org/officeDocument/2006/relationships" id="261" r:id="R9d7af89ba79d4b57"/>
+    <p:sldId xmlns:r="http://schemas.openxmlformats.org/officeDocument/2006/relationships" id="262" r:id="R7e5e0efead5a406b"/>
+    <p:sldId xmlns:r="http://schemas.openxmlformats.org/officeDocument/2006/relationships" id="263" r:id="R3aff725fbbca4604"/>
+    <p:sldId xmlns:r="http://schemas.openxmlformats.org/officeDocument/2006/relationships" id="264" r:id="Rb85e70a5df004f58"/>
+    <p:sldId xmlns:r="http://schemas.openxmlformats.org/officeDocument/2006/relationships" id="265" r:id="R47fa5b18f5e44a3d"/>
+    <p:sldId xmlns:r="http://schemas.openxmlformats.org/officeDocument/2006/relationships" id="266" r:id="Rdc5c3fac795c4cc4"/>
+    <p:sldId xmlns:r="http://schemas.openxmlformats.org/officeDocument/2006/relationships" id="267" r:id="Rd153fc7ec26f446b"/>
   </p:sldIdLst>
   <p:sldSz cx="12192000" cy="6858000"/>
   <p:notesSz cx="6858000" cy="9144000"/>
@@ -1338,7 +1338,7 @@
   </p:cSld>
   <p:clrMap bg1="lt1" tx1="dk1" bg2="lt2" tx2="dk2" accent1="accent1" accent2="accent2" accent3="accent3" accent4="accent4" accent5="accent5" accent6="accent6" hlink="hlink" folHlink="folHlink"/>
   <p:sldLayoutIdLst>
-    <p:sldLayoutId xmlns:r="http://schemas.openxmlformats.org/officeDocument/2006/relationships" id="2147483649" r:id="Re0f304e8d4e94e03"/>
+    <p:sldLayoutId xmlns:r="http://schemas.openxmlformats.org/officeDocument/2006/relationships" id="2147483649" r:id="R06908231e4674ef6"/>
   </p:sldLayoutIdLst>
   <p:txStyles>
     <p:titleStyle>
@@ -1889,7 +1889,7 @@
           <p:cNvPr id="13" name="">
             <a:extLst xmlns:a="http://schemas.openxmlformats.org/drawingml/2006/main">
               <a:ext uri="{FF2B5EF4-FFF2-40B4-BE49-F238E27FC236}">
-                <a16:creationId xmlns:a16="http://schemas.microsoft.com/office/drawing/2014/main" id="{A72E1958-A782-49ED-A7D4-A6E047476B35}"/>
+                <a16:creationId xmlns:a16="http://schemas.microsoft.com/office/drawing/2014/main" id="{D70E756A-C3CE-455E-9174-B672301982F9}"/>
               </a:ext>
             </a:extLst>
           </p:cNvPr>
@@ -1922,7 +1922,7 @@
           <p:cNvPr id="2" name="">
             <a:extLst xmlns:a="http://schemas.openxmlformats.org/drawingml/2006/main">
               <a:ext uri="{FF2B5EF4-FFF2-40B4-BE49-F238E27FC236}">
-                <a16:creationId xmlns:a16="http://schemas.microsoft.com/office/drawing/2014/main" id="{BCC3E7AA-F813-4FEC-8DDD-83B665E99B99}"/>
+                <a16:creationId xmlns:a16="http://schemas.microsoft.com/office/drawing/2014/main" id="{88BB1C4E-13F2-49A4-BBDE-BC08F2021D9C}"/>
               </a:ext>
             </a:extLst>
           </p:cNvPr>
@@ -1972,7 +1972,7 @@
           <p:cNvPr id="3" name="">
             <a:extLst xmlns:a="http://schemas.openxmlformats.org/drawingml/2006/main">
               <a:ext uri="{FF2B5EF4-FFF2-40B4-BE49-F238E27FC236}">
-                <a16:creationId xmlns:a16="http://schemas.microsoft.com/office/drawing/2014/main" id="{E0D2FBC5-CDB6-4816-949E-C8726B019A2C}"/>
+                <a16:creationId xmlns:a16="http://schemas.microsoft.com/office/drawing/2014/main" id="{05952D4C-1282-4716-A866-D14F7D7E3440}"/>
               </a:ext>
             </a:extLst>
           </p:cNvPr>
@@ -2039,7 +2039,7 @@
           <p:cNvPr id="4" name="">
             <a:extLst xmlns:a="http://schemas.openxmlformats.org/drawingml/2006/main">
               <a:ext uri="{FF2B5EF4-FFF2-40B4-BE49-F238E27FC236}">
-                <a16:creationId xmlns:a16="http://schemas.microsoft.com/office/drawing/2014/main" id="{AEC54908-CA34-44F2-A066-8C6637D884B5}"/>
+                <a16:creationId xmlns:a16="http://schemas.microsoft.com/office/drawing/2014/main" id="{D532A8F5-79FC-45D6-B168-A685D4E85E93}"/>
               </a:ext>
             </a:extLst>
           </p:cNvPr>
@@ -2089,7 +2089,7 @@
           <p:cNvPr id="5" name="">
             <a:extLst xmlns:a="http://schemas.openxmlformats.org/drawingml/2006/main">
               <a:ext uri="{FF2B5EF4-FFF2-40B4-BE49-F238E27FC236}">
-                <a16:creationId xmlns:a16="http://schemas.microsoft.com/office/drawing/2014/main" id="{40164EE3-3D8B-475F-A0E8-644AAD9CB0F0}"/>
+                <a16:creationId xmlns:a16="http://schemas.microsoft.com/office/drawing/2014/main" id="{4B6834DF-8BFC-44BF-841B-448C968A8CCF}"/>
               </a:ext>
             </a:extLst>
           </p:cNvPr>
@@ -2122,7 +2122,7 @@
           <p:cNvPr id="6" name="">
             <a:extLst xmlns:a="http://schemas.openxmlformats.org/drawingml/2006/main">
               <a:ext uri="{FF2B5EF4-FFF2-40B4-BE49-F238E27FC236}">
-                <a16:creationId xmlns:a16="http://schemas.microsoft.com/office/drawing/2014/main" id="{56A2AE54-FA62-4DCB-97E6-9BE784A4CAB3}"/>
+                <a16:creationId xmlns:a16="http://schemas.microsoft.com/office/drawing/2014/main" id="{77DA0408-0BF4-4972-9ACB-9D31E6A1A0D7}"/>
               </a:ext>
             </a:extLst>
           </p:cNvPr>
@@ -2172,7 +2172,7 @@
           <p:cNvPr id="7" name="">
             <a:extLst xmlns:a="http://schemas.openxmlformats.org/drawingml/2006/main">
               <a:ext uri="{FF2B5EF4-FFF2-40B4-BE49-F238E27FC236}">
-                <a16:creationId xmlns:a16="http://schemas.microsoft.com/office/drawing/2014/main" id="{F192A8AD-5CD3-46D4-A4F3-7E53C151881B}"/>
+                <a16:creationId xmlns:a16="http://schemas.microsoft.com/office/drawing/2014/main" id="{9D893071-F881-424B-B914-AE6628A3FDBA}"/>
               </a:ext>
             </a:extLst>
           </p:cNvPr>
@@ -2222,7 +2222,7 @@
           <p:cNvPr id="8" name="">
             <a:extLst xmlns:a="http://schemas.openxmlformats.org/drawingml/2006/main">
               <a:ext uri="{FF2B5EF4-FFF2-40B4-BE49-F238E27FC236}">
-                <a16:creationId xmlns:a16="http://schemas.microsoft.com/office/drawing/2014/main" id="{2B5253A9-8771-480B-BBFE-EEDD893BA093}"/>
+                <a16:creationId xmlns:a16="http://schemas.microsoft.com/office/drawing/2014/main" id="{E4D58984-F9B7-4991-99FA-9A8B59A632BF}"/>
               </a:ext>
             </a:extLst>
           </p:cNvPr>
@@ -2272,7 +2272,7 @@
           <p:cNvPr id="9" name="">
             <a:extLst xmlns:a="http://schemas.openxmlformats.org/drawingml/2006/main">
               <a:ext uri="{FF2B5EF4-FFF2-40B4-BE49-F238E27FC236}">
-                <a16:creationId xmlns:a16="http://schemas.microsoft.com/office/drawing/2014/main" id="{474A3EC0-C5D3-434A-AB85-428530E2A707}"/>
+                <a16:creationId xmlns:a16="http://schemas.microsoft.com/office/drawing/2014/main" id="{B1658E27-E63F-4EE5-84BB-D9FB2D12610D}"/>
               </a:ext>
             </a:extLst>
           </p:cNvPr>
@@ -2322,7 +2322,7 @@
           <p:cNvPr id="10" name="">
             <a:extLst xmlns:a="http://schemas.openxmlformats.org/drawingml/2006/main">
               <a:ext uri="{FF2B5EF4-FFF2-40B4-BE49-F238E27FC236}">
-                <a16:creationId xmlns:a16="http://schemas.microsoft.com/office/drawing/2014/main" id="{0399F9F2-BB41-4B59-BBAB-B85D8FE88F56}"/>
+                <a16:creationId xmlns:a16="http://schemas.microsoft.com/office/drawing/2014/main" id="{DA6A42E1-DE39-46E7-A633-62690949D39C}"/>
               </a:ext>
             </a:extLst>
           </p:cNvPr>
@@ -2372,7 +2372,7 @@
           <p:cNvPr id="11" name="">
             <a:extLst xmlns:a="http://schemas.openxmlformats.org/drawingml/2006/main">
               <a:ext uri="{FF2B5EF4-FFF2-40B4-BE49-F238E27FC236}">
-                <a16:creationId xmlns:a16="http://schemas.microsoft.com/office/drawing/2014/main" id="{09D7351B-8B07-4C78-9100-31A186B62FA1}"/>
+                <a16:creationId xmlns:a16="http://schemas.microsoft.com/office/drawing/2014/main" id="{E48166F7-2DF4-4144-A4C0-5FE7BB3B17D3}"/>
               </a:ext>
             </a:extLst>
           </p:cNvPr>
@@ -2422,7 +2422,7 @@
           <p:cNvPr id="12" name="">
             <a:extLst xmlns:a="http://schemas.openxmlformats.org/drawingml/2006/main">
               <a:ext uri="{FF2B5EF4-FFF2-40B4-BE49-F238E27FC236}">
-                <a16:creationId xmlns:a16="http://schemas.microsoft.com/office/drawing/2014/main" id="{0CA66238-97F6-4395-9F3C-575CA03F6304}"/>
+                <a16:creationId xmlns:a16="http://schemas.microsoft.com/office/drawing/2014/main" id="{78FF2A8B-A34A-4775-B543-9D01EBBD2B39}"/>
               </a:ext>
             </a:extLst>
           </p:cNvPr>
@@ -2470,7 +2470,7 @@
     </p:spTree>
     <p:extLst>
       <p:ext uri="{BB962C8B-B14F-4D97-AF65-F5344CB8AC3E}">
-        <p14:creationId xmlns:p14="http://schemas.microsoft.com/office/powerpoint/2010/main" val="700628330"/>
+        <p14:creationId xmlns:p14="http://schemas.microsoft.com/office/powerpoint/2010/main" val="1218036231"/>
       </p:ext>
     </p:extLst>
   </p:cSld>
@@ -2501,7 +2501,7 @@
           <p:cNvPr id="47" name="">
             <a:extLst xmlns:a="http://schemas.openxmlformats.org/drawingml/2006/main">
               <a:ext uri="{FF2B5EF4-FFF2-40B4-BE49-F238E27FC236}">
-                <a16:creationId xmlns:a16="http://schemas.microsoft.com/office/drawing/2014/main" id="{6F270559-FF89-4826-8EF4-E876918C1777}"/>
+                <a16:creationId xmlns:a16="http://schemas.microsoft.com/office/drawing/2014/main" id="{F1A634C4-7FBA-4930-84B1-1E711E365A7D}"/>
               </a:ext>
             </a:extLst>
           </p:cNvPr>
@@ -2551,7 +2551,7 @@
           <p:cNvPr id="2" name="">
             <a:extLst xmlns:a="http://schemas.openxmlformats.org/drawingml/2006/main">
               <a:ext uri="{FF2B5EF4-FFF2-40B4-BE49-F238E27FC236}">
-                <a16:creationId xmlns:a16="http://schemas.microsoft.com/office/drawing/2014/main" id="{5919AAD1-EA32-4993-9213-9048943D8AE7}"/>
+                <a16:creationId xmlns:a16="http://schemas.microsoft.com/office/drawing/2014/main" id="{17F79A6D-EC01-4974-A1B7-8CD01377EB3B}"/>
               </a:ext>
             </a:extLst>
           </p:cNvPr>
@@ -2601,7 +2601,7 @@
           <p:cNvPr id="3" name="">
             <a:extLst xmlns:a="http://schemas.openxmlformats.org/drawingml/2006/main">
               <a:ext uri="{FF2B5EF4-FFF2-40B4-BE49-F238E27FC236}">
-                <a16:creationId xmlns:a16="http://schemas.microsoft.com/office/drawing/2014/main" id="{020C8285-E9BC-4D52-989F-03BD2C298CF2}"/>
+                <a16:creationId xmlns:a16="http://schemas.microsoft.com/office/drawing/2014/main" id="{097CDBBB-18AA-48FA-A679-90C6CCCED93D}"/>
               </a:ext>
             </a:extLst>
           </p:cNvPr>
@@ -2651,7 +2651,7 @@
           <p:cNvPr id="4" name="">
             <a:extLst xmlns:a="http://schemas.openxmlformats.org/drawingml/2006/main">
               <a:ext uri="{FF2B5EF4-FFF2-40B4-BE49-F238E27FC236}">
-                <a16:creationId xmlns:a16="http://schemas.microsoft.com/office/drawing/2014/main" id="{A8281156-4C71-4710-8328-73B39A878166}"/>
+                <a16:creationId xmlns:a16="http://schemas.microsoft.com/office/drawing/2014/main" id="{D68D4667-BA91-4EA7-B6F4-A1A8BEBC9868}"/>
               </a:ext>
             </a:extLst>
           </p:cNvPr>
@@ -2701,7 +2701,7 @@
           <p:cNvPr id="5" name="">
             <a:extLst xmlns:a="http://schemas.openxmlformats.org/drawingml/2006/main">
               <a:ext uri="{FF2B5EF4-FFF2-40B4-BE49-F238E27FC236}">
-                <a16:creationId xmlns:a16="http://schemas.microsoft.com/office/drawing/2014/main" id="{10EA863E-CA17-483C-9725-360D94D7FE6E}"/>
+                <a16:creationId xmlns:a16="http://schemas.microsoft.com/office/drawing/2014/main" id="{36DECE1B-DF08-448C-9B7F-8593DAF850FB}"/>
               </a:ext>
             </a:extLst>
           </p:cNvPr>
@@ -2751,7 +2751,7 @@
           <p:cNvPr id="6" name="">
             <a:extLst xmlns:a="http://schemas.openxmlformats.org/drawingml/2006/main">
               <a:ext uri="{FF2B5EF4-FFF2-40B4-BE49-F238E27FC236}">
-                <a16:creationId xmlns:a16="http://schemas.microsoft.com/office/drawing/2014/main" id="{E7F8EAF8-C525-485B-B791-39F01927A368}"/>
+                <a16:creationId xmlns:a16="http://schemas.microsoft.com/office/drawing/2014/main" id="{8A0FC8EB-7BAE-471D-9144-3E57FCD2ED50}"/>
               </a:ext>
             </a:extLst>
           </p:cNvPr>
@@ -2784,7 +2784,7 @@
           <p:cNvPr id="7" name="">
             <a:extLst xmlns:a="http://schemas.openxmlformats.org/drawingml/2006/main">
               <a:ext uri="{FF2B5EF4-FFF2-40B4-BE49-F238E27FC236}">
-                <a16:creationId xmlns:a16="http://schemas.microsoft.com/office/drawing/2014/main" id="{CCA1737A-B230-4DC0-A1ED-05B75D2E8F6C}"/>
+                <a16:creationId xmlns:a16="http://schemas.microsoft.com/office/drawing/2014/main" id="{3023ADDC-9ECC-4421-90FC-86E6EF79AAA4}"/>
               </a:ext>
             </a:extLst>
           </p:cNvPr>
@@ -2817,7 +2817,7 @@
           <p:cNvPr id="8" name="">
             <a:extLst xmlns:a="http://schemas.openxmlformats.org/drawingml/2006/main">
               <a:ext uri="{FF2B5EF4-FFF2-40B4-BE49-F238E27FC236}">
-                <a16:creationId xmlns:a16="http://schemas.microsoft.com/office/drawing/2014/main" id="{C5E7AB66-EDF7-4A9F-8959-A09B01BEEBE5}"/>
+                <a16:creationId xmlns:a16="http://schemas.microsoft.com/office/drawing/2014/main" id="{CF078473-49AC-400A-94C0-DFE06A6B1440}"/>
               </a:ext>
             </a:extLst>
           </p:cNvPr>
@@ -2867,7 +2867,7 @@
           <p:cNvPr id="9" name="">
             <a:extLst xmlns:a="http://schemas.openxmlformats.org/drawingml/2006/main">
               <a:ext uri="{FF2B5EF4-FFF2-40B4-BE49-F238E27FC236}">
-                <a16:creationId xmlns:a16="http://schemas.microsoft.com/office/drawing/2014/main" id="{E9DC67BA-0006-435A-A53C-B13DFBF7A387}"/>
+                <a16:creationId xmlns:a16="http://schemas.microsoft.com/office/drawing/2014/main" id="{99404F44-2362-4389-AFF6-45FC3E98BF51}"/>
               </a:ext>
             </a:extLst>
           </p:cNvPr>
@@ -2934,7 +2934,7 @@
           <p:cNvPr id="10" name="">
             <a:extLst xmlns:a="http://schemas.openxmlformats.org/drawingml/2006/main">
               <a:ext uri="{FF2B5EF4-FFF2-40B4-BE49-F238E27FC236}">
-                <a16:creationId xmlns:a16="http://schemas.microsoft.com/office/drawing/2014/main" id="{01AAC51E-0396-4BE5-9C27-CAF467C7BE37}"/>
+                <a16:creationId xmlns:a16="http://schemas.microsoft.com/office/drawing/2014/main" id="{21016FFD-9515-498A-A459-EFC03D3FA66A}"/>
               </a:ext>
             </a:extLst>
           </p:cNvPr>
@@ -2984,7 +2984,7 @@
           <p:cNvPr id="11" name="">
             <a:extLst xmlns:a="http://schemas.openxmlformats.org/drawingml/2006/main">
               <a:ext uri="{FF2B5EF4-FFF2-40B4-BE49-F238E27FC236}">
-                <a16:creationId xmlns:a16="http://schemas.microsoft.com/office/drawing/2014/main" id="{5CDA12D7-3C62-4770-86B6-15C639022FB8}"/>
+                <a16:creationId xmlns:a16="http://schemas.microsoft.com/office/drawing/2014/main" id="{58BF6665-FBA1-4171-8767-D8440F43AA09}"/>
               </a:ext>
             </a:extLst>
           </p:cNvPr>
@@ -3017,7 +3017,7 @@
           <p:cNvPr id="12" name="">
             <a:extLst xmlns:a="http://schemas.openxmlformats.org/drawingml/2006/main">
               <a:ext uri="{FF2B5EF4-FFF2-40B4-BE49-F238E27FC236}">
-                <a16:creationId xmlns:a16="http://schemas.microsoft.com/office/drawing/2014/main" id="{41C6A4BF-1697-4AB9-8DD9-BA20C8E66850}"/>
+                <a16:creationId xmlns:a16="http://schemas.microsoft.com/office/drawing/2014/main" id="{835C4DD4-B53C-4E8F-B31C-FB0F6876869E}"/>
               </a:ext>
             </a:extLst>
           </p:cNvPr>
@@ -3050,7 +3050,7 @@
           <p:cNvPr id="13" name="">
             <a:extLst xmlns:a="http://schemas.openxmlformats.org/drawingml/2006/main">
               <a:ext uri="{FF2B5EF4-FFF2-40B4-BE49-F238E27FC236}">
-                <a16:creationId xmlns:a16="http://schemas.microsoft.com/office/drawing/2014/main" id="{7CA5F45B-9B41-465B-BA86-2103D76AD9C3}"/>
+                <a16:creationId xmlns:a16="http://schemas.microsoft.com/office/drawing/2014/main" id="{CD7BA00C-32E9-4A6E-A82E-0809D69ABAEC}"/>
               </a:ext>
             </a:extLst>
           </p:cNvPr>
@@ -3100,7 +3100,7 @@
           <p:cNvPr id="14" name="">
             <a:extLst xmlns:a="http://schemas.openxmlformats.org/drawingml/2006/main">
               <a:ext uri="{FF2B5EF4-FFF2-40B4-BE49-F238E27FC236}">
-                <a16:creationId xmlns:a16="http://schemas.microsoft.com/office/drawing/2014/main" id="{ED8DA9CE-F233-487D-8B95-A51EB62E6BFE}"/>
+                <a16:creationId xmlns:a16="http://schemas.microsoft.com/office/drawing/2014/main" id="{AA7DE81C-71FF-432B-ACA6-90049CE64C5D}"/>
               </a:ext>
             </a:extLst>
           </p:cNvPr>
@@ -3167,7 +3167,7 @@
           <p:cNvPr id="15" name="">
             <a:extLst xmlns:a="http://schemas.openxmlformats.org/drawingml/2006/main">
               <a:ext uri="{FF2B5EF4-FFF2-40B4-BE49-F238E27FC236}">
-                <a16:creationId xmlns:a16="http://schemas.microsoft.com/office/drawing/2014/main" id="{D0FAE5C4-08EB-4251-8565-089BCC1D9F89}"/>
+                <a16:creationId xmlns:a16="http://schemas.microsoft.com/office/drawing/2014/main" id="{636D0369-0F71-4AF5-BB61-604C91B648EE}"/>
               </a:ext>
             </a:extLst>
           </p:cNvPr>
@@ -3217,7 +3217,7 @@
           <p:cNvPr id="16" name="">
             <a:extLst xmlns:a="http://schemas.openxmlformats.org/drawingml/2006/main">
               <a:ext uri="{FF2B5EF4-FFF2-40B4-BE49-F238E27FC236}">
-                <a16:creationId xmlns:a16="http://schemas.microsoft.com/office/drawing/2014/main" id="{2F9B83CC-418A-4460-A8A9-29927C58D219}"/>
+                <a16:creationId xmlns:a16="http://schemas.microsoft.com/office/drawing/2014/main" id="{BDC7A477-29B8-4E3B-B9FE-323BD8BE8547}"/>
               </a:ext>
             </a:extLst>
           </p:cNvPr>
@@ -3250,7 +3250,7 @@
           <p:cNvPr id="17" name="">
             <a:extLst xmlns:a="http://schemas.openxmlformats.org/drawingml/2006/main">
               <a:ext uri="{FF2B5EF4-FFF2-40B4-BE49-F238E27FC236}">
-                <a16:creationId xmlns:a16="http://schemas.microsoft.com/office/drawing/2014/main" id="{C76CAAE7-75D4-42EC-929C-ADE8BAE6CDE0}"/>
+                <a16:creationId xmlns:a16="http://schemas.microsoft.com/office/drawing/2014/main" id="{51C64EAA-8A05-47AA-A328-3B9428C705F2}"/>
               </a:ext>
             </a:extLst>
           </p:cNvPr>
@@ -3283,7 +3283,7 @@
           <p:cNvPr id="18" name="">
             <a:extLst xmlns:a="http://schemas.openxmlformats.org/drawingml/2006/main">
               <a:ext uri="{FF2B5EF4-FFF2-40B4-BE49-F238E27FC236}">
-                <a16:creationId xmlns:a16="http://schemas.microsoft.com/office/drawing/2014/main" id="{B3FBA4E2-27EA-4AD0-9B5B-DAC099579371}"/>
+                <a16:creationId xmlns:a16="http://schemas.microsoft.com/office/drawing/2014/main" id="{D5591BC1-4006-4BDB-BA45-2312E84E87A3}"/>
               </a:ext>
             </a:extLst>
           </p:cNvPr>
@@ -3333,7 +3333,7 @@
           <p:cNvPr id="19" name="">
             <a:extLst xmlns:a="http://schemas.openxmlformats.org/drawingml/2006/main">
               <a:ext uri="{FF2B5EF4-FFF2-40B4-BE49-F238E27FC236}">
-                <a16:creationId xmlns:a16="http://schemas.microsoft.com/office/drawing/2014/main" id="{A1E267C0-EDB3-441C-8158-52CAF70341D9}"/>
+                <a16:creationId xmlns:a16="http://schemas.microsoft.com/office/drawing/2014/main" id="{81F99AA2-BD11-4EF4-AFEB-B85E478146A5}"/>
               </a:ext>
             </a:extLst>
           </p:cNvPr>
@@ -3400,7 +3400,7 @@
           <p:cNvPr id="20" name="">
             <a:extLst xmlns:a="http://schemas.openxmlformats.org/drawingml/2006/main">
               <a:ext uri="{FF2B5EF4-FFF2-40B4-BE49-F238E27FC236}">
-                <a16:creationId xmlns:a16="http://schemas.microsoft.com/office/drawing/2014/main" id="{9F26839F-D95A-4696-90D3-2C65AD08C8B4}"/>
+                <a16:creationId xmlns:a16="http://schemas.microsoft.com/office/drawing/2014/main" id="{751B252B-5C8B-4F56-B926-A1FCD66BCB32}"/>
               </a:ext>
             </a:extLst>
           </p:cNvPr>
@@ -3450,7 +3450,7 @@
           <p:cNvPr id="21" name="">
             <a:extLst xmlns:a="http://schemas.openxmlformats.org/drawingml/2006/main">
               <a:ext uri="{FF2B5EF4-FFF2-40B4-BE49-F238E27FC236}">
-                <a16:creationId xmlns:a16="http://schemas.microsoft.com/office/drawing/2014/main" id="{89602306-DAB7-4302-806A-06E3078DC4E2}"/>
+                <a16:creationId xmlns:a16="http://schemas.microsoft.com/office/drawing/2014/main" id="{C6F98682-97C9-4820-BAD7-BB8D7AF12541}"/>
               </a:ext>
             </a:extLst>
           </p:cNvPr>
@@ -3483,7 +3483,7 @@
           <p:cNvPr id="22" name="">
             <a:extLst xmlns:a="http://schemas.openxmlformats.org/drawingml/2006/main">
               <a:ext uri="{FF2B5EF4-FFF2-40B4-BE49-F238E27FC236}">
-                <a16:creationId xmlns:a16="http://schemas.microsoft.com/office/drawing/2014/main" id="{09E4AC95-E628-4E60-BC7C-FED4AA137AC5}"/>
+                <a16:creationId xmlns:a16="http://schemas.microsoft.com/office/drawing/2014/main" id="{0E4370D5-8F1F-4097-8EFF-5509CDF03814}"/>
               </a:ext>
             </a:extLst>
           </p:cNvPr>
@@ -3516,7 +3516,7 @@
           <p:cNvPr id="23" name="">
             <a:extLst xmlns:a="http://schemas.openxmlformats.org/drawingml/2006/main">
               <a:ext uri="{FF2B5EF4-FFF2-40B4-BE49-F238E27FC236}">
-                <a16:creationId xmlns:a16="http://schemas.microsoft.com/office/drawing/2014/main" id="{5EE29B6F-A6EB-4A86-8959-B960F1566D81}"/>
+                <a16:creationId xmlns:a16="http://schemas.microsoft.com/office/drawing/2014/main" id="{643FB7AF-B84C-4EEB-BA12-5CA055F5532F}"/>
               </a:ext>
             </a:extLst>
           </p:cNvPr>
@@ -3566,7 +3566,7 @@
           <p:cNvPr id="24" name="">
             <a:extLst xmlns:a="http://schemas.openxmlformats.org/drawingml/2006/main">
               <a:ext uri="{FF2B5EF4-FFF2-40B4-BE49-F238E27FC236}">
-                <a16:creationId xmlns:a16="http://schemas.microsoft.com/office/drawing/2014/main" id="{D5FB0A9A-1555-46B6-8F86-3BCC993848D0}"/>
+                <a16:creationId xmlns:a16="http://schemas.microsoft.com/office/drawing/2014/main" id="{E6CD4D1A-E4E1-49F3-BC47-490EB147B645}"/>
               </a:ext>
             </a:extLst>
           </p:cNvPr>
@@ -3633,7 +3633,7 @@
           <p:cNvPr id="25" name="">
             <a:extLst xmlns:a="http://schemas.openxmlformats.org/drawingml/2006/main">
               <a:ext uri="{FF2B5EF4-FFF2-40B4-BE49-F238E27FC236}">
-                <a16:creationId xmlns:a16="http://schemas.microsoft.com/office/drawing/2014/main" id="{ABF4716C-66B9-431B-A7A1-E7E4E95A6FDD}"/>
+                <a16:creationId xmlns:a16="http://schemas.microsoft.com/office/drawing/2014/main" id="{C107FC95-1E76-413C-94F9-097F6663569F}"/>
               </a:ext>
             </a:extLst>
           </p:cNvPr>
@@ -3683,7 +3683,7 @@
           <p:cNvPr id="26" name="">
             <a:extLst xmlns:a="http://schemas.openxmlformats.org/drawingml/2006/main">
               <a:ext uri="{FF2B5EF4-FFF2-40B4-BE49-F238E27FC236}">
-                <a16:creationId xmlns:a16="http://schemas.microsoft.com/office/drawing/2014/main" id="{D716C8A4-D3E4-478F-84BB-BD8D382DC692}"/>
+                <a16:creationId xmlns:a16="http://schemas.microsoft.com/office/drawing/2014/main" id="{2D2D9BAC-AADC-4CFB-BE3C-0FB9D8AA2D9B}"/>
               </a:ext>
             </a:extLst>
           </p:cNvPr>
@@ -3716,7 +3716,7 @@
           <p:cNvPr id="27" name="">
             <a:extLst xmlns:a="http://schemas.openxmlformats.org/drawingml/2006/main">
               <a:ext uri="{FF2B5EF4-FFF2-40B4-BE49-F238E27FC236}">
-                <a16:creationId xmlns:a16="http://schemas.microsoft.com/office/drawing/2014/main" id="{379758A3-640A-4928-9D89-5AC658D0D11E}"/>
+                <a16:creationId xmlns:a16="http://schemas.microsoft.com/office/drawing/2014/main" id="{7A93BB2C-433F-4BDD-88F6-DDCB792275D1}"/>
               </a:ext>
             </a:extLst>
           </p:cNvPr>
@@ -3749,7 +3749,7 @@
           <p:cNvPr id="28" name="">
             <a:extLst xmlns:a="http://schemas.openxmlformats.org/drawingml/2006/main">
               <a:ext uri="{FF2B5EF4-FFF2-40B4-BE49-F238E27FC236}">
-                <a16:creationId xmlns:a16="http://schemas.microsoft.com/office/drawing/2014/main" id="{3783677E-4F2A-49A2-B0E6-6BBE375AC98F}"/>
+                <a16:creationId xmlns:a16="http://schemas.microsoft.com/office/drawing/2014/main" id="{B30F4A83-0320-4C5C-9D8D-1290AB8E98CB}"/>
               </a:ext>
             </a:extLst>
           </p:cNvPr>
@@ -3799,7 +3799,7 @@
           <p:cNvPr id="29" name="">
             <a:extLst xmlns:a="http://schemas.openxmlformats.org/drawingml/2006/main">
               <a:ext uri="{FF2B5EF4-FFF2-40B4-BE49-F238E27FC236}">
-                <a16:creationId xmlns:a16="http://schemas.microsoft.com/office/drawing/2014/main" id="{5691DF68-09E3-4981-882A-21F9FA47AA4A}"/>
+                <a16:creationId xmlns:a16="http://schemas.microsoft.com/office/drawing/2014/main" id="{D673D110-0ACE-4F11-9F77-16FA27559C94}"/>
               </a:ext>
             </a:extLst>
           </p:cNvPr>
@@ -3866,7 +3866,7 @@
           <p:cNvPr id="30" name="">
             <a:extLst xmlns:a="http://schemas.openxmlformats.org/drawingml/2006/main">
               <a:ext uri="{FF2B5EF4-FFF2-40B4-BE49-F238E27FC236}">
-                <a16:creationId xmlns:a16="http://schemas.microsoft.com/office/drawing/2014/main" id="{B6CD3CE2-9335-4787-A39E-1F74D5DAFB5D}"/>
+                <a16:creationId xmlns:a16="http://schemas.microsoft.com/office/drawing/2014/main" id="{5DD714B2-431C-4E8D-B2B9-FAF8B8DB9C8F}"/>
               </a:ext>
             </a:extLst>
           </p:cNvPr>
@@ -3916,7 +3916,7 @@
           <p:cNvPr id="31" name="">
             <a:extLst xmlns:a="http://schemas.openxmlformats.org/drawingml/2006/main">
               <a:ext uri="{FF2B5EF4-FFF2-40B4-BE49-F238E27FC236}">
-                <a16:creationId xmlns:a16="http://schemas.microsoft.com/office/drawing/2014/main" id="{A657382A-54A0-49D3-A811-E7F58E8D4842}"/>
+                <a16:creationId xmlns:a16="http://schemas.microsoft.com/office/drawing/2014/main" id="{ADC35C89-3F88-4047-B855-11F7FBF8ECAF}"/>
               </a:ext>
             </a:extLst>
           </p:cNvPr>
@@ -3949,7 +3949,7 @@
           <p:cNvPr id="32" name="">
             <a:extLst xmlns:a="http://schemas.openxmlformats.org/drawingml/2006/main">
               <a:ext uri="{FF2B5EF4-FFF2-40B4-BE49-F238E27FC236}">
-                <a16:creationId xmlns:a16="http://schemas.microsoft.com/office/drawing/2014/main" id="{C6776B72-255C-476E-A906-3C68D233160E}"/>
+                <a16:creationId xmlns:a16="http://schemas.microsoft.com/office/drawing/2014/main" id="{9D9BC3AA-2CAE-45EC-8F93-FCAA7896FB41}"/>
               </a:ext>
             </a:extLst>
           </p:cNvPr>
@@ -3982,7 +3982,7 @@
           <p:cNvPr id="33" name="">
             <a:extLst xmlns:a="http://schemas.openxmlformats.org/drawingml/2006/main">
               <a:ext uri="{FF2B5EF4-FFF2-40B4-BE49-F238E27FC236}">
-                <a16:creationId xmlns:a16="http://schemas.microsoft.com/office/drawing/2014/main" id="{CA58FD3E-1A2F-4536-BDAD-09D661C220A7}"/>
+                <a16:creationId xmlns:a16="http://schemas.microsoft.com/office/drawing/2014/main" id="{3DB6E474-EAE4-436C-8575-BD67682365C6}"/>
               </a:ext>
             </a:extLst>
           </p:cNvPr>
@@ -4032,7 +4032,7 @@
           <p:cNvPr id="34" name="">
             <a:extLst xmlns:a="http://schemas.openxmlformats.org/drawingml/2006/main">
               <a:ext uri="{FF2B5EF4-FFF2-40B4-BE49-F238E27FC236}">
-                <a16:creationId xmlns:a16="http://schemas.microsoft.com/office/drawing/2014/main" id="{92300EF4-8B3E-4738-8210-4F97D033E844}"/>
+                <a16:creationId xmlns:a16="http://schemas.microsoft.com/office/drawing/2014/main" id="{47B14569-1A81-4F9E-9A7B-7A3418DBAB20}"/>
               </a:ext>
             </a:extLst>
           </p:cNvPr>
@@ -4099,7 +4099,7 @@
           <p:cNvPr id="35" name="">
             <a:extLst xmlns:a="http://schemas.openxmlformats.org/drawingml/2006/main">
               <a:ext uri="{FF2B5EF4-FFF2-40B4-BE49-F238E27FC236}">
-                <a16:creationId xmlns:a16="http://schemas.microsoft.com/office/drawing/2014/main" id="{35919345-69C9-4E76-B552-E8EAD657401B}"/>
+                <a16:creationId xmlns:a16="http://schemas.microsoft.com/office/drawing/2014/main" id="{BCDC9DBC-34A0-4411-97C3-90E5B92C6D96}"/>
               </a:ext>
             </a:extLst>
           </p:cNvPr>
@@ -4132,7 +4132,7 @@
           <p:cNvPr id="36" name="">
             <a:extLst xmlns:a="http://schemas.openxmlformats.org/drawingml/2006/main">
               <a:ext uri="{FF2B5EF4-FFF2-40B4-BE49-F238E27FC236}">
-                <a16:creationId xmlns:a16="http://schemas.microsoft.com/office/drawing/2014/main" id="{81634079-BE1C-4E95-B563-C042A7B133A1}"/>
+                <a16:creationId xmlns:a16="http://schemas.microsoft.com/office/drawing/2014/main" id="{A61FDDFB-C9BA-4B40-9502-94AD1E05109E}"/>
               </a:ext>
             </a:extLst>
           </p:cNvPr>
@@ -4165,7 +4165,7 @@
           <p:cNvPr id="37" name="">
             <a:extLst xmlns:a="http://schemas.openxmlformats.org/drawingml/2006/main">
               <a:ext uri="{FF2B5EF4-FFF2-40B4-BE49-F238E27FC236}">
-                <a16:creationId xmlns:a16="http://schemas.microsoft.com/office/drawing/2014/main" id="{2E9121FF-454C-4037-997F-F2250076B481}"/>
+                <a16:creationId xmlns:a16="http://schemas.microsoft.com/office/drawing/2014/main" id="{6AA7BC28-4535-40C2-9FD6-2522EDF0F6F4}"/>
               </a:ext>
             </a:extLst>
           </p:cNvPr>
@@ -4215,7 +4215,7 @@
           <p:cNvPr id="38" name="">
             <a:extLst xmlns:a="http://schemas.openxmlformats.org/drawingml/2006/main">
               <a:ext uri="{FF2B5EF4-FFF2-40B4-BE49-F238E27FC236}">
-                <a16:creationId xmlns:a16="http://schemas.microsoft.com/office/drawing/2014/main" id="{2FBC664A-39CA-4C97-AAE3-CE9B2D0FDA60}"/>
+                <a16:creationId xmlns:a16="http://schemas.microsoft.com/office/drawing/2014/main" id="{1996F082-BF4F-4D8D-A7D0-B489E11247A7}"/>
               </a:ext>
             </a:extLst>
           </p:cNvPr>
@@ -4265,7 +4265,7 @@
           <p:cNvPr id="39" name="">
             <a:extLst xmlns:a="http://schemas.openxmlformats.org/drawingml/2006/main">
               <a:ext uri="{FF2B5EF4-FFF2-40B4-BE49-F238E27FC236}">
-                <a16:creationId xmlns:a16="http://schemas.microsoft.com/office/drawing/2014/main" id="{AB30B83D-B7CC-426F-B874-60444426CA64}"/>
+                <a16:creationId xmlns:a16="http://schemas.microsoft.com/office/drawing/2014/main" id="{EEDC8DC8-87C3-4309-AC10-0ED1FCC9283B}"/>
               </a:ext>
             </a:extLst>
           </p:cNvPr>
@@ -4298,7 +4298,7 @@
           <p:cNvPr id="40" name="">
             <a:extLst xmlns:a="http://schemas.openxmlformats.org/drawingml/2006/main">
               <a:ext uri="{FF2B5EF4-FFF2-40B4-BE49-F238E27FC236}">
-                <a16:creationId xmlns:a16="http://schemas.microsoft.com/office/drawing/2014/main" id="{DD4A13F0-43A1-4387-8DEB-4128F9A5AD86}"/>
+                <a16:creationId xmlns:a16="http://schemas.microsoft.com/office/drawing/2014/main" id="{924C7038-5528-4C36-AE1D-9BAD9CF3242B}"/>
               </a:ext>
             </a:extLst>
           </p:cNvPr>
@@ -4331,7 +4331,7 @@
           <p:cNvPr id="41" name="">
             <a:extLst xmlns:a="http://schemas.openxmlformats.org/drawingml/2006/main">
               <a:ext uri="{FF2B5EF4-FFF2-40B4-BE49-F238E27FC236}">
-                <a16:creationId xmlns:a16="http://schemas.microsoft.com/office/drawing/2014/main" id="{3B2C1B1C-81D8-452B-8889-F79FC70E7D0F}"/>
+                <a16:creationId xmlns:a16="http://schemas.microsoft.com/office/drawing/2014/main" id="{F225BCF5-10A6-4B02-B8CA-393A7C38466F}"/>
               </a:ext>
             </a:extLst>
           </p:cNvPr>
@@ -4381,7 +4381,7 @@
           <p:cNvPr id="42" name="">
             <a:extLst xmlns:a="http://schemas.openxmlformats.org/drawingml/2006/main">
               <a:ext uri="{FF2B5EF4-FFF2-40B4-BE49-F238E27FC236}">
-                <a16:creationId xmlns:a16="http://schemas.microsoft.com/office/drawing/2014/main" id="{7AA15FD1-4C8E-4D76-9DE0-4199071617A0}"/>
+                <a16:creationId xmlns:a16="http://schemas.microsoft.com/office/drawing/2014/main" id="{8FD348C3-4121-4B8F-8B6F-BD4F3DBB0E09}"/>
               </a:ext>
             </a:extLst>
           </p:cNvPr>
@@ -4431,7 +4431,7 @@
           <p:cNvPr id="43" name="">
             <a:extLst xmlns:a="http://schemas.openxmlformats.org/drawingml/2006/main">
               <a:ext uri="{FF2B5EF4-FFF2-40B4-BE49-F238E27FC236}">
-                <a16:creationId xmlns:a16="http://schemas.microsoft.com/office/drawing/2014/main" id="{E2201316-CA24-4886-8A5F-286D6B51F9F7}"/>
+                <a16:creationId xmlns:a16="http://schemas.microsoft.com/office/drawing/2014/main" id="{F29B63E6-4943-46F7-861B-DA727A050DA1}"/>
               </a:ext>
             </a:extLst>
           </p:cNvPr>
@@ -4464,7 +4464,7 @@
           <p:cNvPr id="44" name="">
             <a:extLst xmlns:a="http://schemas.openxmlformats.org/drawingml/2006/main">
               <a:ext uri="{FF2B5EF4-FFF2-40B4-BE49-F238E27FC236}">
-                <a16:creationId xmlns:a16="http://schemas.microsoft.com/office/drawing/2014/main" id="{36ADFE26-51C0-4F86-A25B-C3FFB0D4565B}"/>
+                <a16:creationId xmlns:a16="http://schemas.microsoft.com/office/drawing/2014/main" id="{D6A5D198-D5EF-4281-9782-E10EC9117458}"/>
               </a:ext>
             </a:extLst>
           </p:cNvPr>
@@ -4497,7 +4497,7 @@
           <p:cNvPr id="45" name="">
             <a:extLst xmlns:a="http://schemas.openxmlformats.org/drawingml/2006/main">
               <a:ext uri="{FF2B5EF4-FFF2-40B4-BE49-F238E27FC236}">
-                <a16:creationId xmlns:a16="http://schemas.microsoft.com/office/drawing/2014/main" id="{59728A62-449B-44C0-89AE-108EEBBDF626}"/>
+                <a16:creationId xmlns:a16="http://schemas.microsoft.com/office/drawing/2014/main" id="{0BDBEE51-320C-4ACF-AF8C-40459F2F99A8}"/>
               </a:ext>
             </a:extLst>
           </p:cNvPr>
@@ -4547,7 +4547,7 @@
           <p:cNvPr id="46" name="">
             <a:extLst xmlns:a="http://schemas.openxmlformats.org/drawingml/2006/main">
               <a:ext uri="{FF2B5EF4-FFF2-40B4-BE49-F238E27FC236}">
-                <a16:creationId xmlns:a16="http://schemas.microsoft.com/office/drawing/2014/main" id="{22DD989E-DD20-419C-A633-B6599D18E809}"/>
+                <a16:creationId xmlns:a16="http://schemas.microsoft.com/office/drawing/2014/main" id="{B828944B-B558-41FD-93BB-B868E5972B6B}"/>
               </a:ext>
             </a:extLst>
           </p:cNvPr>
@@ -4595,7 +4595,7 @@
     </p:spTree>
     <p:extLst>
       <p:ext uri="{BB962C8B-B14F-4D97-AF65-F5344CB8AC3E}">
-        <p14:creationId xmlns:p14="http://schemas.microsoft.com/office/powerpoint/2010/main" val="1259503310"/>
+        <p14:creationId xmlns:p14="http://schemas.microsoft.com/office/powerpoint/2010/main" val="454279628"/>
       </p:ext>
     </p:extLst>
   </p:cSld>
@@ -4626,7 +4626,7 @@
           <p:cNvPr id="35" name="">
             <a:extLst xmlns:a="http://schemas.openxmlformats.org/drawingml/2006/main">
               <a:ext uri="{FF2B5EF4-FFF2-40B4-BE49-F238E27FC236}">
-                <a16:creationId xmlns:a16="http://schemas.microsoft.com/office/drawing/2014/main" id="{74018513-BE8F-4ECA-82AE-50C0BBB28F1D}"/>
+                <a16:creationId xmlns:a16="http://schemas.microsoft.com/office/drawing/2014/main" id="{367A1319-EC93-4A68-84EB-5E5FDF9F8DE1}"/>
               </a:ext>
             </a:extLst>
           </p:cNvPr>
@@ -4676,7 +4676,7 @@
           <p:cNvPr id="2" name="">
             <a:extLst xmlns:a="http://schemas.openxmlformats.org/drawingml/2006/main">
               <a:ext uri="{FF2B5EF4-FFF2-40B4-BE49-F238E27FC236}">
-                <a16:creationId xmlns:a16="http://schemas.microsoft.com/office/drawing/2014/main" id="{937262FA-3E92-4A43-B897-E2A34133FDE9}"/>
+                <a16:creationId xmlns:a16="http://schemas.microsoft.com/office/drawing/2014/main" id="{7601F91F-6827-4758-9241-38379A2FFC1D}"/>
               </a:ext>
             </a:extLst>
           </p:cNvPr>
@@ -4726,7 +4726,7 @@
           <p:cNvPr id="3" name="">
             <a:extLst xmlns:a="http://schemas.openxmlformats.org/drawingml/2006/main">
               <a:ext uri="{FF2B5EF4-FFF2-40B4-BE49-F238E27FC236}">
-                <a16:creationId xmlns:a16="http://schemas.microsoft.com/office/drawing/2014/main" id="{5DBE621E-4075-45A3-9C06-2F26811ED12E}"/>
+                <a16:creationId xmlns:a16="http://schemas.microsoft.com/office/drawing/2014/main" id="{76A4D316-BA50-4666-8407-442DCA0E15AD}"/>
               </a:ext>
             </a:extLst>
           </p:cNvPr>
@@ -4776,7 +4776,7 @@
           <p:cNvPr id="4" name="">
             <a:extLst xmlns:a="http://schemas.openxmlformats.org/drawingml/2006/main">
               <a:ext uri="{FF2B5EF4-FFF2-40B4-BE49-F238E27FC236}">
-                <a16:creationId xmlns:a16="http://schemas.microsoft.com/office/drawing/2014/main" id="{661D8805-3E5B-4230-B836-429C76C6DEA2}"/>
+                <a16:creationId xmlns:a16="http://schemas.microsoft.com/office/drawing/2014/main" id="{A8A2F703-E107-43A2-A6E7-F591705AEC19}"/>
               </a:ext>
             </a:extLst>
           </p:cNvPr>
@@ -4826,7 +4826,7 @@
           <p:cNvPr id="5" name="">
             <a:extLst xmlns:a="http://schemas.openxmlformats.org/drawingml/2006/main">
               <a:ext uri="{FF2B5EF4-FFF2-40B4-BE49-F238E27FC236}">
-                <a16:creationId xmlns:a16="http://schemas.microsoft.com/office/drawing/2014/main" id="{2904EEF5-323F-45F0-B46E-84D588CF557D}"/>
+                <a16:creationId xmlns:a16="http://schemas.microsoft.com/office/drawing/2014/main" id="{5BFACA57-FC0A-42DA-A8BF-7F8617F7D9DA}"/>
               </a:ext>
             </a:extLst>
           </p:cNvPr>
@@ -4876,7 +4876,7 @@
           <p:cNvPr id="6" name="">
             <a:extLst xmlns:a="http://schemas.openxmlformats.org/drawingml/2006/main">
               <a:ext uri="{FF2B5EF4-FFF2-40B4-BE49-F238E27FC236}">
-                <a16:creationId xmlns:a16="http://schemas.microsoft.com/office/drawing/2014/main" id="{27C1F3DE-DBD9-4EC3-80A7-F6E7872D9797}"/>
+                <a16:creationId xmlns:a16="http://schemas.microsoft.com/office/drawing/2014/main" id="{FDBED0D2-D3C0-4A05-82B5-84DA9C48DE93}"/>
               </a:ext>
             </a:extLst>
           </p:cNvPr>
@@ -4909,7 +4909,7 @@
           <p:cNvPr id="7" name="">
             <a:extLst xmlns:a="http://schemas.openxmlformats.org/drawingml/2006/main">
               <a:ext uri="{FF2B5EF4-FFF2-40B4-BE49-F238E27FC236}">
-                <a16:creationId xmlns:a16="http://schemas.microsoft.com/office/drawing/2014/main" id="{2E4F216D-3586-42D5-88CF-A1CE6D859176}"/>
+                <a16:creationId xmlns:a16="http://schemas.microsoft.com/office/drawing/2014/main" id="{6C0F91CC-8375-48E8-85E3-042480BA69C1}"/>
               </a:ext>
             </a:extLst>
           </p:cNvPr>
@@ -4959,7 +4959,7 @@
           <p:cNvPr id="8" name="">
             <a:extLst xmlns:a="http://schemas.openxmlformats.org/drawingml/2006/main">
               <a:ext uri="{FF2B5EF4-FFF2-40B4-BE49-F238E27FC236}">
-                <a16:creationId xmlns:a16="http://schemas.microsoft.com/office/drawing/2014/main" id="{496BB74A-6DD9-42F6-B78C-326B1A7CEEB8}"/>
+                <a16:creationId xmlns:a16="http://schemas.microsoft.com/office/drawing/2014/main" id="{E67CA373-D080-4158-8029-1C163B794608}"/>
               </a:ext>
             </a:extLst>
           </p:cNvPr>
@@ -5009,7 +5009,7 @@
           <p:cNvPr id="9" name="">
             <a:extLst xmlns:a="http://schemas.openxmlformats.org/drawingml/2006/main">
               <a:ext uri="{FF2B5EF4-FFF2-40B4-BE49-F238E27FC236}">
-                <a16:creationId xmlns:a16="http://schemas.microsoft.com/office/drawing/2014/main" id="{69883CD9-352B-4001-98EA-D9212AF14C51}"/>
+                <a16:creationId xmlns:a16="http://schemas.microsoft.com/office/drawing/2014/main" id="{7659C1CD-1BD0-4DAC-A801-F2814D9F9E82}"/>
               </a:ext>
             </a:extLst>
           </p:cNvPr>
@@ -5059,7 +5059,7 @@
           <p:cNvPr id="10" name="">
             <a:extLst xmlns:a="http://schemas.openxmlformats.org/drawingml/2006/main">
               <a:ext uri="{FF2B5EF4-FFF2-40B4-BE49-F238E27FC236}">
-                <a16:creationId xmlns:a16="http://schemas.microsoft.com/office/drawing/2014/main" id="{8F3D1594-57F1-462F-BFF0-D2BF635CC246}"/>
+                <a16:creationId xmlns:a16="http://schemas.microsoft.com/office/drawing/2014/main" id="{EFEE51B0-75C4-4190-9AAD-FD0EDB539E99}"/>
               </a:ext>
             </a:extLst>
           </p:cNvPr>
@@ -5092,7 +5092,7 @@
           <p:cNvPr id="11" name="">
             <a:extLst xmlns:a="http://schemas.openxmlformats.org/drawingml/2006/main">
               <a:ext uri="{FF2B5EF4-FFF2-40B4-BE49-F238E27FC236}">
-                <a16:creationId xmlns:a16="http://schemas.microsoft.com/office/drawing/2014/main" id="{BDA1660A-FE8A-4930-B040-B953BB70D2F9}"/>
+                <a16:creationId xmlns:a16="http://schemas.microsoft.com/office/drawing/2014/main" id="{D9032EFC-9866-455A-B7AB-26181115DD65}"/>
               </a:ext>
             </a:extLst>
           </p:cNvPr>
@@ -5142,7 +5142,7 @@
           <p:cNvPr id="12" name="">
             <a:extLst xmlns:a="http://schemas.openxmlformats.org/drawingml/2006/main">
               <a:ext uri="{FF2B5EF4-FFF2-40B4-BE49-F238E27FC236}">
-                <a16:creationId xmlns:a16="http://schemas.microsoft.com/office/drawing/2014/main" id="{92CDFAAC-5CF1-42CF-80E1-3CCE73FC56C2}"/>
+                <a16:creationId xmlns:a16="http://schemas.microsoft.com/office/drawing/2014/main" id="{D0120448-3223-4338-A7CA-969E47D94F34}"/>
               </a:ext>
             </a:extLst>
           </p:cNvPr>
@@ -5192,7 +5192,7 @@
           <p:cNvPr id="13" name="">
             <a:extLst xmlns:a="http://schemas.openxmlformats.org/drawingml/2006/main">
               <a:ext uri="{FF2B5EF4-FFF2-40B4-BE49-F238E27FC236}">
-                <a16:creationId xmlns:a16="http://schemas.microsoft.com/office/drawing/2014/main" id="{C74BC946-FFA8-4F4F-B7BB-69F77B2D0835}"/>
+                <a16:creationId xmlns:a16="http://schemas.microsoft.com/office/drawing/2014/main" id="{8D308868-1A26-4784-9D66-C8B52F4E3CEC}"/>
               </a:ext>
             </a:extLst>
           </p:cNvPr>
@@ -5242,7 +5242,7 @@
           <p:cNvPr id="14" name="">
             <a:extLst xmlns:a="http://schemas.openxmlformats.org/drawingml/2006/main">
               <a:ext uri="{FF2B5EF4-FFF2-40B4-BE49-F238E27FC236}">
-                <a16:creationId xmlns:a16="http://schemas.microsoft.com/office/drawing/2014/main" id="{46FDE214-BC15-45EA-A1D3-3F90A1AB6842}"/>
+                <a16:creationId xmlns:a16="http://schemas.microsoft.com/office/drawing/2014/main" id="{9C33F301-1100-4996-8B39-1D6E3962CE25}"/>
               </a:ext>
             </a:extLst>
           </p:cNvPr>
@@ -5275,7 +5275,7 @@
           <p:cNvPr id="15" name="">
             <a:extLst xmlns:a="http://schemas.openxmlformats.org/drawingml/2006/main">
               <a:ext uri="{FF2B5EF4-FFF2-40B4-BE49-F238E27FC236}">
-                <a16:creationId xmlns:a16="http://schemas.microsoft.com/office/drawing/2014/main" id="{217F0740-ED34-4F1F-9447-60A35BD278B0}"/>
+                <a16:creationId xmlns:a16="http://schemas.microsoft.com/office/drawing/2014/main" id="{C34E658E-F786-444C-9AE3-4C35446C0560}"/>
               </a:ext>
             </a:extLst>
           </p:cNvPr>
@@ -5325,7 +5325,7 @@
           <p:cNvPr id="16" name="">
             <a:extLst xmlns:a="http://schemas.openxmlformats.org/drawingml/2006/main">
               <a:ext uri="{FF2B5EF4-FFF2-40B4-BE49-F238E27FC236}">
-                <a16:creationId xmlns:a16="http://schemas.microsoft.com/office/drawing/2014/main" id="{E5C44EA5-F738-45ED-8375-2BD84137A779}"/>
+                <a16:creationId xmlns:a16="http://schemas.microsoft.com/office/drawing/2014/main" id="{C2CE0A56-F94E-4E86-A5AB-D89686101427}"/>
               </a:ext>
             </a:extLst>
           </p:cNvPr>
@@ -5375,7 +5375,7 @@
           <p:cNvPr id="17" name="">
             <a:extLst xmlns:a="http://schemas.openxmlformats.org/drawingml/2006/main">
               <a:ext uri="{FF2B5EF4-FFF2-40B4-BE49-F238E27FC236}">
-                <a16:creationId xmlns:a16="http://schemas.microsoft.com/office/drawing/2014/main" id="{2781E186-AB1B-486E-BA42-03338C3CF32F}"/>
+                <a16:creationId xmlns:a16="http://schemas.microsoft.com/office/drawing/2014/main" id="{0919289D-E338-42D4-AC1A-0E863D307CA9}"/>
               </a:ext>
             </a:extLst>
           </p:cNvPr>
@@ -5425,7 +5425,7 @@
           <p:cNvPr id="18" name="">
             <a:extLst xmlns:a="http://schemas.openxmlformats.org/drawingml/2006/main">
               <a:ext uri="{FF2B5EF4-FFF2-40B4-BE49-F238E27FC236}">
-                <a16:creationId xmlns:a16="http://schemas.microsoft.com/office/drawing/2014/main" id="{EA305487-5282-48CA-96CD-A5B378AE514F}"/>
+                <a16:creationId xmlns:a16="http://schemas.microsoft.com/office/drawing/2014/main" id="{C196C114-5DEC-4B22-9F14-10AF3B0DB98D}"/>
               </a:ext>
             </a:extLst>
           </p:cNvPr>
@@ -5458,7 +5458,7 @@
           <p:cNvPr id="19" name="">
             <a:extLst xmlns:a="http://schemas.openxmlformats.org/drawingml/2006/main">
               <a:ext uri="{FF2B5EF4-FFF2-40B4-BE49-F238E27FC236}">
-                <a16:creationId xmlns:a16="http://schemas.microsoft.com/office/drawing/2014/main" id="{6E51B4CC-4E9B-4C04-9910-65355174A4D5}"/>
+                <a16:creationId xmlns:a16="http://schemas.microsoft.com/office/drawing/2014/main" id="{0B67B6F2-460E-4FEE-9E60-EF4E24B710F0}"/>
               </a:ext>
             </a:extLst>
           </p:cNvPr>
@@ -5508,7 +5508,7 @@
           <p:cNvPr id="20" name="">
             <a:extLst xmlns:a="http://schemas.openxmlformats.org/drawingml/2006/main">
               <a:ext uri="{FF2B5EF4-FFF2-40B4-BE49-F238E27FC236}">
-                <a16:creationId xmlns:a16="http://schemas.microsoft.com/office/drawing/2014/main" id="{557D4C37-22AC-4B4B-97E3-DFF42FBA7A61}"/>
+                <a16:creationId xmlns:a16="http://schemas.microsoft.com/office/drawing/2014/main" id="{9461D0B3-E779-47C8-BDF8-822CCC01EAF1}"/>
               </a:ext>
             </a:extLst>
           </p:cNvPr>
@@ -5558,7 +5558,7 @@
           <p:cNvPr id="21" name="">
             <a:extLst xmlns:a="http://schemas.openxmlformats.org/drawingml/2006/main">
               <a:ext uri="{FF2B5EF4-FFF2-40B4-BE49-F238E27FC236}">
-                <a16:creationId xmlns:a16="http://schemas.microsoft.com/office/drawing/2014/main" id="{C8DA8B51-7656-4158-A4EF-0FD9AF6F83F1}"/>
+                <a16:creationId xmlns:a16="http://schemas.microsoft.com/office/drawing/2014/main" id="{54AD9C94-13E6-4A1B-9F29-464B466857A0}"/>
               </a:ext>
             </a:extLst>
           </p:cNvPr>
@@ -5608,7 +5608,7 @@
           <p:cNvPr id="22" name="">
             <a:extLst xmlns:a="http://schemas.openxmlformats.org/drawingml/2006/main">
               <a:ext uri="{FF2B5EF4-FFF2-40B4-BE49-F238E27FC236}">
-                <a16:creationId xmlns:a16="http://schemas.microsoft.com/office/drawing/2014/main" id="{D0092EEF-9A2B-47E4-8126-7ACF36FA6E88}"/>
+                <a16:creationId xmlns:a16="http://schemas.microsoft.com/office/drawing/2014/main" id="{56A10C5C-DC74-4E77-8343-C3A5C1DE8064}"/>
               </a:ext>
             </a:extLst>
           </p:cNvPr>
@@ -5641,7 +5641,7 @@
           <p:cNvPr id="23" name="">
             <a:extLst xmlns:a="http://schemas.openxmlformats.org/drawingml/2006/main">
               <a:ext uri="{FF2B5EF4-FFF2-40B4-BE49-F238E27FC236}">
-                <a16:creationId xmlns:a16="http://schemas.microsoft.com/office/drawing/2014/main" id="{F6C31529-9811-4E39-938D-939A858D0532}"/>
+                <a16:creationId xmlns:a16="http://schemas.microsoft.com/office/drawing/2014/main" id="{8A207523-F5D1-4820-81DD-90924D19C3DC}"/>
               </a:ext>
             </a:extLst>
           </p:cNvPr>
@@ -5691,7 +5691,7 @@
           <p:cNvPr id="24" name="">
             <a:extLst xmlns:a="http://schemas.openxmlformats.org/drawingml/2006/main">
               <a:ext uri="{FF2B5EF4-FFF2-40B4-BE49-F238E27FC236}">
-                <a16:creationId xmlns:a16="http://schemas.microsoft.com/office/drawing/2014/main" id="{4AC3F1A6-0D19-46D9-9744-97DEF9EE5D02}"/>
+                <a16:creationId xmlns:a16="http://schemas.microsoft.com/office/drawing/2014/main" id="{39CF0693-27B2-47C8-A166-0D20FC2F8E3D}"/>
               </a:ext>
             </a:extLst>
           </p:cNvPr>
@@ -5741,7 +5741,7 @@
           <p:cNvPr id="25" name="">
             <a:extLst xmlns:a="http://schemas.openxmlformats.org/drawingml/2006/main">
               <a:ext uri="{FF2B5EF4-FFF2-40B4-BE49-F238E27FC236}">
-                <a16:creationId xmlns:a16="http://schemas.microsoft.com/office/drawing/2014/main" id="{527D7C5B-AE01-4EE9-A8D0-3345B442CCAA}"/>
+                <a16:creationId xmlns:a16="http://schemas.microsoft.com/office/drawing/2014/main" id="{BC62CCF7-30F3-40B8-AB67-BA530C83F50C}"/>
               </a:ext>
             </a:extLst>
           </p:cNvPr>
@@ -5791,7 +5791,7 @@
           <p:cNvPr id="26" name="">
             <a:extLst xmlns:a="http://schemas.openxmlformats.org/drawingml/2006/main">
               <a:ext uri="{FF2B5EF4-FFF2-40B4-BE49-F238E27FC236}">
-                <a16:creationId xmlns:a16="http://schemas.microsoft.com/office/drawing/2014/main" id="{5D61FEA5-54FC-46E2-8454-22431962BC6E}"/>
+                <a16:creationId xmlns:a16="http://schemas.microsoft.com/office/drawing/2014/main" id="{9FFE2E73-8661-43DC-8F34-46FF10B675D6}"/>
               </a:ext>
             </a:extLst>
           </p:cNvPr>
@@ -5824,7 +5824,7 @@
           <p:cNvPr id="27" name="">
             <a:extLst xmlns:a="http://schemas.openxmlformats.org/drawingml/2006/main">
               <a:ext uri="{FF2B5EF4-FFF2-40B4-BE49-F238E27FC236}">
-                <a16:creationId xmlns:a16="http://schemas.microsoft.com/office/drawing/2014/main" id="{713FBB94-956E-4E90-B203-06F1EF05AA5F}"/>
+                <a16:creationId xmlns:a16="http://schemas.microsoft.com/office/drawing/2014/main" id="{7D4C8265-D1FD-4128-9782-D8FF8BD8CE33}"/>
               </a:ext>
             </a:extLst>
           </p:cNvPr>
@@ -5874,7 +5874,7 @@
           <p:cNvPr id="28" name="">
             <a:extLst xmlns:a="http://schemas.openxmlformats.org/drawingml/2006/main">
               <a:ext uri="{FF2B5EF4-FFF2-40B4-BE49-F238E27FC236}">
-                <a16:creationId xmlns:a16="http://schemas.microsoft.com/office/drawing/2014/main" id="{47B07EA0-A5B9-4532-873F-A869BC94624E}"/>
+                <a16:creationId xmlns:a16="http://schemas.microsoft.com/office/drawing/2014/main" id="{330C834A-25A0-4100-8443-E3220C88B1E3}"/>
               </a:ext>
             </a:extLst>
           </p:cNvPr>
@@ -5924,7 +5924,7 @@
           <p:cNvPr id="29" name="">
             <a:extLst xmlns:a="http://schemas.openxmlformats.org/drawingml/2006/main">
               <a:ext uri="{FF2B5EF4-FFF2-40B4-BE49-F238E27FC236}">
-                <a16:creationId xmlns:a16="http://schemas.microsoft.com/office/drawing/2014/main" id="{8C16B2F6-4D1D-4B42-9348-083F9576C9B6}"/>
+                <a16:creationId xmlns:a16="http://schemas.microsoft.com/office/drawing/2014/main" id="{13E3E121-D868-43DF-ACD3-587BBF8CA694}"/>
               </a:ext>
             </a:extLst>
           </p:cNvPr>
@@ -5974,7 +5974,7 @@
           <p:cNvPr id="30" name="">
             <a:extLst xmlns:a="http://schemas.openxmlformats.org/drawingml/2006/main">
               <a:ext uri="{FF2B5EF4-FFF2-40B4-BE49-F238E27FC236}">
-                <a16:creationId xmlns:a16="http://schemas.microsoft.com/office/drawing/2014/main" id="{70D9959F-EB4A-4B85-B7E7-4B3F98622B79}"/>
+                <a16:creationId xmlns:a16="http://schemas.microsoft.com/office/drawing/2014/main" id="{BCEFA513-BD5F-45B8-A9AC-3F0A7013348C}"/>
               </a:ext>
             </a:extLst>
           </p:cNvPr>
@@ -6007,7 +6007,7 @@
           <p:cNvPr id="31" name="">
             <a:extLst xmlns:a="http://schemas.openxmlformats.org/drawingml/2006/main">
               <a:ext uri="{FF2B5EF4-FFF2-40B4-BE49-F238E27FC236}">
-                <a16:creationId xmlns:a16="http://schemas.microsoft.com/office/drawing/2014/main" id="{BA7A985C-06B9-40CE-86AD-AB7062DB4B2C}"/>
+                <a16:creationId xmlns:a16="http://schemas.microsoft.com/office/drawing/2014/main" id="{932F1543-65FF-4DBA-BA5A-670B73AE1835}"/>
               </a:ext>
             </a:extLst>
           </p:cNvPr>
@@ -6074,7 +6074,7 @@
           <p:cNvPr id="32" name="">
             <a:extLst xmlns:a="http://schemas.openxmlformats.org/drawingml/2006/main">
               <a:ext uri="{FF2B5EF4-FFF2-40B4-BE49-F238E27FC236}">
-                <a16:creationId xmlns:a16="http://schemas.microsoft.com/office/drawing/2014/main" id="{2A966775-671E-4A5B-B187-42F9B49DB6C9}"/>
+                <a16:creationId xmlns:a16="http://schemas.microsoft.com/office/drawing/2014/main" id="{11E98E4B-DF81-4447-ADD2-A8F47EF0727E}"/>
               </a:ext>
             </a:extLst>
           </p:cNvPr>
@@ -6141,7 +6141,7 @@
           <p:cNvPr id="33" name="">
             <a:extLst xmlns:a="http://schemas.openxmlformats.org/drawingml/2006/main">
               <a:ext uri="{FF2B5EF4-FFF2-40B4-BE49-F238E27FC236}">
-                <a16:creationId xmlns:a16="http://schemas.microsoft.com/office/drawing/2014/main" id="{ACB4754F-B00A-46CC-8794-FD7B2EEBD1FC}"/>
+                <a16:creationId xmlns:a16="http://schemas.microsoft.com/office/drawing/2014/main" id="{46BC0C95-38E5-41C4-88BF-933ABB0EB1A6}"/>
               </a:ext>
             </a:extLst>
           </p:cNvPr>
@@ -6208,7 +6208,7 @@
           <p:cNvPr id="34" name="">
             <a:extLst xmlns:a="http://schemas.openxmlformats.org/drawingml/2006/main">
               <a:ext uri="{FF2B5EF4-FFF2-40B4-BE49-F238E27FC236}">
-                <a16:creationId xmlns:a16="http://schemas.microsoft.com/office/drawing/2014/main" id="{6C9E9073-5BF1-4865-BE00-964243900DC8}"/>
+                <a16:creationId xmlns:a16="http://schemas.microsoft.com/office/drawing/2014/main" id="{B2E65F3F-7B68-45DF-B89B-B4A6395EF445}"/>
               </a:ext>
             </a:extLst>
           </p:cNvPr>
@@ -6256,7 +6256,7 @@
     </p:spTree>
     <p:extLst>
       <p:ext uri="{BB962C8B-B14F-4D97-AF65-F5344CB8AC3E}">
-        <p14:creationId xmlns:p14="http://schemas.microsoft.com/office/powerpoint/2010/main" val="800897869"/>
+        <p14:creationId xmlns:p14="http://schemas.microsoft.com/office/powerpoint/2010/main" val="1966937738"/>
       </p:ext>
     </p:extLst>
   </p:cSld>
@@ -6287,7 +6287,7 @@
           <p:cNvPr id="17" name="">
             <a:extLst xmlns:a="http://schemas.openxmlformats.org/drawingml/2006/main">
               <a:ext uri="{FF2B5EF4-FFF2-40B4-BE49-F238E27FC236}">
-                <a16:creationId xmlns:a16="http://schemas.microsoft.com/office/drawing/2014/main" id="{EF48AF4B-C86B-4B5E-80B1-948B5C80B096}"/>
+                <a16:creationId xmlns:a16="http://schemas.microsoft.com/office/drawing/2014/main" id="{1150AFA4-0A9F-41DF-B631-9F5A7B8EFAB5}"/>
               </a:ext>
             </a:extLst>
           </p:cNvPr>
@@ -6354,7 +6354,7 @@
           <p:cNvPr id="2" name="">
             <a:extLst xmlns:a="http://schemas.openxmlformats.org/drawingml/2006/main">
               <a:ext uri="{FF2B5EF4-FFF2-40B4-BE49-F238E27FC236}">
-                <a16:creationId xmlns:a16="http://schemas.microsoft.com/office/drawing/2014/main" id="{84FDFC9C-D272-49E3-ADFB-5B87B5604694}"/>
+                <a16:creationId xmlns:a16="http://schemas.microsoft.com/office/drawing/2014/main" id="{FCF071B9-8055-420A-8F92-51773F15BB36}"/>
               </a:ext>
             </a:extLst>
           </p:cNvPr>
@@ -6387,7 +6387,7 @@
           <p:cNvPr id="3" name="">
             <a:extLst xmlns:a="http://schemas.openxmlformats.org/drawingml/2006/main">
               <a:ext uri="{FF2B5EF4-FFF2-40B4-BE49-F238E27FC236}">
-                <a16:creationId xmlns:a16="http://schemas.microsoft.com/office/drawing/2014/main" id="{F112DC7B-1633-494B-8AFE-CA6F409402D3}"/>
+                <a16:creationId xmlns:a16="http://schemas.microsoft.com/office/drawing/2014/main" id="{7A72CE4B-91E0-4DA4-9FEC-70F55DCB963D}"/>
               </a:ext>
             </a:extLst>
           </p:cNvPr>
@@ -6420,7 +6420,7 @@
           <p:cNvPr id="4" name="">
             <a:extLst xmlns:a="http://schemas.openxmlformats.org/drawingml/2006/main">
               <a:ext uri="{FF2B5EF4-FFF2-40B4-BE49-F238E27FC236}">
-                <a16:creationId xmlns:a16="http://schemas.microsoft.com/office/drawing/2014/main" id="{FFBFC43B-7D13-4613-82BF-B468E96A1AAD}"/>
+                <a16:creationId xmlns:a16="http://schemas.microsoft.com/office/drawing/2014/main" id="{0566976B-69A6-4A27-A368-316597CA7238}"/>
               </a:ext>
             </a:extLst>
           </p:cNvPr>
@@ -6470,7 +6470,7 @@
           <p:cNvPr id="5" name="">
             <a:extLst xmlns:a="http://schemas.openxmlformats.org/drawingml/2006/main">
               <a:ext uri="{FF2B5EF4-FFF2-40B4-BE49-F238E27FC236}">
-                <a16:creationId xmlns:a16="http://schemas.microsoft.com/office/drawing/2014/main" id="{CB893E14-81D0-41E1-831B-607E5BF0A9B1}"/>
+                <a16:creationId xmlns:a16="http://schemas.microsoft.com/office/drawing/2014/main" id="{E7B08B12-4D3F-492D-B777-90D551AC97EC}"/>
               </a:ext>
             </a:extLst>
           </p:cNvPr>
@@ -6520,7 +6520,7 @@
           <p:cNvPr id="6" name="">
             <a:extLst xmlns:a="http://schemas.openxmlformats.org/drawingml/2006/main">
               <a:ext uri="{FF2B5EF4-FFF2-40B4-BE49-F238E27FC236}">
-                <a16:creationId xmlns:a16="http://schemas.microsoft.com/office/drawing/2014/main" id="{2FEEFB2F-4636-4499-A1F6-D5FB1651F714}"/>
+                <a16:creationId xmlns:a16="http://schemas.microsoft.com/office/drawing/2014/main" id="{B0B83F45-3C55-470B-84AF-C725A1BA1117}"/>
               </a:ext>
             </a:extLst>
           </p:cNvPr>
@@ -6553,7 +6553,7 @@
           <p:cNvPr id="7" name="">
             <a:extLst xmlns:a="http://schemas.openxmlformats.org/drawingml/2006/main">
               <a:ext uri="{FF2B5EF4-FFF2-40B4-BE49-F238E27FC236}">
-                <a16:creationId xmlns:a16="http://schemas.microsoft.com/office/drawing/2014/main" id="{6DDDDCC7-FE8F-4932-9778-93FF5B3A0465}"/>
+                <a16:creationId xmlns:a16="http://schemas.microsoft.com/office/drawing/2014/main" id="{A305486A-F7FA-411D-BDB4-E77D3AB85798}"/>
               </a:ext>
             </a:extLst>
           </p:cNvPr>
@@ -6586,7 +6586,7 @@
           <p:cNvPr id="8" name="">
             <a:extLst xmlns:a="http://schemas.openxmlformats.org/drawingml/2006/main">
               <a:ext uri="{FF2B5EF4-FFF2-40B4-BE49-F238E27FC236}">
-                <a16:creationId xmlns:a16="http://schemas.microsoft.com/office/drawing/2014/main" id="{2DAD6476-00EA-4B37-9DB4-790436D9C534}"/>
+                <a16:creationId xmlns:a16="http://schemas.microsoft.com/office/drawing/2014/main" id="{44018A9A-EE1F-49ED-9ED5-D815B5D49BCB}"/>
               </a:ext>
             </a:extLst>
           </p:cNvPr>
@@ -6636,7 +6636,7 @@
           <p:cNvPr id="9" name="">
             <a:extLst xmlns:a="http://schemas.openxmlformats.org/drawingml/2006/main">
               <a:ext uri="{FF2B5EF4-FFF2-40B4-BE49-F238E27FC236}">
-                <a16:creationId xmlns:a16="http://schemas.microsoft.com/office/drawing/2014/main" id="{50A38EF2-F7DE-4EB0-A622-1B13EC961DB4}"/>
+                <a16:creationId xmlns:a16="http://schemas.microsoft.com/office/drawing/2014/main" id="{4A9997F1-736B-41B8-8243-4B138CAB6F93}"/>
               </a:ext>
             </a:extLst>
           </p:cNvPr>
@@ -6686,7 +6686,7 @@
           <p:cNvPr id="10" name="">
             <a:extLst xmlns:a="http://schemas.openxmlformats.org/drawingml/2006/main">
               <a:ext uri="{FF2B5EF4-FFF2-40B4-BE49-F238E27FC236}">
-                <a16:creationId xmlns:a16="http://schemas.microsoft.com/office/drawing/2014/main" id="{F7C0B7A3-D10C-4E75-8C4D-5B3181C32AC3}"/>
+                <a16:creationId xmlns:a16="http://schemas.microsoft.com/office/drawing/2014/main" id="{DC0C0EDE-1BB3-4F3D-B1C7-96DB569D5743}"/>
               </a:ext>
             </a:extLst>
           </p:cNvPr>
@@ -6719,7 +6719,7 @@
           <p:cNvPr id="11" name="">
             <a:extLst xmlns:a="http://schemas.openxmlformats.org/drawingml/2006/main">
               <a:ext uri="{FF2B5EF4-FFF2-40B4-BE49-F238E27FC236}">
-                <a16:creationId xmlns:a16="http://schemas.microsoft.com/office/drawing/2014/main" id="{15EEF55B-9016-453F-AE3B-77C1B333CB18}"/>
+                <a16:creationId xmlns:a16="http://schemas.microsoft.com/office/drawing/2014/main" id="{55C76AA3-3C12-400A-B31E-D4C4D70A2AA2}"/>
               </a:ext>
             </a:extLst>
           </p:cNvPr>
@@ -6752,7 +6752,7 @@
           <p:cNvPr id="12" name="">
             <a:extLst xmlns:a="http://schemas.openxmlformats.org/drawingml/2006/main">
               <a:ext uri="{FF2B5EF4-FFF2-40B4-BE49-F238E27FC236}">
-                <a16:creationId xmlns:a16="http://schemas.microsoft.com/office/drawing/2014/main" id="{A5A1F88D-5302-4BD6-A156-A2E16AB36D29}"/>
+                <a16:creationId xmlns:a16="http://schemas.microsoft.com/office/drawing/2014/main" id="{84E62C0A-9701-4D5B-BEA4-E0BA3BB59FCE}"/>
               </a:ext>
             </a:extLst>
           </p:cNvPr>
@@ -6802,7 +6802,7 @@
           <p:cNvPr id="13" name="">
             <a:extLst xmlns:a="http://schemas.openxmlformats.org/drawingml/2006/main">
               <a:ext uri="{FF2B5EF4-FFF2-40B4-BE49-F238E27FC236}">
-                <a16:creationId xmlns:a16="http://schemas.microsoft.com/office/drawing/2014/main" id="{1DC9E2C5-4DD3-4388-AD9D-589366974C3D}"/>
+                <a16:creationId xmlns:a16="http://schemas.microsoft.com/office/drawing/2014/main" id="{7A265475-73EE-4949-A08A-1F2F23EF6797}"/>
               </a:ext>
             </a:extLst>
           </p:cNvPr>
@@ -6852,7 +6852,7 @@
           <p:cNvPr id="14" name="">
             <a:extLst xmlns:a="http://schemas.openxmlformats.org/drawingml/2006/main">
               <a:ext uri="{FF2B5EF4-FFF2-40B4-BE49-F238E27FC236}">
-                <a16:creationId xmlns:a16="http://schemas.microsoft.com/office/drawing/2014/main" id="{48A11EC9-6F12-4E56-BFB9-9D852B1DF29E}"/>
+                <a16:creationId xmlns:a16="http://schemas.microsoft.com/office/drawing/2014/main" id="{3B180078-2205-4592-BCCB-ED1C5BD6CAB2}"/>
               </a:ext>
             </a:extLst>
           </p:cNvPr>
@@ -6902,7 +6902,7 @@
           <p:cNvPr id="15" name="">
             <a:extLst xmlns:a="http://schemas.openxmlformats.org/drawingml/2006/main">
               <a:ext uri="{FF2B5EF4-FFF2-40B4-BE49-F238E27FC236}">
-                <a16:creationId xmlns:a16="http://schemas.microsoft.com/office/drawing/2014/main" id="{62E24230-3A50-4B84-BC02-421D4D9357DF}"/>
+                <a16:creationId xmlns:a16="http://schemas.microsoft.com/office/drawing/2014/main" id="{45FF785E-E9B0-4559-88CD-826795D5109F}"/>
               </a:ext>
             </a:extLst>
           </p:cNvPr>
@@ -6952,7 +6952,7 @@
           <p:cNvPr id="16" name="">
             <a:extLst xmlns:a="http://schemas.openxmlformats.org/drawingml/2006/main">
               <a:ext uri="{FF2B5EF4-FFF2-40B4-BE49-F238E27FC236}">
-                <a16:creationId xmlns:a16="http://schemas.microsoft.com/office/drawing/2014/main" id="{7173C3F9-7B1D-44E2-87A4-ECD12F3CE883}"/>
+                <a16:creationId xmlns:a16="http://schemas.microsoft.com/office/drawing/2014/main" id="{D8907CF4-9336-45D3-86B7-DA14EDA1D536}"/>
               </a:ext>
             </a:extLst>
           </p:cNvPr>
@@ -7000,7 +7000,7 @@
     </p:spTree>
     <p:extLst>
       <p:ext uri="{BB962C8B-B14F-4D97-AF65-F5344CB8AC3E}">
-        <p14:creationId xmlns:p14="http://schemas.microsoft.com/office/powerpoint/2010/main" val="1285154895"/>
+        <p14:creationId xmlns:p14="http://schemas.microsoft.com/office/powerpoint/2010/main" val="1074525787"/>
       </p:ext>
     </p:extLst>
   </p:cSld>
@@ -7031,7 +7031,7 @@
           <p:cNvPr id="26" name="">
             <a:extLst xmlns:a="http://schemas.openxmlformats.org/drawingml/2006/main">
               <a:ext uri="{FF2B5EF4-FFF2-40B4-BE49-F238E27FC236}">
-                <a16:creationId xmlns:a16="http://schemas.microsoft.com/office/drawing/2014/main" id="{DAC98BD3-9FDD-4A8C-B5F9-01CB0BCA7B9C}"/>
+                <a16:creationId xmlns:a16="http://schemas.microsoft.com/office/drawing/2014/main" id="{765DF91A-5958-4403-8F99-CA998EE4C70B}"/>
               </a:ext>
             </a:extLst>
           </p:cNvPr>
@@ -7081,7 +7081,7 @@
           <p:cNvPr id="2" name="">
             <a:extLst xmlns:a="http://schemas.openxmlformats.org/drawingml/2006/main">
               <a:ext uri="{FF2B5EF4-FFF2-40B4-BE49-F238E27FC236}">
-                <a16:creationId xmlns:a16="http://schemas.microsoft.com/office/drawing/2014/main" id="{D015C565-6C75-43A6-BDD8-B9AB42E177B7}"/>
+                <a16:creationId xmlns:a16="http://schemas.microsoft.com/office/drawing/2014/main" id="{A659E60D-AB83-4EB3-A615-8DC5EF283875}"/>
               </a:ext>
             </a:extLst>
           </p:cNvPr>
@@ -7131,7 +7131,7 @@
           <p:cNvPr id="3" name="">
             <a:extLst xmlns:a="http://schemas.openxmlformats.org/drawingml/2006/main">
               <a:ext uri="{FF2B5EF4-FFF2-40B4-BE49-F238E27FC236}">
-                <a16:creationId xmlns:a16="http://schemas.microsoft.com/office/drawing/2014/main" id="{1C2A4ECA-9767-4276-88D5-F6F65F32C8E1}"/>
+                <a16:creationId xmlns:a16="http://schemas.microsoft.com/office/drawing/2014/main" id="{B7908518-44B0-4413-8208-FC122503C16B}"/>
               </a:ext>
             </a:extLst>
           </p:cNvPr>
@@ -7181,7 +7181,7 @@
           <p:cNvPr id="4" name="">
             <a:extLst xmlns:a="http://schemas.openxmlformats.org/drawingml/2006/main">
               <a:ext uri="{FF2B5EF4-FFF2-40B4-BE49-F238E27FC236}">
-                <a16:creationId xmlns:a16="http://schemas.microsoft.com/office/drawing/2014/main" id="{1F9C6050-B7CB-4B82-B92B-62241B931A45}"/>
+                <a16:creationId xmlns:a16="http://schemas.microsoft.com/office/drawing/2014/main" id="{DE371ABF-1530-4ADF-9379-F8CA3FF2E6CE}"/>
               </a:ext>
             </a:extLst>
           </p:cNvPr>
@@ -7231,7 +7231,7 @@
           <p:cNvPr id="5" name="">
             <a:extLst xmlns:a="http://schemas.openxmlformats.org/drawingml/2006/main">
               <a:ext uri="{FF2B5EF4-FFF2-40B4-BE49-F238E27FC236}">
-                <a16:creationId xmlns:a16="http://schemas.microsoft.com/office/drawing/2014/main" id="{723C8618-0038-4E12-AC72-8EAA11654E3F}"/>
+                <a16:creationId xmlns:a16="http://schemas.microsoft.com/office/drawing/2014/main" id="{9F86FC00-0CB4-4E38-B627-772D95143CF0}"/>
               </a:ext>
             </a:extLst>
           </p:cNvPr>
@@ -7281,7 +7281,7 @@
           <p:cNvPr id="6" name="">
             <a:extLst xmlns:a="http://schemas.openxmlformats.org/drawingml/2006/main">
               <a:ext uri="{FF2B5EF4-FFF2-40B4-BE49-F238E27FC236}">
-                <a16:creationId xmlns:a16="http://schemas.microsoft.com/office/drawing/2014/main" id="{82004F57-6FCD-4C34-868E-054D4BC8D4FD}"/>
+                <a16:creationId xmlns:a16="http://schemas.microsoft.com/office/drawing/2014/main" id="{F69AA9F3-BDA4-4002-BB46-31D29931FD31}"/>
               </a:ext>
             </a:extLst>
           </p:cNvPr>
@@ -7314,7 +7314,7 @@
           <p:cNvPr id="7" name="">
             <a:extLst xmlns:a="http://schemas.openxmlformats.org/drawingml/2006/main">
               <a:ext uri="{FF2B5EF4-FFF2-40B4-BE49-F238E27FC236}">
-                <a16:creationId xmlns:a16="http://schemas.microsoft.com/office/drawing/2014/main" id="{61E7DEA3-4807-447E-AA8E-EEC7E3751896}"/>
+                <a16:creationId xmlns:a16="http://schemas.microsoft.com/office/drawing/2014/main" id="{67436B72-316E-420A-8262-EB7F9FC94A33}"/>
               </a:ext>
             </a:extLst>
           </p:cNvPr>
@@ -7347,7 +7347,7 @@
           <p:cNvPr id="8" name="">
             <a:extLst xmlns:a="http://schemas.openxmlformats.org/drawingml/2006/main">
               <a:ext uri="{FF2B5EF4-FFF2-40B4-BE49-F238E27FC236}">
-                <a16:creationId xmlns:a16="http://schemas.microsoft.com/office/drawing/2014/main" id="{3D0D6C5B-6AC4-4A54-BFBF-A3089877F8F6}"/>
+                <a16:creationId xmlns:a16="http://schemas.microsoft.com/office/drawing/2014/main" id="{6A57EC96-5E3C-40E7-9CAB-855025A381A8}"/>
               </a:ext>
             </a:extLst>
           </p:cNvPr>
@@ -7397,7 +7397,7 @@
           <p:cNvPr id="9" name="">
             <a:extLst xmlns:a="http://schemas.openxmlformats.org/drawingml/2006/main">
               <a:ext uri="{FF2B5EF4-FFF2-40B4-BE49-F238E27FC236}">
-                <a16:creationId xmlns:a16="http://schemas.microsoft.com/office/drawing/2014/main" id="{C4761700-1D89-4412-B986-FED7A29737C0}"/>
+                <a16:creationId xmlns:a16="http://schemas.microsoft.com/office/drawing/2014/main" id="{2E47E6C5-F39F-4411-8739-536E22DEC4E4}"/>
               </a:ext>
             </a:extLst>
           </p:cNvPr>
@@ -7447,7 +7447,7 @@
           <p:cNvPr id="10" name="">
             <a:extLst xmlns:a="http://schemas.openxmlformats.org/drawingml/2006/main">
               <a:ext uri="{FF2B5EF4-FFF2-40B4-BE49-F238E27FC236}">
-                <a16:creationId xmlns:a16="http://schemas.microsoft.com/office/drawing/2014/main" id="{54B60CEB-2B22-4EC9-9D44-83CFB03670DD}"/>
+                <a16:creationId xmlns:a16="http://schemas.microsoft.com/office/drawing/2014/main" id="{626321F3-5C3C-4308-BC6A-8832E05B5A3A}"/>
               </a:ext>
             </a:extLst>
           </p:cNvPr>
@@ -7480,7 +7480,7 @@
           <p:cNvPr id="11" name="">
             <a:extLst xmlns:a="http://schemas.openxmlformats.org/drawingml/2006/main">
               <a:ext uri="{FF2B5EF4-FFF2-40B4-BE49-F238E27FC236}">
-                <a16:creationId xmlns:a16="http://schemas.microsoft.com/office/drawing/2014/main" id="{D1352DAD-9F74-48F4-87B5-203EDFF2389D}"/>
+                <a16:creationId xmlns:a16="http://schemas.microsoft.com/office/drawing/2014/main" id="{20ADAB96-BF9D-46D4-9573-DFB71829283C}"/>
               </a:ext>
             </a:extLst>
           </p:cNvPr>
@@ -7513,7 +7513,7 @@
           <p:cNvPr id="12" name="">
             <a:extLst xmlns:a="http://schemas.openxmlformats.org/drawingml/2006/main">
               <a:ext uri="{FF2B5EF4-FFF2-40B4-BE49-F238E27FC236}">
-                <a16:creationId xmlns:a16="http://schemas.microsoft.com/office/drawing/2014/main" id="{64F929B2-E62B-447F-A697-EBA2D55F84B9}"/>
+                <a16:creationId xmlns:a16="http://schemas.microsoft.com/office/drawing/2014/main" id="{970FF353-8846-4346-AC63-C1BA8C67C860}"/>
               </a:ext>
             </a:extLst>
           </p:cNvPr>
@@ -7563,7 +7563,7 @@
           <p:cNvPr id="13" name="">
             <a:extLst xmlns:a="http://schemas.openxmlformats.org/drawingml/2006/main">
               <a:ext uri="{FF2B5EF4-FFF2-40B4-BE49-F238E27FC236}">
-                <a16:creationId xmlns:a16="http://schemas.microsoft.com/office/drawing/2014/main" id="{6C40B6FE-C32F-44FF-A536-18FF4D732146}"/>
+                <a16:creationId xmlns:a16="http://schemas.microsoft.com/office/drawing/2014/main" id="{BEB4CE23-A4F2-467C-A37F-8CB3327001AB}"/>
               </a:ext>
             </a:extLst>
           </p:cNvPr>
@@ -7613,7 +7613,7 @@
           <p:cNvPr id="14" name="">
             <a:extLst xmlns:a="http://schemas.openxmlformats.org/drawingml/2006/main">
               <a:ext uri="{FF2B5EF4-FFF2-40B4-BE49-F238E27FC236}">
-                <a16:creationId xmlns:a16="http://schemas.microsoft.com/office/drawing/2014/main" id="{D2EAD4C9-8292-4C10-B262-D3926CED1473}"/>
+                <a16:creationId xmlns:a16="http://schemas.microsoft.com/office/drawing/2014/main" id="{343C4127-5871-4066-8493-510BDA4B7DC1}"/>
               </a:ext>
             </a:extLst>
           </p:cNvPr>
@@ -7646,7 +7646,7 @@
           <p:cNvPr id="15" name="">
             <a:extLst xmlns:a="http://schemas.openxmlformats.org/drawingml/2006/main">
               <a:ext uri="{FF2B5EF4-FFF2-40B4-BE49-F238E27FC236}">
-                <a16:creationId xmlns:a16="http://schemas.microsoft.com/office/drawing/2014/main" id="{BB1C844D-CCD0-4AA0-BAD7-52D9477BF468}"/>
+                <a16:creationId xmlns:a16="http://schemas.microsoft.com/office/drawing/2014/main" id="{F7C3B60B-ECD2-4F94-AB01-39BBD9F63B32}"/>
               </a:ext>
             </a:extLst>
           </p:cNvPr>
@@ -7679,7 +7679,7 @@
           <p:cNvPr id="16" name="">
             <a:extLst xmlns:a="http://schemas.openxmlformats.org/drawingml/2006/main">
               <a:ext uri="{FF2B5EF4-FFF2-40B4-BE49-F238E27FC236}">
-                <a16:creationId xmlns:a16="http://schemas.microsoft.com/office/drawing/2014/main" id="{72C993F3-4848-4E0A-B079-86D784A65EFD}"/>
+                <a16:creationId xmlns:a16="http://schemas.microsoft.com/office/drawing/2014/main" id="{9E8B665F-8D45-40F8-9428-EFE42EB51EA4}"/>
               </a:ext>
             </a:extLst>
           </p:cNvPr>
@@ -7729,7 +7729,7 @@
           <p:cNvPr id="17" name="">
             <a:extLst xmlns:a="http://schemas.openxmlformats.org/drawingml/2006/main">
               <a:ext uri="{FF2B5EF4-FFF2-40B4-BE49-F238E27FC236}">
-                <a16:creationId xmlns:a16="http://schemas.microsoft.com/office/drawing/2014/main" id="{5BBF1B36-CAEA-458D-A892-664630FA7B90}"/>
+                <a16:creationId xmlns:a16="http://schemas.microsoft.com/office/drawing/2014/main" id="{F2922F0C-D3C7-4CEC-A6FD-D15E772274C6}"/>
               </a:ext>
             </a:extLst>
           </p:cNvPr>
@@ -7779,7 +7779,7 @@
           <p:cNvPr id="18" name="">
             <a:extLst xmlns:a="http://schemas.openxmlformats.org/drawingml/2006/main">
               <a:ext uri="{FF2B5EF4-FFF2-40B4-BE49-F238E27FC236}">
-                <a16:creationId xmlns:a16="http://schemas.microsoft.com/office/drawing/2014/main" id="{8CE5229B-E5C2-4FC9-8A56-35160316EA2D}"/>
+                <a16:creationId xmlns:a16="http://schemas.microsoft.com/office/drawing/2014/main" id="{15FEB420-6DB4-4A0A-B213-C8B88E55C547}"/>
               </a:ext>
             </a:extLst>
           </p:cNvPr>
@@ -7812,7 +7812,7 @@
           <p:cNvPr id="19" name="">
             <a:extLst xmlns:a="http://schemas.openxmlformats.org/drawingml/2006/main">
               <a:ext uri="{FF2B5EF4-FFF2-40B4-BE49-F238E27FC236}">
-                <a16:creationId xmlns:a16="http://schemas.microsoft.com/office/drawing/2014/main" id="{4B1BA6A6-1ACF-4679-92D4-8C675E53035D}"/>
+                <a16:creationId xmlns:a16="http://schemas.microsoft.com/office/drawing/2014/main" id="{07685457-57F9-4541-81FC-D413E9303530}"/>
               </a:ext>
             </a:extLst>
           </p:cNvPr>
@@ -7862,7 +7862,7 @@
           <p:cNvPr id="20" name="">
             <a:extLst xmlns:a="http://schemas.openxmlformats.org/drawingml/2006/main">
               <a:ext uri="{FF2B5EF4-FFF2-40B4-BE49-F238E27FC236}">
-                <a16:creationId xmlns:a16="http://schemas.microsoft.com/office/drawing/2014/main" id="{93C8E52F-EB4C-40B7-B24E-AA64886F28FF}"/>
+                <a16:creationId xmlns:a16="http://schemas.microsoft.com/office/drawing/2014/main" id="{D2DF407B-F3FB-4339-B3D5-9D00E4D3BF40}"/>
               </a:ext>
             </a:extLst>
           </p:cNvPr>
@@ -7912,7 +7912,7 @@
           <p:cNvPr id="21" name="">
             <a:extLst xmlns:a="http://schemas.openxmlformats.org/drawingml/2006/main">
               <a:ext uri="{FF2B5EF4-FFF2-40B4-BE49-F238E27FC236}">
-                <a16:creationId xmlns:a16="http://schemas.microsoft.com/office/drawing/2014/main" id="{703D469D-3B8F-4093-86B0-3F9156C885B6}"/>
+                <a16:creationId xmlns:a16="http://schemas.microsoft.com/office/drawing/2014/main" id="{B0C75A07-0101-4E51-874D-35AEA8E3908F}"/>
               </a:ext>
             </a:extLst>
           </p:cNvPr>
@@ -7962,7 +7962,7 @@
           <p:cNvPr id="22" name="">
             <a:extLst xmlns:a="http://schemas.openxmlformats.org/drawingml/2006/main">
               <a:ext uri="{FF2B5EF4-FFF2-40B4-BE49-F238E27FC236}">
-                <a16:creationId xmlns:a16="http://schemas.microsoft.com/office/drawing/2014/main" id="{3BF235DD-5B50-477B-BE6E-37FD856BB0A2}"/>
+                <a16:creationId xmlns:a16="http://schemas.microsoft.com/office/drawing/2014/main" id="{EF1C7DC5-059E-4A36-9E46-D7E2DF56F207}"/>
               </a:ext>
             </a:extLst>
           </p:cNvPr>
@@ -8012,7 +8012,7 @@
           <p:cNvPr id="23" name="">
             <a:extLst xmlns:a="http://schemas.openxmlformats.org/drawingml/2006/main">
               <a:ext uri="{FF2B5EF4-FFF2-40B4-BE49-F238E27FC236}">
-                <a16:creationId xmlns:a16="http://schemas.microsoft.com/office/drawing/2014/main" id="{61389C19-78F9-4C8B-A4F4-87B23553C1F4}"/>
+                <a16:creationId xmlns:a16="http://schemas.microsoft.com/office/drawing/2014/main" id="{12FB4D22-938B-4004-876A-0039FEF53D14}"/>
               </a:ext>
             </a:extLst>
           </p:cNvPr>
@@ -8062,7 +8062,7 @@
           <p:cNvPr id="24" name="">
             <a:extLst xmlns:a="http://schemas.openxmlformats.org/drawingml/2006/main">
               <a:ext uri="{FF2B5EF4-FFF2-40B4-BE49-F238E27FC236}">
-                <a16:creationId xmlns:a16="http://schemas.microsoft.com/office/drawing/2014/main" id="{C6BF1C74-C7BC-4955-B9F7-3B0CB9EB01F8}"/>
+                <a16:creationId xmlns:a16="http://schemas.microsoft.com/office/drawing/2014/main" id="{F8911826-F8D3-4C01-9063-04B1E39F15C6}"/>
               </a:ext>
             </a:extLst>
           </p:cNvPr>
@@ -8112,7 +8112,7 @@
           <p:cNvPr id="25" name="">
             <a:extLst xmlns:a="http://schemas.openxmlformats.org/drawingml/2006/main">
               <a:ext uri="{FF2B5EF4-FFF2-40B4-BE49-F238E27FC236}">
-                <a16:creationId xmlns:a16="http://schemas.microsoft.com/office/drawing/2014/main" id="{A5D01172-D8D7-4E66-B3EF-E8D6CC0DB5E9}"/>
+                <a16:creationId xmlns:a16="http://schemas.microsoft.com/office/drawing/2014/main" id="{0CD4372F-CF2C-4BCC-ADF4-AA28A1F43E80}"/>
               </a:ext>
             </a:extLst>
           </p:cNvPr>
@@ -8160,7 +8160,7 @@
     </p:spTree>
     <p:extLst>
       <p:ext uri="{BB962C8B-B14F-4D97-AF65-F5344CB8AC3E}">
-        <p14:creationId xmlns:p14="http://schemas.microsoft.com/office/powerpoint/2010/main" val="198796420"/>
+        <p14:creationId xmlns:p14="http://schemas.microsoft.com/office/powerpoint/2010/main" val="2043747795"/>
       </p:ext>
     </p:extLst>
   </p:cSld>
@@ -8191,7 +8191,7 @@
           <p:cNvPr id="26" name="">
             <a:extLst xmlns:a="http://schemas.openxmlformats.org/drawingml/2006/main">
               <a:ext uri="{FF2B5EF4-FFF2-40B4-BE49-F238E27FC236}">
-                <a16:creationId xmlns:a16="http://schemas.microsoft.com/office/drawing/2014/main" id="{584276A9-8354-4A47-83C2-898827651F6C}"/>
+                <a16:creationId xmlns:a16="http://schemas.microsoft.com/office/drawing/2014/main" id="{436A626C-33AE-443A-92A4-3EBBF1E5DD8D}"/>
               </a:ext>
             </a:extLst>
           </p:cNvPr>
@@ -8241,7 +8241,7 @@
           <p:cNvPr id="2" name="">
             <a:extLst xmlns:a="http://schemas.openxmlformats.org/drawingml/2006/main">
               <a:ext uri="{FF2B5EF4-FFF2-40B4-BE49-F238E27FC236}">
-                <a16:creationId xmlns:a16="http://schemas.microsoft.com/office/drawing/2014/main" id="{7BA7C149-430D-431F-AD46-61B77F6894BA}"/>
+                <a16:creationId xmlns:a16="http://schemas.microsoft.com/office/drawing/2014/main" id="{8047C6C9-0DCF-4AA2-8401-FE9D6839074B}"/>
               </a:ext>
             </a:extLst>
           </p:cNvPr>
@@ -8291,7 +8291,7 @@
           <p:cNvPr id="3" name="">
             <a:extLst xmlns:a="http://schemas.openxmlformats.org/drawingml/2006/main">
               <a:ext uri="{FF2B5EF4-FFF2-40B4-BE49-F238E27FC236}">
-                <a16:creationId xmlns:a16="http://schemas.microsoft.com/office/drawing/2014/main" id="{731C9353-E1AD-4A25-BB9E-EA2E9D73D80C}"/>
+                <a16:creationId xmlns:a16="http://schemas.microsoft.com/office/drawing/2014/main" id="{17EAF4C0-B6CD-4741-8411-FAF3A9E718B6}"/>
               </a:ext>
             </a:extLst>
           </p:cNvPr>
@@ -8341,7 +8341,7 @@
           <p:cNvPr id="4" name="">
             <a:extLst xmlns:a="http://schemas.openxmlformats.org/drawingml/2006/main">
               <a:ext uri="{FF2B5EF4-FFF2-40B4-BE49-F238E27FC236}">
-                <a16:creationId xmlns:a16="http://schemas.microsoft.com/office/drawing/2014/main" id="{D7A51F89-6333-40A9-A68B-8C023CE5F5E1}"/>
+                <a16:creationId xmlns:a16="http://schemas.microsoft.com/office/drawing/2014/main" id="{EA36C744-42B8-4231-97E5-04A18F06B243}"/>
               </a:ext>
             </a:extLst>
           </p:cNvPr>
@@ -8391,7 +8391,7 @@
           <p:cNvPr id="5" name="">
             <a:extLst xmlns:a="http://schemas.openxmlformats.org/drawingml/2006/main">
               <a:ext uri="{FF2B5EF4-FFF2-40B4-BE49-F238E27FC236}">
-                <a16:creationId xmlns:a16="http://schemas.microsoft.com/office/drawing/2014/main" id="{FDA62185-036D-4374-AD8E-B66F06AD0468}"/>
+                <a16:creationId xmlns:a16="http://schemas.microsoft.com/office/drawing/2014/main" id="{CB930375-8E9D-4EC8-83A6-D5DA89340D34}"/>
               </a:ext>
             </a:extLst>
           </p:cNvPr>
@@ -8441,7 +8441,7 @@
           <p:cNvPr id="6" name="">
             <a:extLst xmlns:a="http://schemas.openxmlformats.org/drawingml/2006/main">
               <a:ext uri="{FF2B5EF4-FFF2-40B4-BE49-F238E27FC236}">
-                <a16:creationId xmlns:a16="http://schemas.microsoft.com/office/drawing/2014/main" id="{C93D3B7A-29C2-4363-B7D2-39DC1FB739AF}"/>
+                <a16:creationId xmlns:a16="http://schemas.microsoft.com/office/drawing/2014/main" id="{D1AF7C55-17CC-4524-A2E0-EE491E1869A6}"/>
               </a:ext>
             </a:extLst>
           </p:cNvPr>
@@ -8474,7 +8474,7 @@
           <p:cNvPr id="7" name="">
             <a:extLst xmlns:a="http://schemas.openxmlformats.org/drawingml/2006/main">
               <a:ext uri="{FF2B5EF4-FFF2-40B4-BE49-F238E27FC236}">
-                <a16:creationId xmlns:a16="http://schemas.microsoft.com/office/drawing/2014/main" id="{15829770-FFB2-4E73-8445-FFFE83FDCC1C}"/>
+                <a16:creationId xmlns:a16="http://schemas.microsoft.com/office/drawing/2014/main" id="{3124EB42-8EAE-4746-94BF-185BEE923EE4}"/>
               </a:ext>
             </a:extLst>
           </p:cNvPr>
@@ -8524,7 +8524,7 @@
           <p:cNvPr id="8" name="">
             <a:extLst xmlns:a="http://schemas.openxmlformats.org/drawingml/2006/main">
               <a:ext uri="{FF2B5EF4-FFF2-40B4-BE49-F238E27FC236}">
-                <a16:creationId xmlns:a16="http://schemas.microsoft.com/office/drawing/2014/main" id="{3F241D3C-FAF2-4E12-A70A-751E1B9C696B}"/>
+                <a16:creationId xmlns:a16="http://schemas.microsoft.com/office/drawing/2014/main" id="{5F022269-5AF8-4136-91EB-0CCE1AC1F049}"/>
               </a:ext>
             </a:extLst>
           </p:cNvPr>
@@ -8574,7 +8574,7 @@
           <p:cNvPr id="9" name="">
             <a:extLst xmlns:a="http://schemas.openxmlformats.org/drawingml/2006/main">
               <a:ext uri="{FF2B5EF4-FFF2-40B4-BE49-F238E27FC236}">
-                <a16:creationId xmlns:a16="http://schemas.microsoft.com/office/drawing/2014/main" id="{26308B5A-487A-47CF-B166-EDFC4B28C994}"/>
+                <a16:creationId xmlns:a16="http://schemas.microsoft.com/office/drawing/2014/main" id="{71B607B4-9241-4D5A-A0A8-E43C569B6BBA}"/>
               </a:ext>
             </a:extLst>
           </p:cNvPr>
@@ -8624,7 +8624,7 @@
           <p:cNvPr id="10" name="">
             <a:extLst xmlns:a="http://schemas.openxmlformats.org/drawingml/2006/main">
               <a:ext uri="{FF2B5EF4-FFF2-40B4-BE49-F238E27FC236}">
-                <a16:creationId xmlns:a16="http://schemas.microsoft.com/office/drawing/2014/main" id="{3812118E-22BB-44E2-A3E6-48768A176DE3}"/>
+                <a16:creationId xmlns:a16="http://schemas.microsoft.com/office/drawing/2014/main" id="{E136F87E-CFC1-4D0D-A6EF-7B65B3C255A4}"/>
               </a:ext>
             </a:extLst>
           </p:cNvPr>
@@ -8657,7 +8657,7 @@
           <p:cNvPr id="11" name="">
             <a:extLst xmlns:a="http://schemas.openxmlformats.org/drawingml/2006/main">
               <a:ext uri="{FF2B5EF4-FFF2-40B4-BE49-F238E27FC236}">
-                <a16:creationId xmlns:a16="http://schemas.microsoft.com/office/drawing/2014/main" id="{E1BA6D00-3B06-4D8B-8BCA-AA8BC5E03A14}"/>
+                <a16:creationId xmlns:a16="http://schemas.microsoft.com/office/drawing/2014/main" id="{26DB8E4A-D8D3-429B-B7FB-DC4A3808D44C}"/>
               </a:ext>
             </a:extLst>
           </p:cNvPr>
@@ -8690,7 +8690,7 @@
           <p:cNvPr id="12" name="">
             <a:extLst xmlns:a="http://schemas.openxmlformats.org/drawingml/2006/main">
               <a:ext uri="{FF2B5EF4-FFF2-40B4-BE49-F238E27FC236}">
-                <a16:creationId xmlns:a16="http://schemas.microsoft.com/office/drawing/2014/main" id="{34196F1C-7BED-4809-B672-33E40FCEEA0D}"/>
+                <a16:creationId xmlns:a16="http://schemas.microsoft.com/office/drawing/2014/main" id="{32A19C40-88E0-4947-A296-182C686AD952}"/>
               </a:ext>
             </a:extLst>
           </p:cNvPr>
@@ -8740,7 +8740,7 @@
           <p:cNvPr id="13" name="">
             <a:extLst xmlns:a="http://schemas.openxmlformats.org/drawingml/2006/main">
               <a:ext uri="{FF2B5EF4-FFF2-40B4-BE49-F238E27FC236}">
-                <a16:creationId xmlns:a16="http://schemas.microsoft.com/office/drawing/2014/main" id="{DDFDA133-FF1A-49CF-B54A-BC95B1BBC565}"/>
+                <a16:creationId xmlns:a16="http://schemas.microsoft.com/office/drawing/2014/main" id="{1FE31335-521E-4100-BA33-C45A61F9CFA8}"/>
               </a:ext>
             </a:extLst>
           </p:cNvPr>
@@ -8790,7 +8790,7 @@
           <p:cNvPr id="14" name="">
             <a:extLst xmlns:a="http://schemas.openxmlformats.org/drawingml/2006/main">
               <a:ext uri="{FF2B5EF4-FFF2-40B4-BE49-F238E27FC236}">
-                <a16:creationId xmlns:a16="http://schemas.microsoft.com/office/drawing/2014/main" id="{6F0E0871-7A09-41FA-A72A-564A37449B1B}"/>
+                <a16:creationId xmlns:a16="http://schemas.microsoft.com/office/drawing/2014/main" id="{93B53A15-D948-41A4-8467-CFA8516C71AD}"/>
               </a:ext>
             </a:extLst>
           </p:cNvPr>
@@ -8823,7 +8823,7 @@
           <p:cNvPr id="15" name="">
             <a:extLst xmlns:a="http://schemas.openxmlformats.org/drawingml/2006/main">
               <a:ext uri="{FF2B5EF4-FFF2-40B4-BE49-F238E27FC236}">
-                <a16:creationId xmlns:a16="http://schemas.microsoft.com/office/drawing/2014/main" id="{6C4786CF-E5AC-4C90-975B-98F12BAA18A5}"/>
+                <a16:creationId xmlns:a16="http://schemas.microsoft.com/office/drawing/2014/main" id="{597DB871-B927-4FB6-88B8-A02EEEB0EB33}"/>
               </a:ext>
             </a:extLst>
           </p:cNvPr>
@@ -8856,7 +8856,7 @@
           <p:cNvPr id="16" name="">
             <a:extLst xmlns:a="http://schemas.openxmlformats.org/drawingml/2006/main">
               <a:ext uri="{FF2B5EF4-FFF2-40B4-BE49-F238E27FC236}">
-                <a16:creationId xmlns:a16="http://schemas.microsoft.com/office/drawing/2014/main" id="{E5465F40-55A0-4E91-99C1-B130CFE34FE0}"/>
+                <a16:creationId xmlns:a16="http://schemas.microsoft.com/office/drawing/2014/main" id="{2A7DC741-0B60-4F8D-891D-DD1C6D07DFC3}"/>
               </a:ext>
             </a:extLst>
           </p:cNvPr>
@@ -8906,7 +8906,7 @@
           <p:cNvPr id="17" name="">
             <a:extLst xmlns:a="http://schemas.openxmlformats.org/drawingml/2006/main">
               <a:ext uri="{FF2B5EF4-FFF2-40B4-BE49-F238E27FC236}">
-                <a16:creationId xmlns:a16="http://schemas.microsoft.com/office/drawing/2014/main" id="{BE41D8AB-D115-462D-AAED-CCD8B7FFDAE5}"/>
+                <a16:creationId xmlns:a16="http://schemas.microsoft.com/office/drawing/2014/main" id="{ED16ED49-81BB-4C96-961C-15601D867455}"/>
               </a:ext>
             </a:extLst>
           </p:cNvPr>
@@ -8956,7 +8956,7 @@
           <p:cNvPr id="18" name="">
             <a:extLst xmlns:a="http://schemas.openxmlformats.org/drawingml/2006/main">
               <a:ext uri="{FF2B5EF4-FFF2-40B4-BE49-F238E27FC236}">
-                <a16:creationId xmlns:a16="http://schemas.microsoft.com/office/drawing/2014/main" id="{BA2E111D-34A7-44B9-B4EA-306C2E7537DE}"/>
+                <a16:creationId xmlns:a16="http://schemas.microsoft.com/office/drawing/2014/main" id="{3E57A278-BB5F-4C0B-AD31-D3E4EF421943}"/>
               </a:ext>
             </a:extLst>
           </p:cNvPr>
@@ -8989,7 +8989,7 @@
           <p:cNvPr id="19" name="">
             <a:extLst xmlns:a="http://schemas.openxmlformats.org/drawingml/2006/main">
               <a:ext uri="{FF2B5EF4-FFF2-40B4-BE49-F238E27FC236}">
-                <a16:creationId xmlns:a16="http://schemas.microsoft.com/office/drawing/2014/main" id="{4EB65A18-34A7-493D-A32C-23711C2750D0}"/>
+                <a16:creationId xmlns:a16="http://schemas.microsoft.com/office/drawing/2014/main" id="{A1DE0791-66D6-4B9F-842F-8D3D68901357}"/>
               </a:ext>
             </a:extLst>
           </p:cNvPr>
@@ -9022,7 +9022,7 @@
           <p:cNvPr id="20" name="">
             <a:extLst xmlns:a="http://schemas.openxmlformats.org/drawingml/2006/main">
               <a:ext uri="{FF2B5EF4-FFF2-40B4-BE49-F238E27FC236}">
-                <a16:creationId xmlns:a16="http://schemas.microsoft.com/office/drawing/2014/main" id="{F70A0C40-CAD8-4D0A-B3C5-C3BCF1093E0E}"/>
+                <a16:creationId xmlns:a16="http://schemas.microsoft.com/office/drawing/2014/main" id="{2A10369D-23E0-4B64-B2B8-CD92B923D7B2}"/>
               </a:ext>
             </a:extLst>
           </p:cNvPr>
@@ -9072,7 +9072,7 @@
           <p:cNvPr id="21" name="">
             <a:extLst xmlns:a="http://schemas.openxmlformats.org/drawingml/2006/main">
               <a:ext uri="{FF2B5EF4-FFF2-40B4-BE49-F238E27FC236}">
-                <a16:creationId xmlns:a16="http://schemas.microsoft.com/office/drawing/2014/main" id="{730452EB-6FBE-4E68-8529-1CB8EF6201F2}"/>
+                <a16:creationId xmlns:a16="http://schemas.microsoft.com/office/drawing/2014/main" id="{02CED715-1536-4B86-B40B-90A420064091}"/>
               </a:ext>
             </a:extLst>
           </p:cNvPr>
@@ -9122,7 +9122,7 @@
           <p:cNvPr id="22" name="">
             <a:extLst xmlns:a="http://schemas.openxmlformats.org/drawingml/2006/main">
               <a:ext uri="{FF2B5EF4-FFF2-40B4-BE49-F238E27FC236}">
-                <a16:creationId xmlns:a16="http://schemas.microsoft.com/office/drawing/2014/main" id="{9F9793F3-48EC-43B3-8E8E-64E31B5C8B53}"/>
+                <a16:creationId xmlns:a16="http://schemas.microsoft.com/office/drawing/2014/main" id="{BCF78F82-EAE1-4CDA-94B6-72F56F43AC8D}"/>
               </a:ext>
             </a:extLst>
           </p:cNvPr>
@@ -9155,7 +9155,7 @@
           <p:cNvPr id="23" name="">
             <a:extLst xmlns:a="http://schemas.openxmlformats.org/drawingml/2006/main">
               <a:ext uri="{FF2B5EF4-FFF2-40B4-BE49-F238E27FC236}">
-                <a16:creationId xmlns:a16="http://schemas.microsoft.com/office/drawing/2014/main" id="{068E00CC-C47C-4F14-A2E4-6D2F28420BD3}"/>
+                <a16:creationId xmlns:a16="http://schemas.microsoft.com/office/drawing/2014/main" id="{DCCD38D5-E513-4E7C-B1AA-4D6C74310522}"/>
               </a:ext>
             </a:extLst>
           </p:cNvPr>
@@ -9205,7 +9205,7 @@
           <p:cNvPr id="24" name="">
             <a:extLst xmlns:a="http://schemas.openxmlformats.org/drawingml/2006/main">
               <a:ext uri="{FF2B5EF4-FFF2-40B4-BE49-F238E27FC236}">
-                <a16:creationId xmlns:a16="http://schemas.microsoft.com/office/drawing/2014/main" id="{7DDB288E-791C-4E79-A4E0-85CCC590398D}"/>
+                <a16:creationId xmlns:a16="http://schemas.microsoft.com/office/drawing/2014/main" id="{B1983B21-92C5-4F60-A068-621B6915E1CB}"/>
               </a:ext>
             </a:extLst>
           </p:cNvPr>
@@ -9255,7 +9255,7 @@
           <p:cNvPr id="25" name="">
             <a:extLst xmlns:a="http://schemas.openxmlformats.org/drawingml/2006/main">
               <a:ext uri="{FF2B5EF4-FFF2-40B4-BE49-F238E27FC236}">
-                <a16:creationId xmlns:a16="http://schemas.microsoft.com/office/drawing/2014/main" id="{F03379C0-2505-4D1A-B160-ECADEB4813B6}"/>
+                <a16:creationId xmlns:a16="http://schemas.microsoft.com/office/drawing/2014/main" id="{26427C7C-76D3-4E7B-AA6B-9CD4057E8EEA}"/>
               </a:ext>
             </a:extLst>
           </p:cNvPr>
@@ -9303,7 +9303,7 @@
     </p:spTree>
     <p:extLst>
       <p:ext uri="{BB962C8B-B14F-4D97-AF65-F5344CB8AC3E}">
-        <p14:creationId xmlns:p14="http://schemas.microsoft.com/office/powerpoint/2010/main" val="202921563"/>
+        <p14:creationId xmlns:p14="http://schemas.microsoft.com/office/powerpoint/2010/main" val="2109176473"/>
       </p:ext>
     </p:extLst>
   </p:cSld>
@@ -9334,7 +9334,7 @@
           <p:cNvPr id="19" name="">
             <a:extLst xmlns:a="http://schemas.openxmlformats.org/drawingml/2006/main">
               <a:ext uri="{FF2B5EF4-FFF2-40B4-BE49-F238E27FC236}">
-                <a16:creationId xmlns:a16="http://schemas.microsoft.com/office/drawing/2014/main" id="{A760A2B2-9FC2-494F-957D-23332EB7EE55}"/>
+                <a16:creationId xmlns:a16="http://schemas.microsoft.com/office/drawing/2014/main" id="{9D077A39-6C3A-4E9D-B394-F691A4756CE8}"/>
               </a:ext>
             </a:extLst>
           </p:cNvPr>
@@ -9384,7 +9384,7 @@
           <p:cNvPr id="2" name="">
             <a:extLst xmlns:a="http://schemas.openxmlformats.org/drawingml/2006/main">
               <a:ext uri="{FF2B5EF4-FFF2-40B4-BE49-F238E27FC236}">
-                <a16:creationId xmlns:a16="http://schemas.microsoft.com/office/drawing/2014/main" id="{CE7A5FEE-C731-4BE7-9EAA-205A44DB0355}"/>
+                <a16:creationId xmlns:a16="http://schemas.microsoft.com/office/drawing/2014/main" id="{CA5ACD37-72C6-4F67-AAD9-990D4BDB0728}"/>
               </a:ext>
             </a:extLst>
           </p:cNvPr>
@@ -9434,7 +9434,7 @@
           <p:cNvPr id="3" name="">
             <a:extLst xmlns:a="http://schemas.openxmlformats.org/drawingml/2006/main">
               <a:ext uri="{FF2B5EF4-FFF2-40B4-BE49-F238E27FC236}">
-                <a16:creationId xmlns:a16="http://schemas.microsoft.com/office/drawing/2014/main" id="{089A52C4-BF59-4810-B3FC-A1DE60A10889}"/>
+                <a16:creationId xmlns:a16="http://schemas.microsoft.com/office/drawing/2014/main" id="{C539BE85-CA83-4114-B04F-CDEE8C32F69D}"/>
               </a:ext>
             </a:extLst>
           </p:cNvPr>
@@ -9484,7 +9484,7 @@
           <p:cNvPr id="4" name="">
             <a:extLst xmlns:a="http://schemas.openxmlformats.org/drawingml/2006/main">
               <a:ext uri="{FF2B5EF4-FFF2-40B4-BE49-F238E27FC236}">
-                <a16:creationId xmlns:a16="http://schemas.microsoft.com/office/drawing/2014/main" id="{452D1D83-3EB9-4FD0-8F56-9D42C88CAB7A}"/>
+                <a16:creationId xmlns:a16="http://schemas.microsoft.com/office/drawing/2014/main" id="{6CD628DA-06AE-4607-A011-1F1D351E09C7}"/>
               </a:ext>
             </a:extLst>
           </p:cNvPr>
@@ -9534,7 +9534,7 @@
           <p:cNvPr id="5" name="">
             <a:extLst xmlns:a="http://schemas.openxmlformats.org/drawingml/2006/main">
               <a:ext uri="{FF2B5EF4-FFF2-40B4-BE49-F238E27FC236}">
-                <a16:creationId xmlns:a16="http://schemas.microsoft.com/office/drawing/2014/main" id="{DBC4620D-5DE3-464E-9CB7-30A441503D80}"/>
+                <a16:creationId xmlns:a16="http://schemas.microsoft.com/office/drawing/2014/main" id="{49AA5365-7D90-47F0-B5AA-4D7419431A33}"/>
               </a:ext>
             </a:extLst>
           </p:cNvPr>
@@ -9584,7 +9584,7 @@
           <p:cNvPr id="6" name="">
             <a:extLst xmlns:a="http://schemas.openxmlformats.org/drawingml/2006/main">
               <a:ext uri="{FF2B5EF4-FFF2-40B4-BE49-F238E27FC236}">
-                <a16:creationId xmlns:a16="http://schemas.microsoft.com/office/drawing/2014/main" id="{6F4014DE-6053-4FFC-8C8A-B9777C76CE7F}"/>
+                <a16:creationId xmlns:a16="http://schemas.microsoft.com/office/drawing/2014/main" id="{EBE13876-599D-4796-A8D3-325A4C0ABA82}"/>
               </a:ext>
             </a:extLst>
           </p:cNvPr>
@@ -9617,7 +9617,7 @@
           <p:cNvPr id="7" name="">
             <a:extLst xmlns:a="http://schemas.openxmlformats.org/drawingml/2006/main">
               <a:ext uri="{FF2B5EF4-FFF2-40B4-BE49-F238E27FC236}">
-                <a16:creationId xmlns:a16="http://schemas.microsoft.com/office/drawing/2014/main" id="{41437698-71E9-48BF-9946-9A09454907DE}"/>
+                <a16:creationId xmlns:a16="http://schemas.microsoft.com/office/drawing/2014/main" id="{D3B9FCEC-E7AD-4DD5-BF8B-ABF11266EE33}"/>
               </a:ext>
             </a:extLst>
           </p:cNvPr>
@@ -9650,7 +9650,7 @@
           <p:cNvPr id="8" name="">
             <a:extLst xmlns:a="http://schemas.openxmlformats.org/drawingml/2006/main">
               <a:ext uri="{FF2B5EF4-FFF2-40B4-BE49-F238E27FC236}">
-                <a16:creationId xmlns:a16="http://schemas.microsoft.com/office/drawing/2014/main" id="{639B70C7-C2A9-4CCF-8E6F-0A80081C0ED4}"/>
+                <a16:creationId xmlns:a16="http://schemas.microsoft.com/office/drawing/2014/main" id="{9AFC4C12-0CA4-4877-A7AA-A3249323C547}"/>
               </a:ext>
             </a:extLst>
           </p:cNvPr>
@@ -9700,7 +9700,7 @@
           <p:cNvPr id="9" name="">
             <a:extLst xmlns:a="http://schemas.openxmlformats.org/drawingml/2006/main">
               <a:ext uri="{FF2B5EF4-FFF2-40B4-BE49-F238E27FC236}">
-                <a16:creationId xmlns:a16="http://schemas.microsoft.com/office/drawing/2014/main" id="{69D1F6AA-2625-4E16-8616-98FC7D208350}"/>
+                <a16:creationId xmlns:a16="http://schemas.microsoft.com/office/drawing/2014/main" id="{C799C2F6-B731-4787-B7F8-2AAC3FD3B1E8}"/>
               </a:ext>
             </a:extLst>
           </p:cNvPr>
@@ -9835,7 +9835,7 @@
           <p:cNvPr id="10" name="">
             <a:extLst xmlns:a="http://schemas.openxmlformats.org/drawingml/2006/main">
               <a:ext uri="{FF2B5EF4-FFF2-40B4-BE49-F238E27FC236}">
-                <a16:creationId xmlns:a16="http://schemas.microsoft.com/office/drawing/2014/main" id="{ACA3D66B-91E9-49EC-8C53-0FF599812308}"/>
+                <a16:creationId xmlns:a16="http://schemas.microsoft.com/office/drawing/2014/main" id="{310A4CBB-3A2A-43C7-8E63-533EE71CABB9}"/>
               </a:ext>
             </a:extLst>
           </p:cNvPr>
@@ -9868,7 +9868,7 @@
           <p:cNvPr id="11" name="">
             <a:extLst xmlns:a="http://schemas.openxmlformats.org/drawingml/2006/main">
               <a:ext uri="{FF2B5EF4-FFF2-40B4-BE49-F238E27FC236}">
-                <a16:creationId xmlns:a16="http://schemas.microsoft.com/office/drawing/2014/main" id="{6FC19D49-01EE-4FC2-BDEC-65FFC79B994D}"/>
+                <a16:creationId xmlns:a16="http://schemas.microsoft.com/office/drawing/2014/main" id="{D86DD350-1782-4A3B-BFCF-BCF97D7AE6B5}"/>
               </a:ext>
             </a:extLst>
           </p:cNvPr>
@@ -9901,7 +9901,7 @@
           <p:cNvPr id="12" name="">
             <a:extLst xmlns:a="http://schemas.openxmlformats.org/drawingml/2006/main">
               <a:ext uri="{FF2B5EF4-FFF2-40B4-BE49-F238E27FC236}">
-                <a16:creationId xmlns:a16="http://schemas.microsoft.com/office/drawing/2014/main" id="{A5DAE2C4-A2C6-48CA-9BF3-EE7D72DB13C6}"/>
+                <a16:creationId xmlns:a16="http://schemas.microsoft.com/office/drawing/2014/main" id="{17FF4C72-C1A5-4CD6-A642-BC601D18CE2C}"/>
               </a:ext>
             </a:extLst>
           </p:cNvPr>
@@ -9951,7 +9951,7 @@
           <p:cNvPr id="13" name="">
             <a:extLst xmlns:a="http://schemas.openxmlformats.org/drawingml/2006/main">
               <a:ext uri="{FF2B5EF4-FFF2-40B4-BE49-F238E27FC236}">
-                <a16:creationId xmlns:a16="http://schemas.microsoft.com/office/drawing/2014/main" id="{463906F9-4DD4-4013-A445-5BA0CAF55BA3}"/>
+                <a16:creationId xmlns:a16="http://schemas.microsoft.com/office/drawing/2014/main" id="{4E2F4582-EC88-4A07-A523-A904AC2F612E}"/>
               </a:ext>
             </a:extLst>
           </p:cNvPr>
@@ -10057,7 +10057,7 @@
           <p:cNvPr id="14" name="">
             <a:extLst xmlns:a="http://schemas.openxmlformats.org/drawingml/2006/main">
               <a:ext uri="{FF2B5EF4-FFF2-40B4-BE49-F238E27FC236}">
-                <a16:creationId xmlns:a16="http://schemas.microsoft.com/office/drawing/2014/main" id="{1FCF3872-5876-4987-89F4-4606AD8F232B}"/>
+                <a16:creationId xmlns:a16="http://schemas.microsoft.com/office/drawing/2014/main" id="{5CBEEA9C-2FB8-49DA-96E1-3C71B6AB291D}"/>
               </a:ext>
             </a:extLst>
           </p:cNvPr>
@@ -10090,7 +10090,7 @@
           <p:cNvPr id="15" name="">
             <a:extLst xmlns:a="http://schemas.openxmlformats.org/drawingml/2006/main">
               <a:ext uri="{FF2B5EF4-FFF2-40B4-BE49-F238E27FC236}">
-                <a16:creationId xmlns:a16="http://schemas.microsoft.com/office/drawing/2014/main" id="{5DC46277-41ED-4309-AA24-5221912C28E6}"/>
+                <a16:creationId xmlns:a16="http://schemas.microsoft.com/office/drawing/2014/main" id="{A6ECB5E4-F18F-40AB-86AA-B226C5DEE886}"/>
               </a:ext>
             </a:extLst>
           </p:cNvPr>
@@ -10123,7 +10123,7 @@
           <p:cNvPr id="16" name="">
             <a:extLst xmlns:a="http://schemas.openxmlformats.org/drawingml/2006/main">
               <a:ext uri="{FF2B5EF4-FFF2-40B4-BE49-F238E27FC236}">
-                <a16:creationId xmlns:a16="http://schemas.microsoft.com/office/drawing/2014/main" id="{3AB539FF-5B2A-4BD6-A02A-DFAB0E99862E}"/>
+                <a16:creationId xmlns:a16="http://schemas.microsoft.com/office/drawing/2014/main" id="{22EE208B-1187-472F-8705-91C8E5699453}"/>
               </a:ext>
             </a:extLst>
           </p:cNvPr>
@@ -10173,7 +10173,7 @@
           <p:cNvPr id="17" name="">
             <a:extLst xmlns:a="http://schemas.openxmlformats.org/drawingml/2006/main">
               <a:ext uri="{FF2B5EF4-FFF2-40B4-BE49-F238E27FC236}">
-                <a16:creationId xmlns:a16="http://schemas.microsoft.com/office/drawing/2014/main" id="{74D0979D-DA02-45E9-A610-80C6259B9A62}"/>
+                <a16:creationId xmlns:a16="http://schemas.microsoft.com/office/drawing/2014/main" id="{B55431F1-A91A-42BF-B509-3D922B2A0D77}"/>
               </a:ext>
             </a:extLst>
           </p:cNvPr>
@@ -10296,7 +10296,7 @@
           <p:cNvPr id="18" name="">
             <a:extLst xmlns:a="http://schemas.openxmlformats.org/drawingml/2006/main">
               <a:ext uri="{FF2B5EF4-FFF2-40B4-BE49-F238E27FC236}">
-                <a16:creationId xmlns:a16="http://schemas.microsoft.com/office/drawing/2014/main" id="{6BE170C8-A76A-46F6-9DC6-7B696124A784}"/>
+                <a16:creationId xmlns:a16="http://schemas.microsoft.com/office/drawing/2014/main" id="{E425F268-EE92-4B65-B706-6531C71A119A}"/>
               </a:ext>
             </a:extLst>
           </p:cNvPr>
@@ -10344,7 +10344,7 @@
     </p:spTree>
     <p:extLst>
       <p:ext uri="{BB962C8B-B14F-4D97-AF65-F5344CB8AC3E}">
-        <p14:creationId xmlns:p14="http://schemas.microsoft.com/office/powerpoint/2010/main" val="419392830"/>
+        <p14:creationId xmlns:p14="http://schemas.microsoft.com/office/powerpoint/2010/main" val="317401644"/>
       </p:ext>
     </p:extLst>
   </p:cSld>
@@ -10375,7 +10375,7 @@
           <p:cNvPr id="49" name="">
             <a:extLst xmlns:a="http://schemas.openxmlformats.org/drawingml/2006/main">
               <a:ext uri="{FF2B5EF4-FFF2-40B4-BE49-F238E27FC236}">
-                <a16:creationId xmlns:a16="http://schemas.microsoft.com/office/drawing/2014/main" id="{EFC2034A-DEF4-45A0-B799-EAE8E8BCF3F6}"/>
+                <a16:creationId xmlns:a16="http://schemas.microsoft.com/office/drawing/2014/main" id="{AC0949C4-73CE-4D83-8F5B-E8700F89E0A3}"/>
               </a:ext>
             </a:extLst>
           </p:cNvPr>
@@ -10425,7 +10425,7 @@
           <p:cNvPr id="2" name="">
             <a:extLst xmlns:a="http://schemas.openxmlformats.org/drawingml/2006/main">
               <a:ext uri="{FF2B5EF4-FFF2-40B4-BE49-F238E27FC236}">
-                <a16:creationId xmlns:a16="http://schemas.microsoft.com/office/drawing/2014/main" id="{3E5A8F51-5A6F-47A2-9896-57C2A1B645F7}"/>
+                <a16:creationId xmlns:a16="http://schemas.microsoft.com/office/drawing/2014/main" id="{1A45A048-8D4F-436A-B1C4-8D62751226B1}"/>
               </a:ext>
             </a:extLst>
           </p:cNvPr>
@@ -10475,7 +10475,7 @@
           <p:cNvPr id="3" name="">
             <a:extLst xmlns:a="http://schemas.openxmlformats.org/drawingml/2006/main">
               <a:ext uri="{FF2B5EF4-FFF2-40B4-BE49-F238E27FC236}">
-                <a16:creationId xmlns:a16="http://schemas.microsoft.com/office/drawing/2014/main" id="{4BF54BF9-B5A0-40BF-8A37-157C6DAE4600}"/>
+                <a16:creationId xmlns:a16="http://schemas.microsoft.com/office/drawing/2014/main" id="{8788918E-6466-4823-BC20-99A86844C859}"/>
               </a:ext>
             </a:extLst>
           </p:cNvPr>
@@ -10525,7 +10525,7 @@
           <p:cNvPr id="4" name="">
             <a:extLst xmlns:a="http://schemas.openxmlformats.org/drawingml/2006/main">
               <a:ext uri="{FF2B5EF4-FFF2-40B4-BE49-F238E27FC236}">
-                <a16:creationId xmlns:a16="http://schemas.microsoft.com/office/drawing/2014/main" id="{263E54F3-9476-4A66-83C4-753BB7FBB424}"/>
+                <a16:creationId xmlns:a16="http://schemas.microsoft.com/office/drawing/2014/main" id="{92C1A9EE-09AE-4DEF-A0F2-933E36408353}"/>
               </a:ext>
             </a:extLst>
           </p:cNvPr>
@@ -10575,7 +10575,7 @@
           <p:cNvPr id="5" name="">
             <a:extLst xmlns:a="http://schemas.openxmlformats.org/drawingml/2006/main">
               <a:ext uri="{FF2B5EF4-FFF2-40B4-BE49-F238E27FC236}">
-                <a16:creationId xmlns:a16="http://schemas.microsoft.com/office/drawing/2014/main" id="{2BF1B6B1-AF71-4746-9442-9DD9AD50846B}"/>
+                <a16:creationId xmlns:a16="http://schemas.microsoft.com/office/drawing/2014/main" id="{3DE9A673-E3A1-4F2D-8138-B9F26E9ACD87}"/>
               </a:ext>
             </a:extLst>
           </p:cNvPr>
@@ -10625,7 +10625,7 @@
           <p:cNvPr id="6" name="">
             <a:extLst xmlns:a="http://schemas.openxmlformats.org/drawingml/2006/main">
               <a:ext uri="{FF2B5EF4-FFF2-40B4-BE49-F238E27FC236}">
-                <a16:creationId xmlns:a16="http://schemas.microsoft.com/office/drawing/2014/main" id="{73E39F4D-8F30-468D-BB5C-4F8BBDEAF0E5}"/>
+                <a16:creationId xmlns:a16="http://schemas.microsoft.com/office/drawing/2014/main" id="{1F2EF8FD-A353-4143-9CD4-6D288FDED4F5}"/>
               </a:ext>
             </a:extLst>
           </p:cNvPr>
@@ -10658,7 +10658,7 @@
           <p:cNvPr id="7" name="">
             <a:extLst xmlns:a="http://schemas.openxmlformats.org/drawingml/2006/main">
               <a:ext uri="{FF2B5EF4-FFF2-40B4-BE49-F238E27FC236}">
-                <a16:creationId xmlns:a16="http://schemas.microsoft.com/office/drawing/2014/main" id="{7B3F0927-0610-405E-A806-95D54EF66220}"/>
+                <a16:creationId xmlns:a16="http://schemas.microsoft.com/office/drawing/2014/main" id="{07583F61-EC84-450D-9BCD-EE59E221C0A0}"/>
               </a:ext>
             </a:extLst>
           </p:cNvPr>
@@ -10691,7 +10691,7 @@
           <p:cNvPr id="8" name="">
             <a:extLst xmlns:a="http://schemas.openxmlformats.org/drawingml/2006/main">
               <a:ext uri="{FF2B5EF4-FFF2-40B4-BE49-F238E27FC236}">
-                <a16:creationId xmlns:a16="http://schemas.microsoft.com/office/drawing/2014/main" id="{4483BABC-7DDC-402B-B776-224C8018D8C9}"/>
+                <a16:creationId xmlns:a16="http://schemas.microsoft.com/office/drawing/2014/main" id="{8582433B-F54D-4A49-BD2D-55C30F0BB1CA}"/>
               </a:ext>
             </a:extLst>
           </p:cNvPr>
@@ -10741,7 +10741,7 @@
           <p:cNvPr id="9" name="">
             <a:extLst xmlns:a="http://schemas.openxmlformats.org/drawingml/2006/main">
               <a:ext uri="{FF2B5EF4-FFF2-40B4-BE49-F238E27FC236}">
-                <a16:creationId xmlns:a16="http://schemas.microsoft.com/office/drawing/2014/main" id="{3FECE647-8CD1-4C2A-9C32-8E6EB91D4ABA}"/>
+                <a16:creationId xmlns:a16="http://schemas.microsoft.com/office/drawing/2014/main" id="{B4EBB0C5-D061-4CF8-BD3F-BDA603FDA843}"/>
               </a:ext>
             </a:extLst>
           </p:cNvPr>
@@ -10791,7 +10791,7 @@
           <p:cNvPr id="10" name="">
             <a:extLst xmlns:a="http://schemas.openxmlformats.org/drawingml/2006/main">
               <a:ext uri="{FF2B5EF4-FFF2-40B4-BE49-F238E27FC236}">
-                <a16:creationId xmlns:a16="http://schemas.microsoft.com/office/drawing/2014/main" id="{C6183D83-DB47-4C34-B3C9-D28C4A71F5C0}"/>
+                <a16:creationId xmlns:a16="http://schemas.microsoft.com/office/drawing/2014/main" id="{DDBE30F4-DE57-48F0-BF71-407E38734260}"/>
               </a:ext>
             </a:extLst>
           </p:cNvPr>
@@ -10841,7 +10841,7 @@
           <p:cNvPr id="11" name="">
             <a:extLst xmlns:a="http://schemas.openxmlformats.org/drawingml/2006/main">
               <a:ext uri="{FF2B5EF4-FFF2-40B4-BE49-F238E27FC236}">
-                <a16:creationId xmlns:a16="http://schemas.microsoft.com/office/drawing/2014/main" id="{199D6952-39D1-4B51-9BEB-9EF19C7A6C21}"/>
+                <a16:creationId xmlns:a16="http://schemas.microsoft.com/office/drawing/2014/main" id="{C8C655A1-FF02-4C74-93D8-985CB2D314DE}"/>
               </a:ext>
             </a:extLst>
           </p:cNvPr>
@@ -10874,7 +10874,7 @@
           <p:cNvPr id="12" name="">
             <a:extLst xmlns:a="http://schemas.openxmlformats.org/drawingml/2006/main">
               <a:ext uri="{FF2B5EF4-FFF2-40B4-BE49-F238E27FC236}">
-                <a16:creationId xmlns:a16="http://schemas.microsoft.com/office/drawing/2014/main" id="{C9D8AE76-4191-47EB-A946-C5708FE5A52A}"/>
+                <a16:creationId xmlns:a16="http://schemas.microsoft.com/office/drawing/2014/main" id="{9724BA96-AD43-4EDC-ADC0-E474336D4E7E}"/>
               </a:ext>
             </a:extLst>
           </p:cNvPr>
@@ -10907,7 +10907,7 @@
           <p:cNvPr id="13" name="">
             <a:extLst xmlns:a="http://schemas.openxmlformats.org/drawingml/2006/main">
               <a:ext uri="{FF2B5EF4-FFF2-40B4-BE49-F238E27FC236}">
-                <a16:creationId xmlns:a16="http://schemas.microsoft.com/office/drawing/2014/main" id="{507816E5-2A79-41D8-9DB7-DE47FCDC35FB}"/>
+                <a16:creationId xmlns:a16="http://schemas.microsoft.com/office/drawing/2014/main" id="{88DAA66D-5AAC-4F3D-A4A2-4F4BD2033B8D}"/>
               </a:ext>
             </a:extLst>
           </p:cNvPr>
@@ -10957,7 +10957,7 @@
           <p:cNvPr id="14" name="">
             <a:extLst xmlns:a="http://schemas.openxmlformats.org/drawingml/2006/main">
               <a:ext uri="{FF2B5EF4-FFF2-40B4-BE49-F238E27FC236}">
-                <a16:creationId xmlns:a16="http://schemas.microsoft.com/office/drawing/2014/main" id="{30EBA381-1607-4D1D-A241-B3A5BB8597B7}"/>
+                <a16:creationId xmlns:a16="http://schemas.microsoft.com/office/drawing/2014/main" id="{F5467DED-445D-4B1F-B9CC-CF21D85FF72B}"/>
               </a:ext>
             </a:extLst>
           </p:cNvPr>
@@ -11007,7 +11007,7 @@
           <p:cNvPr id="15" name="">
             <a:extLst xmlns:a="http://schemas.openxmlformats.org/drawingml/2006/main">
               <a:ext uri="{FF2B5EF4-FFF2-40B4-BE49-F238E27FC236}">
-                <a16:creationId xmlns:a16="http://schemas.microsoft.com/office/drawing/2014/main" id="{17F4FA37-8CA6-4CBD-A907-D4213472E5A7}"/>
+                <a16:creationId xmlns:a16="http://schemas.microsoft.com/office/drawing/2014/main" id="{BD513DDF-5A02-4A8D-BE18-44848D3A7AB1}"/>
               </a:ext>
             </a:extLst>
           </p:cNvPr>
@@ -11057,7 +11057,7 @@
           <p:cNvPr id="16" name="">
             <a:extLst xmlns:a="http://schemas.openxmlformats.org/drawingml/2006/main">
               <a:ext uri="{FF2B5EF4-FFF2-40B4-BE49-F238E27FC236}">
-                <a16:creationId xmlns:a16="http://schemas.microsoft.com/office/drawing/2014/main" id="{22AD4680-B429-4479-809C-824E9FFF5627}"/>
+                <a16:creationId xmlns:a16="http://schemas.microsoft.com/office/drawing/2014/main" id="{AA1EAD86-1D47-4761-9C7B-E66BCD197698}"/>
               </a:ext>
             </a:extLst>
           </p:cNvPr>
@@ -11090,7 +11090,7 @@
           <p:cNvPr id="17" name="">
             <a:extLst xmlns:a="http://schemas.openxmlformats.org/drawingml/2006/main">
               <a:ext uri="{FF2B5EF4-FFF2-40B4-BE49-F238E27FC236}">
-                <a16:creationId xmlns:a16="http://schemas.microsoft.com/office/drawing/2014/main" id="{126D251A-3C6E-4712-A58F-D3A8A1B36A11}"/>
+                <a16:creationId xmlns:a16="http://schemas.microsoft.com/office/drawing/2014/main" id="{ACA430AE-F7FC-431E-A589-F149F3F6D071}"/>
               </a:ext>
             </a:extLst>
           </p:cNvPr>
@@ -11123,7 +11123,7 @@
           <p:cNvPr id="18" name="">
             <a:extLst xmlns:a="http://schemas.openxmlformats.org/drawingml/2006/main">
               <a:ext uri="{FF2B5EF4-FFF2-40B4-BE49-F238E27FC236}">
-                <a16:creationId xmlns:a16="http://schemas.microsoft.com/office/drawing/2014/main" id="{43F2DF76-0823-49E1-93D3-05FFC9C39AEB}"/>
+                <a16:creationId xmlns:a16="http://schemas.microsoft.com/office/drawing/2014/main" id="{09EAF6BF-4A82-43C2-98F0-DEA94B5BAB92}"/>
               </a:ext>
             </a:extLst>
           </p:cNvPr>
@@ -11173,7 +11173,7 @@
           <p:cNvPr id="19" name="">
             <a:extLst xmlns:a="http://schemas.openxmlformats.org/drawingml/2006/main">
               <a:ext uri="{FF2B5EF4-FFF2-40B4-BE49-F238E27FC236}">
-                <a16:creationId xmlns:a16="http://schemas.microsoft.com/office/drawing/2014/main" id="{561C4A7D-8FE3-447C-99CA-E532B2A11E99}"/>
+                <a16:creationId xmlns:a16="http://schemas.microsoft.com/office/drawing/2014/main" id="{EFC61FFE-807D-4D16-945D-96D3BC540370}"/>
               </a:ext>
             </a:extLst>
           </p:cNvPr>
@@ -11223,7 +11223,7 @@
           <p:cNvPr id="20" name="">
             <a:extLst xmlns:a="http://schemas.openxmlformats.org/drawingml/2006/main">
               <a:ext uri="{FF2B5EF4-FFF2-40B4-BE49-F238E27FC236}">
-                <a16:creationId xmlns:a16="http://schemas.microsoft.com/office/drawing/2014/main" id="{0E37DF23-8BD4-483A-8603-A427D86CF3E1}"/>
+                <a16:creationId xmlns:a16="http://schemas.microsoft.com/office/drawing/2014/main" id="{79ECFFC7-BA4A-4ED4-911E-69214958165F}"/>
               </a:ext>
             </a:extLst>
           </p:cNvPr>
@@ -11273,7 +11273,7 @@
           <p:cNvPr id="21" name="">
             <a:extLst xmlns:a="http://schemas.openxmlformats.org/drawingml/2006/main">
               <a:ext uri="{FF2B5EF4-FFF2-40B4-BE49-F238E27FC236}">
-                <a16:creationId xmlns:a16="http://schemas.microsoft.com/office/drawing/2014/main" id="{EAE6F96F-6CE7-4F9B-8301-06B17A6E7A4D}"/>
+                <a16:creationId xmlns:a16="http://schemas.microsoft.com/office/drawing/2014/main" id="{AC1DDBE9-7793-456F-93CB-CA1BA54DD719}"/>
               </a:ext>
             </a:extLst>
           </p:cNvPr>
@@ -11306,7 +11306,7 @@
           <p:cNvPr id="22" name="">
             <a:extLst xmlns:a="http://schemas.openxmlformats.org/drawingml/2006/main">
               <a:ext uri="{FF2B5EF4-FFF2-40B4-BE49-F238E27FC236}">
-                <a16:creationId xmlns:a16="http://schemas.microsoft.com/office/drawing/2014/main" id="{F1ED99C4-0C36-41E1-8C9A-08B8A8F7675D}"/>
+                <a16:creationId xmlns:a16="http://schemas.microsoft.com/office/drawing/2014/main" id="{26616E33-154F-407C-9A10-731335642169}"/>
               </a:ext>
             </a:extLst>
           </p:cNvPr>
@@ -11339,7 +11339,7 @@
           <p:cNvPr id="23" name="">
             <a:extLst xmlns:a="http://schemas.openxmlformats.org/drawingml/2006/main">
               <a:ext uri="{FF2B5EF4-FFF2-40B4-BE49-F238E27FC236}">
-                <a16:creationId xmlns:a16="http://schemas.microsoft.com/office/drawing/2014/main" id="{29673DFE-8F87-4241-963B-1FF9EAFAFAE4}"/>
+                <a16:creationId xmlns:a16="http://schemas.microsoft.com/office/drawing/2014/main" id="{6E036D12-EF27-4251-8A8D-1F9CD97F9500}"/>
               </a:ext>
             </a:extLst>
           </p:cNvPr>
@@ -11389,7 +11389,7 @@
           <p:cNvPr id="24" name="">
             <a:extLst xmlns:a="http://schemas.openxmlformats.org/drawingml/2006/main">
               <a:ext uri="{FF2B5EF4-FFF2-40B4-BE49-F238E27FC236}">
-                <a16:creationId xmlns:a16="http://schemas.microsoft.com/office/drawing/2014/main" id="{DDD24398-5250-45F4-83F8-303F0CF996D1}"/>
+                <a16:creationId xmlns:a16="http://schemas.microsoft.com/office/drawing/2014/main" id="{918AFA21-7A12-48F4-8D02-C4D920575122}"/>
               </a:ext>
             </a:extLst>
           </p:cNvPr>
@@ -11439,7 +11439,7 @@
           <p:cNvPr id="25" name="">
             <a:extLst xmlns:a="http://schemas.openxmlformats.org/drawingml/2006/main">
               <a:ext uri="{FF2B5EF4-FFF2-40B4-BE49-F238E27FC236}">
-                <a16:creationId xmlns:a16="http://schemas.microsoft.com/office/drawing/2014/main" id="{CB225B25-B2C8-4997-BCC8-576256870F74}"/>
+                <a16:creationId xmlns:a16="http://schemas.microsoft.com/office/drawing/2014/main" id="{25726B6A-DDF5-44A3-99D3-0F84E46E21BA}"/>
               </a:ext>
             </a:extLst>
           </p:cNvPr>
@@ -11489,7 +11489,7 @@
           <p:cNvPr id="26" name="">
             <a:extLst xmlns:a="http://schemas.openxmlformats.org/drawingml/2006/main">
               <a:ext uri="{FF2B5EF4-FFF2-40B4-BE49-F238E27FC236}">
-                <a16:creationId xmlns:a16="http://schemas.microsoft.com/office/drawing/2014/main" id="{6C54AFEC-0C59-4A49-9CB6-F569B2D28134}"/>
+                <a16:creationId xmlns:a16="http://schemas.microsoft.com/office/drawing/2014/main" id="{546303F6-AFF1-4FB2-AB5D-14155C77A974}"/>
               </a:ext>
             </a:extLst>
           </p:cNvPr>
@@ -11522,7 +11522,7 @@
           <p:cNvPr id="27" name="">
             <a:extLst xmlns:a="http://schemas.openxmlformats.org/drawingml/2006/main">
               <a:ext uri="{FF2B5EF4-FFF2-40B4-BE49-F238E27FC236}">
-                <a16:creationId xmlns:a16="http://schemas.microsoft.com/office/drawing/2014/main" id="{D8D22FB5-ABEB-4F66-87F3-05EEBB5EE96E}"/>
+                <a16:creationId xmlns:a16="http://schemas.microsoft.com/office/drawing/2014/main" id="{4F3BEE25-DE09-4E3B-BE03-A38CC21D4B31}"/>
               </a:ext>
             </a:extLst>
           </p:cNvPr>
@@ -11555,7 +11555,7 @@
           <p:cNvPr id="28" name="">
             <a:extLst xmlns:a="http://schemas.openxmlformats.org/drawingml/2006/main">
               <a:ext uri="{FF2B5EF4-FFF2-40B4-BE49-F238E27FC236}">
-                <a16:creationId xmlns:a16="http://schemas.microsoft.com/office/drawing/2014/main" id="{ADBA2224-9A75-4B26-B277-89C58A416D5C}"/>
+                <a16:creationId xmlns:a16="http://schemas.microsoft.com/office/drawing/2014/main" id="{D2788066-0338-4D61-ADFD-CEBD75C8FC11}"/>
               </a:ext>
             </a:extLst>
           </p:cNvPr>
@@ -11605,7 +11605,7 @@
           <p:cNvPr id="29" name="">
             <a:extLst xmlns:a="http://schemas.openxmlformats.org/drawingml/2006/main">
               <a:ext uri="{FF2B5EF4-FFF2-40B4-BE49-F238E27FC236}">
-                <a16:creationId xmlns:a16="http://schemas.microsoft.com/office/drawing/2014/main" id="{65C7C726-6CFA-4009-B988-ABAF213CA03F}"/>
+                <a16:creationId xmlns:a16="http://schemas.microsoft.com/office/drawing/2014/main" id="{0BC63E5B-C069-4176-AD8F-21544828B3B9}"/>
               </a:ext>
             </a:extLst>
           </p:cNvPr>
@@ -11655,7 +11655,7 @@
           <p:cNvPr id="30" name="">
             <a:extLst xmlns:a="http://schemas.openxmlformats.org/drawingml/2006/main">
               <a:ext uri="{FF2B5EF4-FFF2-40B4-BE49-F238E27FC236}">
-                <a16:creationId xmlns:a16="http://schemas.microsoft.com/office/drawing/2014/main" id="{B09A5CB7-DB24-445A-B35A-FFCD559D4D61}"/>
+                <a16:creationId xmlns:a16="http://schemas.microsoft.com/office/drawing/2014/main" id="{66E06E64-C08F-44F8-89C6-2D25E8E46784}"/>
               </a:ext>
             </a:extLst>
           </p:cNvPr>
@@ -11705,7 +11705,7 @@
           <p:cNvPr id="31" name="">
             <a:extLst xmlns:a="http://schemas.openxmlformats.org/drawingml/2006/main">
               <a:ext uri="{FF2B5EF4-FFF2-40B4-BE49-F238E27FC236}">
-                <a16:creationId xmlns:a16="http://schemas.microsoft.com/office/drawing/2014/main" id="{5C5AD45D-980B-4ADB-B992-5DB31F18E07B}"/>
+                <a16:creationId xmlns:a16="http://schemas.microsoft.com/office/drawing/2014/main" id="{3D0C155F-ED59-4FC4-81C0-C85DC7BF857E}"/>
               </a:ext>
             </a:extLst>
           </p:cNvPr>
@@ -11738,7 +11738,7 @@
           <p:cNvPr id="32" name="">
             <a:extLst xmlns:a="http://schemas.openxmlformats.org/drawingml/2006/main">
               <a:ext uri="{FF2B5EF4-FFF2-40B4-BE49-F238E27FC236}">
-                <a16:creationId xmlns:a16="http://schemas.microsoft.com/office/drawing/2014/main" id="{4DCFC001-C60E-4109-B8B1-9D9F0E57A468}"/>
+                <a16:creationId xmlns:a16="http://schemas.microsoft.com/office/drawing/2014/main" id="{7424E096-8FC2-43E8-8359-2675ADD9E0D4}"/>
               </a:ext>
             </a:extLst>
           </p:cNvPr>
@@ -11771,7 +11771,7 @@
           <p:cNvPr id="33" name="">
             <a:extLst xmlns:a="http://schemas.openxmlformats.org/drawingml/2006/main">
               <a:ext uri="{FF2B5EF4-FFF2-40B4-BE49-F238E27FC236}">
-                <a16:creationId xmlns:a16="http://schemas.microsoft.com/office/drawing/2014/main" id="{D8F45E0A-1D81-451B-8617-690B1EAE150C}"/>
+                <a16:creationId xmlns:a16="http://schemas.microsoft.com/office/drawing/2014/main" id="{544B1818-8D46-45A2-B019-0761FD8620A6}"/>
               </a:ext>
             </a:extLst>
           </p:cNvPr>
@@ -11821,7 +11821,7 @@
           <p:cNvPr id="34" name="">
             <a:extLst xmlns:a="http://schemas.openxmlformats.org/drawingml/2006/main">
               <a:ext uri="{FF2B5EF4-FFF2-40B4-BE49-F238E27FC236}">
-                <a16:creationId xmlns:a16="http://schemas.microsoft.com/office/drawing/2014/main" id="{9C4C7A6C-94B5-44BF-BEAC-503AF289E5EA}"/>
+                <a16:creationId xmlns:a16="http://schemas.microsoft.com/office/drawing/2014/main" id="{E470CC5F-046F-4AE5-8349-EFCA8DD794D0}"/>
               </a:ext>
             </a:extLst>
           </p:cNvPr>
@@ -11871,7 +11871,7 @@
           <p:cNvPr id="35" name="">
             <a:extLst xmlns:a="http://schemas.openxmlformats.org/drawingml/2006/main">
               <a:ext uri="{FF2B5EF4-FFF2-40B4-BE49-F238E27FC236}">
-                <a16:creationId xmlns:a16="http://schemas.microsoft.com/office/drawing/2014/main" id="{081AD391-849D-407E-94F1-4962E099D414}"/>
+                <a16:creationId xmlns:a16="http://schemas.microsoft.com/office/drawing/2014/main" id="{FD8224B5-D364-45A0-8CA4-50962575F0EA}"/>
               </a:ext>
             </a:extLst>
           </p:cNvPr>
@@ -11921,7 +11921,7 @@
           <p:cNvPr id="36" name="">
             <a:extLst xmlns:a="http://schemas.openxmlformats.org/drawingml/2006/main">
               <a:ext uri="{FF2B5EF4-FFF2-40B4-BE49-F238E27FC236}">
-                <a16:creationId xmlns:a16="http://schemas.microsoft.com/office/drawing/2014/main" id="{943ACEC6-8D9D-4A92-8246-FADF7CA1DD97}"/>
+                <a16:creationId xmlns:a16="http://schemas.microsoft.com/office/drawing/2014/main" id="{622A58B5-D195-48B9-8966-4071A35E6B0E}"/>
               </a:ext>
             </a:extLst>
           </p:cNvPr>
@@ -11954,7 +11954,7 @@
           <p:cNvPr id="37" name="">
             <a:extLst xmlns:a="http://schemas.openxmlformats.org/drawingml/2006/main">
               <a:ext uri="{FF2B5EF4-FFF2-40B4-BE49-F238E27FC236}">
-                <a16:creationId xmlns:a16="http://schemas.microsoft.com/office/drawing/2014/main" id="{8131054F-2FC4-4740-9478-51832B9A26A5}"/>
+                <a16:creationId xmlns:a16="http://schemas.microsoft.com/office/drawing/2014/main" id="{F17C130D-AD03-4C1C-88F7-AC074DE59DD8}"/>
               </a:ext>
             </a:extLst>
           </p:cNvPr>
@@ -11987,7 +11987,7 @@
           <p:cNvPr id="38" name="">
             <a:extLst xmlns:a="http://schemas.openxmlformats.org/drawingml/2006/main">
               <a:ext uri="{FF2B5EF4-FFF2-40B4-BE49-F238E27FC236}">
-                <a16:creationId xmlns:a16="http://schemas.microsoft.com/office/drawing/2014/main" id="{5892A2A7-8D2A-4C34-8EE5-49BABC6CDB4E}"/>
+                <a16:creationId xmlns:a16="http://schemas.microsoft.com/office/drawing/2014/main" id="{F73021A4-3F2C-4976-ABFD-5AB8C9580067}"/>
               </a:ext>
             </a:extLst>
           </p:cNvPr>
@@ -12037,7 +12037,7 @@
           <p:cNvPr id="39" name="">
             <a:extLst xmlns:a="http://schemas.openxmlformats.org/drawingml/2006/main">
               <a:ext uri="{FF2B5EF4-FFF2-40B4-BE49-F238E27FC236}">
-                <a16:creationId xmlns:a16="http://schemas.microsoft.com/office/drawing/2014/main" id="{3C68BC0F-8EF0-4A81-A377-5D9637EAF806}"/>
+                <a16:creationId xmlns:a16="http://schemas.microsoft.com/office/drawing/2014/main" id="{7A4BE6EF-7E7D-4058-85EE-77F18390F365}"/>
               </a:ext>
             </a:extLst>
           </p:cNvPr>
@@ -12087,7 +12087,7 @@
           <p:cNvPr id="40" name="">
             <a:extLst xmlns:a="http://schemas.openxmlformats.org/drawingml/2006/main">
               <a:ext uri="{FF2B5EF4-FFF2-40B4-BE49-F238E27FC236}">
-                <a16:creationId xmlns:a16="http://schemas.microsoft.com/office/drawing/2014/main" id="{04EF1CDB-E3CC-4941-9850-9E84DF93CC78}"/>
+                <a16:creationId xmlns:a16="http://schemas.microsoft.com/office/drawing/2014/main" id="{D7B2BF2B-C9C3-4E52-9C1A-AC4375728BC8}"/>
               </a:ext>
             </a:extLst>
           </p:cNvPr>
@@ -12120,7 +12120,7 @@
           <p:cNvPr id="41" name="">
             <a:extLst xmlns:a="http://schemas.openxmlformats.org/drawingml/2006/main">
               <a:ext uri="{FF2B5EF4-FFF2-40B4-BE49-F238E27FC236}">
-                <a16:creationId xmlns:a16="http://schemas.microsoft.com/office/drawing/2014/main" id="{F24820AB-4DD9-45AA-B0F7-794270E69333}"/>
+                <a16:creationId xmlns:a16="http://schemas.microsoft.com/office/drawing/2014/main" id="{014A707E-6A90-4E25-8DF0-85C26453CC65}"/>
               </a:ext>
             </a:extLst>
           </p:cNvPr>
@@ -12153,7 +12153,7 @@
           <p:cNvPr id="42" name="">
             <a:extLst xmlns:a="http://schemas.openxmlformats.org/drawingml/2006/main">
               <a:ext uri="{FF2B5EF4-FFF2-40B4-BE49-F238E27FC236}">
-                <a16:creationId xmlns:a16="http://schemas.microsoft.com/office/drawing/2014/main" id="{AAA47A47-C9A2-41BA-97CF-E538B2B535B9}"/>
+                <a16:creationId xmlns:a16="http://schemas.microsoft.com/office/drawing/2014/main" id="{4D5AD5F2-8B60-4EB2-B9EB-342EAC8530FA}"/>
               </a:ext>
             </a:extLst>
           </p:cNvPr>
@@ -12203,7 +12203,7 @@
           <p:cNvPr id="43" name="">
             <a:extLst xmlns:a="http://schemas.openxmlformats.org/drawingml/2006/main">
               <a:ext uri="{FF2B5EF4-FFF2-40B4-BE49-F238E27FC236}">
-                <a16:creationId xmlns:a16="http://schemas.microsoft.com/office/drawing/2014/main" id="{4268708B-17B7-4CFF-8C94-4D39C6FD9CB9}"/>
+                <a16:creationId xmlns:a16="http://schemas.microsoft.com/office/drawing/2014/main" id="{D5F3ECB6-85D6-4E88-9944-576010B3491F}"/>
               </a:ext>
             </a:extLst>
           </p:cNvPr>
@@ -12253,7 +12253,7 @@
           <p:cNvPr id="44" name="">
             <a:extLst xmlns:a="http://schemas.openxmlformats.org/drawingml/2006/main">
               <a:ext uri="{FF2B5EF4-FFF2-40B4-BE49-F238E27FC236}">
-                <a16:creationId xmlns:a16="http://schemas.microsoft.com/office/drawing/2014/main" id="{4142DD96-2E23-4A80-8EED-EED016C57F8E}"/>
+                <a16:creationId xmlns:a16="http://schemas.microsoft.com/office/drawing/2014/main" id="{75AF744B-27D5-42AC-A52D-2B53FC7829C7}"/>
               </a:ext>
             </a:extLst>
           </p:cNvPr>
@@ -12286,7 +12286,7 @@
           <p:cNvPr id="45" name="">
             <a:extLst xmlns:a="http://schemas.openxmlformats.org/drawingml/2006/main">
               <a:ext uri="{FF2B5EF4-FFF2-40B4-BE49-F238E27FC236}">
-                <a16:creationId xmlns:a16="http://schemas.microsoft.com/office/drawing/2014/main" id="{19001EE3-B503-4FFE-9159-E2D8208FCCCF}"/>
+                <a16:creationId xmlns:a16="http://schemas.microsoft.com/office/drawing/2014/main" id="{EB387CF9-0A5E-4456-9300-ABFE45D2F289}"/>
               </a:ext>
             </a:extLst>
           </p:cNvPr>
@@ -12319,7 +12319,7 @@
           <p:cNvPr id="46" name="">
             <a:extLst xmlns:a="http://schemas.openxmlformats.org/drawingml/2006/main">
               <a:ext uri="{FF2B5EF4-FFF2-40B4-BE49-F238E27FC236}">
-                <a16:creationId xmlns:a16="http://schemas.microsoft.com/office/drawing/2014/main" id="{AED9DAA4-75BC-4A05-A23D-1F3D79950BE7}"/>
+                <a16:creationId xmlns:a16="http://schemas.microsoft.com/office/drawing/2014/main" id="{C468BC06-E26D-4AE6-820E-20EDFCD75575}"/>
               </a:ext>
             </a:extLst>
           </p:cNvPr>
@@ -12369,7 +12369,7 @@
           <p:cNvPr id="47" name="">
             <a:extLst xmlns:a="http://schemas.openxmlformats.org/drawingml/2006/main">
               <a:ext uri="{FF2B5EF4-FFF2-40B4-BE49-F238E27FC236}">
-                <a16:creationId xmlns:a16="http://schemas.microsoft.com/office/drawing/2014/main" id="{1BD4E905-D1FD-496F-A57F-FA6F61796E4D}"/>
+                <a16:creationId xmlns:a16="http://schemas.microsoft.com/office/drawing/2014/main" id="{250804D0-25F6-4561-832A-EC47B09B229A}"/>
               </a:ext>
             </a:extLst>
           </p:cNvPr>
@@ -12419,7 +12419,7 @@
           <p:cNvPr id="48" name="">
             <a:extLst xmlns:a="http://schemas.openxmlformats.org/drawingml/2006/main">
               <a:ext uri="{FF2B5EF4-FFF2-40B4-BE49-F238E27FC236}">
-                <a16:creationId xmlns:a16="http://schemas.microsoft.com/office/drawing/2014/main" id="{1301F91F-4134-4C42-9100-F12C304DBE6E}"/>
+                <a16:creationId xmlns:a16="http://schemas.microsoft.com/office/drawing/2014/main" id="{20857F47-6549-4FAE-B3D0-F94C816F1975}"/>
               </a:ext>
             </a:extLst>
           </p:cNvPr>
@@ -12467,7 +12467,7 @@
     </p:spTree>
     <p:extLst>
       <p:ext uri="{BB962C8B-B14F-4D97-AF65-F5344CB8AC3E}">
-        <p14:creationId xmlns:p14="http://schemas.microsoft.com/office/powerpoint/2010/main" val="1803336702"/>
+        <p14:creationId xmlns:p14="http://schemas.microsoft.com/office/powerpoint/2010/main" val="1451366259"/>
       </p:ext>
     </p:extLst>
   </p:cSld>
@@ -12498,7 +12498,7 @@
           <p:cNvPr id="25" name="">
             <a:extLst xmlns:a="http://schemas.openxmlformats.org/drawingml/2006/main">
               <a:ext uri="{FF2B5EF4-FFF2-40B4-BE49-F238E27FC236}">
-                <a16:creationId xmlns:a16="http://schemas.microsoft.com/office/drawing/2014/main" id="{766337C2-FBE0-4653-BBC4-9C4B443D3D54}"/>
+                <a16:creationId xmlns:a16="http://schemas.microsoft.com/office/drawing/2014/main" id="{8C30BDD0-D7CD-4228-B2B7-13E0E63E982C}"/>
               </a:ext>
             </a:extLst>
           </p:cNvPr>
@@ -12548,7 +12548,7 @@
           <p:cNvPr id="2" name="">
             <a:extLst xmlns:a="http://schemas.openxmlformats.org/drawingml/2006/main">
               <a:ext uri="{FF2B5EF4-FFF2-40B4-BE49-F238E27FC236}">
-                <a16:creationId xmlns:a16="http://schemas.microsoft.com/office/drawing/2014/main" id="{49BBEE2F-CEAE-46C6-BB3C-0DCDE847BBB2}"/>
+                <a16:creationId xmlns:a16="http://schemas.microsoft.com/office/drawing/2014/main" id="{4CDEC08E-8655-4CD7-8F50-CB2097DAF67C}"/>
               </a:ext>
             </a:extLst>
           </p:cNvPr>
@@ -12598,7 +12598,7 @@
           <p:cNvPr id="3" name="">
             <a:extLst xmlns:a="http://schemas.openxmlformats.org/drawingml/2006/main">
               <a:ext uri="{FF2B5EF4-FFF2-40B4-BE49-F238E27FC236}">
-                <a16:creationId xmlns:a16="http://schemas.microsoft.com/office/drawing/2014/main" id="{EAEFB7A2-DD34-44AC-9970-6E0B01463BB6}"/>
+                <a16:creationId xmlns:a16="http://schemas.microsoft.com/office/drawing/2014/main" id="{B939E9F1-6B4F-47E0-A5DC-6245CB02D766}"/>
               </a:ext>
             </a:extLst>
           </p:cNvPr>
@@ -12648,7 +12648,7 @@
           <p:cNvPr id="4" name="">
             <a:extLst xmlns:a="http://schemas.openxmlformats.org/drawingml/2006/main">
               <a:ext uri="{FF2B5EF4-FFF2-40B4-BE49-F238E27FC236}">
-                <a16:creationId xmlns:a16="http://schemas.microsoft.com/office/drawing/2014/main" id="{45A91C73-3D8B-4A84-9CC8-F8B474444E9B}"/>
+                <a16:creationId xmlns:a16="http://schemas.microsoft.com/office/drawing/2014/main" id="{CC2C520A-E7DD-444A-97B4-38B8AC730A0B}"/>
               </a:ext>
             </a:extLst>
           </p:cNvPr>
@@ -12698,7 +12698,7 @@
           <p:cNvPr id="5" name="">
             <a:extLst xmlns:a="http://schemas.openxmlformats.org/drawingml/2006/main">
               <a:ext uri="{FF2B5EF4-FFF2-40B4-BE49-F238E27FC236}">
-                <a16:creationId xmlns:a16="http://schemas.microsoft.com/office/drawing/2014/main" id="{709D81B8-C5D2-4395-B2FB-5D09696FCAF8}"/>
+                <a16:creationId xmlns:a16="http://schemas.microsoft.com/office/drawing/2014/main" id="{A37C5142-0440-4DC8-A85C-17DCA5A7886F}"/>
               </a:ext>
             </a:extLst>
           </p:cNvPr>
@@ -12748,7 +12748,7 @@
           <p:cNvPr id="6" name="">
             <a:extLst xmlns:a="http://schemas.openxmlformats.org/drawingml/2006/main">
               <a:ext uri="{FF2B5EF4-FFF2-40B4-BE49-F238E27FC236}">
-                <a16:creationId xmlns:a16="http://schemas.microsoft.com/office/drawing/2014/main" id="{3448FAF7-F488-4370-8297-31EE2A317093}"/>
+                <a16:creationId xmlns:a16="http://schemas.microsoft.com/office/drawing/2014/main" id="{D18D4CA1-D265-4DF7-8500-6B5D1169C6D8}"/>
               </a:ext>
             </a:extLst>
           </p:cNvPr>
@@ -12781,7 +12781,7 @@
           <p:cNvPr id="7" name="">
             <a:extLst xmlns:a="http://schemas.openxmlformats.org/drawingml/2006/main">
               <a:ext uri="{FF2B5EF4-FFF2-40B4-BE49-F238E27FC236}">
-                <a16:creationId xmlns:a16="http://schemas.microsoft.com/office/drawing/2014/main" id="{111919C5-87AA-4099-B732-126829662102}"/>
+                <a16:creationId xmlns:a16="http://schemas.microsoft.com/office/drawing/2014/main" id="{43F79AA9-6E94-43A9-9A2C-97B558DA1B3A}"/>
               </a:ext>
             </a:extLst>
           </p:cNvPr>
@@ -12831,7 +12831,7 @@
           <p:cNvPr id="8" name="">
             <a:extLst xmlns:a="http://schemas.openxmlformats.org/drawingml/2006/main">
               <a:ext uri="{FF2B5EF4-FFF2-40B4-BE49-F238E27FC236}">
-                <a16:creationId xmlns:a16="http://schemas.microsoft.com/office/drawing/2014/main" id="{68F42044-A071-41EA-93BF-EB8BE1AD1768}"/>
+                <a16:creationId xmlns:a16="http://schemas.microsoft.com/office/drawing/2014/main" id="{C9571239-C093-4653-B7A5-9447BF143224}"/>
               </a:ext>
             </a:extLst>
           </p:cNvPr>
@@ -12881,7 +12881,7 @@
           <p:cNvPr id="9" name="">
             <a:extLst xmlns:a="http://schemas.openxmlformats.org/drawingml/2006/main">
               <a:ext uri="{FF2B5EF4-FFF2-40B4-BE49-F238E27FC236}">
-                <a16:creationId xmlns:a16="http://schemas.microsoft.com/office/drawing/2014/main" id="{74FCA1E9-CBBF-470E-9CDF-CF7FCF1A36D8}"/>
+                <a16:creationId xmlns:a16="http://schemas.microsoft.com/office/drawing/2014/main" id="{19060BFF-13EE-44D9-A5E6-C39319DFF4ED}"/>
               </a:ext>
             </a:extLst>
           </p:cNvPr>
@@ -12931,7 +12931,7 @@
           <p:cNvPr id="10" name="">
             <a:extLst xmlns:a="http://schemas.openxmlformats.org/drawingml/2006/main">
               <a:ext uri="{FF2B5EF4-FFF2-40B4-BE49-F238E27FC236}">
-                <a16:creationId xmlns:a16="http://schemas.microsoft.com/office/drawing/2014/main" id="{667225C7-3A16-41E0-AE51-9E8045866170}"/>
+                <a16:creationId xmlns:a16="http://schemas.microsoft.com/office/drawing/2014/main" id="{E9980F35-234E-4813-A455-39D1C4206BC1}"/>
               </a:ext>
             </a:extLst>
           </p:cNvPr>
@@ -12964,7 +12964,7 @@
           <p:cNvPr id="11" name="">
             <a:extLst xmlns:a="http://schemas.openxmlformats.org/drawingml/2006/main">
               <a:ext uri="{FF2B5EF4-FFF2-40B4-BE49-F238E27FC236}">
-                <a16:creationId xmlns:a16="http://schemas.microsoft.com/office/drawing/2014/main" id="{94FF7B9D-4B01-4CAE-9412-51399CE61ED1}"/>
+                <a16:creationId xmlns:a16="http://schemas.microsoft.com/office/drawing/2014/main" id="{2882EDD5-C88A-4740-B7B4-2344900BB85A}"/>
               </a:ext>
             </a:extLst>
           </p:cNvPr>
@@ -13014,7 +13014,7 @@
           <p:cNvPr id="12" name="">
             <a:extLst xmlns:a="http://schemas.openxmlformats.org/drawingml/2006/main">
               <a:ext uri="{FF2B5EF4-FFF2-40B4-BE49-F238E27FC236}">
-                <a16:creationId xmlns:a16="http://schemas.microsoft.com/office/drawing/2014/main" id="{623DFB55-3680-4B71-90E9-3E56A3D51AE3}"/>
+                <a16:creationId xmlns:a16="http://schemas.microsoft.com/office/drawing/2014/main" id="{80E7B0B7-A6F2-4269-A54D-CBB5C9A42D09}"/>
               </a:ext>
             </a:extLst>
           </p:cNvPr>
@@ -13064,7 +13064,7 @@
           <p:cNvPr id="13" name="">
             <a:extLst xmlns:a="http://schemas.openxmlformats.org/drawingml/2006/main">
               <a:ext uri="{FF2B5EF4-FFF2-40B4-BE49-F238E27FC236}">
-                <a16:creationId xmlns:a16="http://schemas.microsoft.com/office/drawing/2014/main" id="{1B24C3DA-1BAA-47E1-AA46-3F2F217309FB}"/>
+                <a16:creationId xmlns:a16="http://schemas.microsoft.com/office/drawing/2014/main" id="{EB660820-95D1-4B7C-B096-48472485E92F}"/>
               </a:ext>
             </a:extLst>
           </p:cNvPr>
@@ -13097,7 +13097,7 @@
           <p:cNvPr id="14" name="">
             <a:extLst xmlns:a="http://schemas.openxmlformats.org/drawingml/2006/main">
               <a:ext uri="{FF2B5EF4-FFF2-40B4-BE49-F238E27FC236}">
-                <a16:creationId xmlns:a16="http://schemas.microsoft.com/office/drawing/2014/main" id="{24475BEA-0DEA-402D-A73C-9B6994503480}"/>
+                <a16:creationId xmlns:a16="http://schemas.microsoft.com/office/drawing/2014/main" id="{A5D11E0E-D8AA-4C1B-9C10-EC1DB5315A00}"/>
               </a:ext>
             </a:extLst>
           </p:cNvPr>
@@ -13147,7 +13147,7 @@
           <p:cNvPr id="15" name="">
             <a:extLst xmlns:a="http://schemas.openxmlformats.org/drawingml/2006/main">
               <a:ext uri="{FF2B5EF4-FFF2-40B4-BE49-F238E27FC236}">
-                <a16:creationId xmlns:a16="http://schemas.microsoft.com/office/drawing/2014/main" id="{852B5844-851D-4FB1-B6A5-43AF1480FE4C}"/>
+                <a16:creationId xmlns:a16="http://schemas.microsoft.com/office/drawing/2014/main" id="{68A70351-ECC7-40ED-A4C5-84384C45BFEB}"/>
               </a:ext>
             </a:extLst>
           </p:cNvPr>
@@ -13197,7 +13197,7 @@
           <p:cNvPr id="16" name="">
             <a:extLst xmlns:a="http://schemas.openxmlformats.org/drawingml/2006/main">
               <a:ext uri="{FF2B5EF4-FFF2-40B4-BE49-F238E27FC236}">
-                <a16:creationId xmlns:a16="http://schemas.microsoft.com/office/drawing/2014/main" id="{01DE44DC-0088-4DC1-9278-52224F360A73}"/>
+                <a16:creationId xmlns:a16="http://schemas.microsoft.com/office/drawing/2014/main" id="{B7C897AE-9134-47C1-B7D3-5ECF3078D0E6}"/>
               </a:ext>
             </a:extLst>
           </p:cNvPr>
@@ -13230,7 +13230,7 @@
           <p:cNvPr id="17" name="">
             <a:extLst xmlns:a="http://schemas.openxmlformats.org/drawingml/2006/main">
               <a:ext uri="{FF2B5EF4-FFF2-40B4-BE49-F238E27FC236}">
-                <a16:creationId xmlns:a16="http://schemas.microsoft.com/office/drawing/2014/main" id="{7D872532-C777-4EE3-B1CB-B767F9167326}"/>
+                <a16:creationId xmlns:a16="http://schemas.microsoft.com/office/drawing/2014/main" id="{63B2703B-9C83-4129-B837-7EDEEEC5F172}"/>
               </a:ext>
             </a:extLst>
           </p:cNvPr>
@@ -13263,7 +13263,7 @@
           <p:cNvPr id="18" name="">
             <a:extLst xmlns:a="http://schemas.openxmlformats.org/drawingml/2006/main">
               <a:ext uri="{FF2B5EF4-FFF2-40B4-BE49-F238E27FC236}">
-                <a16:creationId xmlns:a16="http://schemas.microsoft.com/office/drawing/2014/main" id="{29766D3F-E206-4A53-AD6A-F62D8723FB8D}"/>
+                <a16:creationId xmlns:a16="http://schemas.microsoft.com/office/drawing/2014/main" id="{EA9C7304-9307-4036-801D-F7F890FEACB9}"/>
               </a:ext>
             </a:extLst>
           </p:cNvPr>
@@ -13313,7 +13313,7 @@
           <p:cNvPr id="19" name="">
             <a:extLst xmlns:a="http://schemas.openxmlformats.org/drawingml/2006/main">
               <a:ext uri="{FF2B5EF4-FFF2-40B4-BE49-F238E27FC236}">
-                <a16:creationId xmlns:a16="http://schemas.microsoft.com/office/drawing/2014/main" id="{F3152FF8-DDDF-4C6C-AE6A-8544D99471AF}"/>
+                <a16:creationId xmlns:a16="http://schemas.microsoft.com/office/drawing/2014/main" id="{3C749618-57F1-4D29-BCD9-311CCDDFA45F}"/>
               </a:ext>
             </a:extLst>
           </p:cNvPr>
@@ -13397,7 +13397,7 @@
           <p:cNvPr id="20" name="">
             <a:extLst xmlns:a="http://schemas.openxmlformats.org/drawingml/2006/main">
               <a:ext uri="{FF2B5EF4-FFF2-40B4-BE49-F238E27FC236}">
-                <a16:creationId xmlns:a16="http://schemas.microsoft.com/office/drawing/2014/main" id="{9143BFBC-BBF3-4C71-AC6A-11B71F917159}"/>
+                <a16:creationId xmlns:a16="http://schemas.microsoft.com/office/drawing/2014/main" id="{28709029-EEED-45B2-978D-58F8A6497345}"/>
               </a:ext>
             </a:extLst>
           </p:cNvPr>
@@ -13430,7 +13430,7 @@
           <p:cNvPr id="21" name="">
             <a:extLst xmlns:a="http://schemas.openxmlformats.org/drawingml/2006/main">
               <a:ext uri="{FF2B5EF4-FFF2-40B4-BE49-F238E27FC236}">
-                <a16:creationId xmlns:a16="http://schemas.microsoft.com/office/drawing/2014/main" id="{34C51DA5-60F2-4C5C-978C-F18A85C56FE8}"/>
+                <a16:creationId xmlns:a16="http://schemas.microsoft.com/office/drawing/2014/main" id="{EA2A0AB8-A96A-4042-925D-D2D41D979E3B}"/>
               </a:ext>
             </a:extLst>
           </p:cNvPr>
@@ -13463,7 +13463,7 @@
           <p:cNvPr id="22" name="">
             <a:extLst xmlns:a="http://schemas.openxmlformats.org/drawingml/2006/main">
               <a:ext uri="{FF2B5EF4-FFF2-40B4-BE49-F238E27FC236}">
-                <a16:creationId xmlns:a16="http://schemas.microsoft.com/office/drawing/2014/main" id="{7BF5B836-A536-4834-9D3A-01E4FF0E867D}"/>
+                <a16:creationId xmlns:a16="http://schemas.microsoft.com/office/drawing/2014/main" id="{0F0B3D8A-5792-47BC-9D63-54E91094C30D}"/>
               </a:ext>
             </a:extLst>
           </p:cNvPr>
@@ -13513,7 +13513,7 @@
           <p:cNvPr id="23" name="">
             <a:extLst xmlns:a="http://schemas.openxmlformats.org/drawingml/2006/main">
               <a:ext uri="{FF2B5EF4-FFF2-40B4-BE49-F238E27FC236}">
-                <a16:creationId xmlns:a16="http://schemas.microsoft.com/office/drawing/2014/main" id="{030C810C-DC89-4C2F-BF92-6ACAA731207A}"/>
+                <a16:creationId xmlns:a16="http://schemas.microsoft.com/office/drawing/2014/main" id="{6A98DBE1-76F8-481E-B7DA-1B1C7383E8B9}"/>
               </a:ext>
             </a:extLst>
           </p:cNvPr>
@@ -13597,7 +13597,7 @@
           <p:cNvPr id="24" name="">
             <a:extLst xmlns:a="http://schemas.openxmlformats.org/drawingml/2006/main">
               <a:ext uri="{FF2B5EF4-FFF2-40B4-BE49-F238E27FC236}">
-                <a16:creationId xmlns:a16="http://schemas.microsoft.com/office/drawing/2014/main" id="{77B622FC-B021-481B-9237-F5454EEB4DC5}"/>
+                <a16:creationId xmlns:a16="http://schemas.microsoft.com/office/drawing/2014/main" id="{0513E761-C9C3-4A85-8C38-213936AF7966}"/>
               </a:ext>
             </a:extLst>
           </p:cNvPr>
@@ -13645,7 +13645,7 @@
     </p:spTree>
     <p:extLst>
       <p:ext uri="{BB962C8B-B14F-4D97-AF65-F5344CB8AC3E}">
-        <p14:creationId xmlns:p14="http://schemas.microsoft.com/office/powerpoint/2010/main" val="2073225231"/>
+        <p14:creationId xmlns:p14="http://schemas.microsoft.com/office/powerpoint/2010/main" val="1836588369"/>
       </p:ext>
     </p:extLst>
   </p:cSld>
@@ -13676,7 +13676,7 @@
           <p:cNvPr id="20" name="">
             <a:extLst xmlns:a="http://schemas.openxmlformats.org/drawingml/2006/main">
               <a:ext uri="{FF2B5EF4-FFF2-40B4-BE49-F238E27FC236}">
-                <a16:creationId xmlns:a16="http://schemas.microsoft.com/office/drawing/2014/main" id="{FE5AEE27-9C2C-47A8-B2E0-E800C0024985}"/>
+                <a16:creationId xmlns:a16="http://schemas.microsoft.com/office/drawing/2014/main" id="{7940CFFA-AB86-4E03-A1A0-93AC2B22F5B5}"/>
               </a:ext>
             </a:extLst>
           </p:cNvPr>
@@ -13726,7 +13726,7 @@
           <p:cNvPr id="2" name="">
             <a:extLst xmlns:a="http://schemas.openxmlformats.org/drawingml/2006/main">
               <a:ext uri="{FF2B5EF4-FFF2-40B4-BE49-F238E27FC236}">
-                <a16:creationId xmlns:a16="http://schemas.microsoft.com/office/drawing/2014/main" id="{AE444C58-951C-4E79-A7C4-E3BA91F73BAF}"/>
+                <a16:creationId xmlns:a16="http://schemas.microsoft.com/office/drawing/2014/main" id="{1F12AF4D-28A3-479E-B0AB-8159B3A470F4}"/>
               </a:ext>
             </a:extLst>
           </p:cNvPr>
@@ -13776,7 +13776,7 @@
           <p:cNvPr id="3" name="">
             <a:extLst xmlns:a="http://schemas.openxmlformats.org/drawingml/2006/main">
               <a:ext uri="{FF2B5EF4-FFF2-40B4-BE49-F238E27FC236}">
-                <a16:creationId xmlns:a16="http://schemas.microsoft.com/office/drawing/2014/main" id="{08FE2B9B-097B-4F28-A4C8-53C25455B0F3}"/>
+                <a16:creationId xmlns:a16="http://schemas.microsoft.com/office/drawing/2014/main" id="{15C791DB-0C4A-4F0A-95AF-55023FF179BE}"/>
               </a:ext>
             </a:extLst>
           </p:cNvPr>
@@ -13826,7 +13826,7 @@
           <p:cNvPr id="4" name="">
             <a:extLst xmlns:a="http://schemas.openxmlformats.org/drawingml/2006/main">
               <a:ext uri="{FF2B5EF4-FFF2-40B4-BE49-F238E27FC236}">
-                <a16:creationId xmlns:a16="http://schemas.microsoft.com/office/drawing/2014/main" id="{9A38B4BB-C344-4A3B-BB0C-566AED87563C}"/>
+                <a16:creationId xmlns:a16="http://schemas.microsoft.com/office/drawing/2014/main" id="{E271B4B2-54A3-480A-A6B7-AEE350F2F0AA}"/>
               </a:ext>
             </a:extLst>
           </p:cNvPr>
@@ -13876,7 +13876,7 @@
           <p:cNvPr id="5" name="">
             <a:extLst xmlns:a="http://schemas.openxmlformats.org/drawingml/2006/main">
               <a:ext uri="{FF2B5EF4-FFF2-40B4-BE49-F238E27FC236}">
-                <a16:creationId xmlns:a16="http://schemas.microsoft.com/office/drawing/2014/main" id="{A9752914-15EC-4250-9DE1-99151AB45D18}"/>
+                <a16:creationId xmlns:a16="http://schemas.microsoft.com/office/drawing/2014/main" id="{DA9AD9B4-DC51-48CA-9275-32C5BB47798B}"/>
               </a:ext>
             </a:extLst>
           </p:cNvPr>
@@ -13926,7 +13926,7 @@
           <p:cNvPr id="6" name="">
             <a:extLst xmlns:a="http://schemas.openxmlformats.org/drawingml/2006/main">
               <a:ext uri="{FF2B5EF4-FFF2-40B4-BE49-F238E27FC236}">
-                <a16:creationId xmlns:a16="http://schemas.microsoft.com/office/drawing/2014/main" id="{9B10CEDE-4419-4797-AE7F-2B78EC0D302C}"/>
+                <a16:creationId xmlns:a16="http://schemas.microsoft.com/office/drawing/2014/main" id="{F21BBD77-2325-4F9E-AB67-33357F2FDAC5}"/>
               </a:ext>
             </a:extLst>
           </p:cNvPr>
@@ -13959,7 +13959,7 @@
           <p:cNvPr id="7" name="">
             <a:extLst xmlns:a="http://schemas.openxmlformats.org/drawingml/2006/main">
               <a:ext uri="{FF2B5EF4-FFF2-40B4-BE49-F238E27FC236}">
-                <a16:creationId xmlns:a16="http://schemas.microsoft.com/office/drawing/2014/main" id="{29B5DBD8-DB9F-476F-A61F-0FF766FD1CBB}"/>
+                <a16:creationId xmlns:a16="http://schemas.microsoft.com/office/drawing/2014/main" id="{846A7C0E-C4EC-49B8-9855-9BCA5A994667}"/>
               </a:ext>
             </a:extLst>
           </p:cNvPr>
@@ -13992,7 +13992,7 @@
           <p:cNvPr id="8" name="">
             <a:extLst xmlns:a="http://schemas.openxmlformats.org/drawingml/2006/main">
               <a:ext uri="{FF2B5EF4-FFF2-40B4-BE49-F238E27FC236}">
-                <a16:creationId xmlns:a16="http://schemas.microsoft.com/office/drawing/2014/main" id="{6C236E0B-A3A2-46D9-8E05-5FB09A1929EE}"/>
+                <a16:creationId xmlns:a16="http://schemas.microsoft.com/office/drawing/2014/main" id="{1389F79E-3BA4-49DA-9863-C90173DC225B}"/>
               </a:ext>
             </a:extLst>
           </p:cNvPr>
@@ -14042,7 +14042,7 @@
           <p:cNvPr id="9" name="">
             <a:extLst xmlns:a="http://schemas.openxmlformats.org/drawingml/2006/main">
               <a:ext uri="{FF2B5EF4-FFF2-40B4-BE49-F238E27FC236}">
-                <a16:creationId xmlns:a16="http://schemas.microsoft.com/office/drawing/2014/main" id="{52E9CD5B-DE29-41A3-97C2-EF8E308168E5}"/>
+                <a16:creationId xmlns:a16="http://schemas.microsoft.com/office/drawing/2014/main" id="{B0E4C4CB-DDFB-449E-8ED1-E790AD0B080E}"/>
               </a:ext>
             </a:extLst>
           </p:cNvPr>
@@ -14092,7 +14092,7 @@
           <p:cNvPr id="10" name="">
             <a:extLst xmlns:a="http://schemas.openxmlformats.org/drawingml/2006/main">
               <a:ext uri="{FF2B5EF4-FFF2-40B4-BE49-F238E27FC236}">
-                <a16:creationId xmlns:a16="http://schemas.microsoft.com/office/drawing/2014/main" id="{0AC574E6-2E85-4047-85DE-5840866C8239}"/>
+                <a16:creationId xmlns:a16="http://schemas.microsoft.com/office/drawing/2014/main" id="{3C3443CC-3186-4881-9538-332B345857EF}"/>
               </a:ext>
             </a:extLst>
           </p:cNvPr>
@@ -14142,7 +14142,7 @@
           <p:cNvPr id="11" name="">
             <a:extLst xmlns:a="http://schemas.openxmlformats.org/drawingml/2006/main">
               <a:ext uri="{FF2B5EF4-FFF2-40B4-BE49-F238E27FC236}">
-                <a16:creationId xmlns:a16="http://schemas.microsoft.com/office/drawing/2014/main" id="{E77D1A04-4662-41C7-A9C2-FFB174C488D8}"/>
+                <a16:creationId xmlns:a16="http://schemas.microsoft.com/office/drawing/2014/main" id="{8383333F-8CD2-417E-A796-65B199B70374}"/>
               </a:ext>
             </a:extLst>
           </p:cNvPr>
@@ -14175,7 +14175,7 @@
           <p:cNvPr id="12" name="">
             <a:extLst xmlns:a="http://schemas.openxmlformats.org/drawingml/2006/main">
               <a:ext uri="{FF2B5EF4-FFF2-40B4-BE49-F238E27FC236}">
-                <a16:creationId xmlns:a16="http://schemas.microsoft.com/office/drawing/2014/main" id="{E632B644-5833-43A6-A7F6-698CA95EF091}"/>
+                <a16:creationId xmlns:a16="http://schemas.microsoft.com/office/drawing/2014/main" id="{945DD67E-FC02-4FF5-B471-4BD649E27B6A}"/>
               </a:ext>
             </a:extLst>
           </p:cNvPr>
@@ -14208,7 +14208,7 @@
           <p:cNvPr id="13" name="">
             <a:extLst xmlns:a="http://schemas.openxmlformats.org/drawingml/2006/main">
               <a:ext uri="{FF2B5EF4-FFF2-40B4-BE49-F238E27FC236}">
-                <a16:creationId xmlns:a16="http://schemas.microsoft.com/office/drawing/2014/main" id="{99CB4255-119A-4632-BB1F-1916E3AC61E8}"/>
+                <a16:creationId xmlns:a16="http://schemas.microsoft.com/office/drawing/2014/main" id="{A0246786-46FF-41E2-9132-29ECBC005751}"/>
               </a:ext>
             </a:extLst>
           </p:cNvPr>
@@ -14258,7 +14258,7 @@
           <p:cNvPr id="14" name="">
             <a:extLst xmlns:a="http://schemas.openxmlformats.org/drawingml/2006/main">
               <a:ext uri="{FF2B5EF4-FFF2-40B4-BE49-F238E27FC236}">
-                <a16:creationId xmlns:a16="http://schemas.microsoft.com/office/drawing/2014/main" id="{57136743-1EF0-492F-9B2A-6E7BDFE564E0}"/>
+                <a16:creationId xmlns:a16="http://schemas.microsoft.com/office/drawing/2014/main" id="{3F35A255-E94F-44D1-A97B-F4A15680C764}"/>
               </a:ext>
             </a:extLst>
           </p:cNvPr>
@@ -14308,7 +14308,7 @@
           <p:cNvPr id="15" name="">
             <a:extLst xmlns:a="http://schemas.openxmlformats.org/drawingml/2006/main">
               <a:ext uri="{FF2B5EF4-FFF2-40B4-BE49-F238E27FC236}">
-                <a16:creationId xmlns:a16="http://schemas.microsoft.com/office/drawing/2014/main" id="{D9CA2003-103F-4961-8E9A-3BC805D301D2}"/>
+                <a16:creationId xmlns:a16="http://schemas.microsoft.com/office/drawing/2014/main" id="{9A555019-5E00-4B38-8A9C-862E9C1937E0}"/>
               </a:ext>
             </a:extLst>
           </p:cNvPr>
@@ -14341,7 +14341,7 @@
           <p:cNvPr id="16" name="">
             <a:extLst xmlns:a="http://schemas.openxmlformats.org/drawingml/2006/main">
               <a:ext uri="{FF2B5EF4-FFF2-40B4-BE49-F238E27FC236}">
-                <a16:creationId xmlns:a16="http://schemas.microsoft.com/office/drawing/2014/main" id="{6B20035B-0F1D-4D12-8E14-95CF431CC161}"/>
+                <a16:creationId xmlns:a16="http://schemas.microsoft.com/office/drawing/2014/main" id="{F23F0946-E401-4FB1-B1F4-03F26DB99ADF}"/>
               </a:ext>
             </a:extLst>
           </p:cNvPr>
@@ -14374,7 +14374,7 @@
           <p:cNvPr id="17" name="">
             <a:extLst xmlns:a="http://schemas.openxmlformats.org/drawingml/2006/main">
               <a:ext uri="{FF2B5EF4-FFF2-40B4-BE49-F238E27FC236}">
-                <a16:creationId xmlns:a16="http://schemas.microsoft.com/office/drawing/2014/main" id="{DD522857-C1D3-4AC7-A556-8948A0CC6DB1}"/>
+                <a16:creationId xmlns:a16="http://schemas.microsoft.com/office/drawing/2014/main" id="{74ACDCFA-F2B9-4B22-B6E0-2EA176B5F569}"/>
               </a:ext>
             </a:extLst>
           </p:cNvPr>
@@ -14424,7 +14424,7 @@
           <p:cNvPr id="18" name="">
             <a:extLst xmlns:a="http://schemas.openxmlformats.org/drawingml/2006/main">
               <a:ext uri="{FF2B5EF4-FFF2-40B4-BE49-F238E27FC236}">
-                <a16:creationId xmlns:a16="http://schemas.microsoft.com/office/drawing/2014/main" id="{35CF6DCB-1401-4B8C-941D-E74E44647092}"/>
+                <a16:creationId xmlns:a16="http://schemas.microsoft.com/office/drawing/2014/main" id="{9111FDEF-0AE5-4A7A-A4CC-E6E25C600E77}"/>
               </a:ext>
             </a:extLst>
           </p:cNvPr>
@@ -14474,7 +14474,7 @@
           <p:cNvPr id="19" name="">
             <a:extLst xmlns:a="http://schemas.openxmlformats.org/drawingml/2006/main">
               <a:ext uri="{FF2B5EF4-FFF2-40B4-BE49-F238E27FC236}">
-                <a16:creationId xmlns:a16="http://schemas.microsoft.com/office/drawing/2014/main" id="{5734DDD9-8440-43DA-8569-2A9A9B96A27A}"/>
+                <a16:creationId xmlns:a16="http://schemas.microsoft.com/office/drawing/2014/main" id="{47FDE7B6-4FE1-4AF7-9BF1-0A65F22D4560}"/>
               </a:ext>
             </a:extLst>
           </p:cNvPr>
@@ -14522,7 +14522,7 @@
     </p:spTree>
     <p:extLst>
       <p:ext uri="{BB962C8B-B14F-4D97-AF65-F5344CB8AC3E}">
-        <p14:creationId xmlns:p14="http://schemas.microsoft.com/office/powerpoint/2010/main" val="2019257040"/>
+        <p14:creationId xmlns:p14="http://schemas.microsoft.com/office/powerpoint/2010/main" val="1415591902"/>
       </p:ext>
     </p:extLst>
   </p:cSld>
@@ -14553,7 +14553,7 @@
           <p:cNvPr id="25" name="">
             <a:extLst xmlns:a="http://schemas.openxmlformats.org/drawingml/2006/main">
               <a:ext uri="{FF2B5EF4-FFF2-40B4-BE49-F238E27FC236}">
-                <a16:creationId xmlns:a16="http://schemas.microsoft.com/office/drawing/2014/main" id="{66A84A22-46ED-4AC4-A7D9-0B98D5523D3D}"/>
+                <a16:creationId xmlns:a16="http://schemas.microsoft.com/office/drawing/2014/main" id="{396260A4-8C56-49C6-A6A9-F1C317500CB0}"/>
               </a:ext>
             </a:extLst>
           </p:cNvPr>
@@ -14603,7 +14603,7 @@
           <p:cNvPr id="2" name="">
             <a:extLst xmlns:a="http://schemas.openxmlformats.org/drawingml/2006/main">
               <a:ext uri="{FF2B5EF4-FFF2-40B4-BE49-F238E27FC236}">
-                <a16:creationId xmlns:a16="http://schemas.microsoft.com/office/drawing/2014/main" id="{21C6517E-C40F-4F39-99FD-CAD26AD612A0}"/>
+                <a16:creationId xmlns:a16="http://schemas.microsoft.com/office/drawing/2014/main" id="{C77ED5B6-CFEC-4B7A-88A3-A0A650915DCC}"/>
               </a:ext>
             </a:extLst>
           </p:cNvPr>
@@ -14653,7 +14653,7 @@
           <p:cNvPr id="3" name="">
             <a:extLst xmlns:a="http://schemas.openxmlformats.org/drawingml/2006/main">
               <a:ext uri="{FF2B5EF4-FFF2-40B4-BE49-F238E27FC236}">
-                <a16:creationId xmlns:a16="http://schemas.microsoft.com/office/drawing/2014/main" id="{57EABB3C-411E-4A87-8814-EE6C0FD5408F}"/>
+                <a16:creationId xmlns:a16="http://schemas.microsoft.com/office/drawing/2014/main" id="{F954C0F9-0A98-4B80-8B69-D91E6F21F484}"/>
               </a:ext>
             </a:extLst>
           </p:cNvPr>
@@ -14703,7 +14703,7 @@
           <p:cNvPr id="4" name="">
             <a:extLst xmlns:a="http://schemas.openxmlformats.org/drawingml/2006/main">
               <a:ext uri="{FF2B5EF4-FFF2-40B4-BE49-F238E27FC236}">
-                <a16:creationId xmlns:a16="http://schemas.microsoft.com/office/drawing/2014/main" id="{A7634172-09E3-4E3B-BDD6-106C49D42A7A}"/>
+                <a16:creationId xmlns:a16="http://schemas.microsoft.com/office/drawing/2014/main" id="{CD60C035-9355-4606-835F-B0D9D3DC968F}"/>
               </a:ext>
             </a:extLst>
           </p:cNvPr>
@@ -14753,7 +14753,7 @@
           <p:cNvPr id="5" name="">
             <a:extLst xmlns:a="http://schemas.openxmlformats.org/drawingml/2006/main">
               <a:ext uri="{FF2B5EF4-FFF2-40B4-BE49-F238E27FC236}">
-                <a16:creationId xmlns:a16="http://schemas.microsoft.com/office/drawing/2014/main" id="{9590A82A-F632-4E9F-AD18-7CD24CEFBA71}"/>
+                <a16:creationId xmlns:a16="http://schemas.microsoft.com/office/drawing/2014/main" id="{FF5E46AA-0B67-4589-A655-9193B1FFB333}"/>
               </a:ext>
             </a:extLst>
           </p:cNvPr>
@@ -14803,7 +14803,7 @@
           <p:cNvPr id="6" name="">
             <a:extLst xmlns:a="http://schemas.openxmlformats.org/drawingml/2006/main">
               <a:ext uri="{FF2B5EF4-FFF2-40B4-BE49-F238E27FC236}">
-                <a16:creationId xmlns:a16="http://schemas.microsoft.com/office/drawing/2014/main" id="{62C269A2-0E62-403C-9613-52B0F10615CA}"/>
+                <a16:creationId xmlns:a16="http://schemas.microsoft.com/office/drawing/2014/main" id="{7AE5F343-9AC9-4F43-81E4-637CD0BE8E3C}"/>
               </a:ext>
             </a:extLst>
           </p:cNvPr>
@@ -14836,7 +14836,7 @@
           <p:cNvPr id="7" name="">
             <a:extLst xmlns:a="http://schemas.openxmlformats.org/drawingml/2006/main">
               <a:ext uri="{FF2B5EF4-FFF2-40B4-BE49-F238E27FC236}">
-                <a16:creationId xmlns:a16="http://schemas.microsoft.com/office/drawing/2014/main" id="{2C95B36F-9583-4EDD-8162-F65FA2C2C86C}"/>
+                <a16:creationId xmlns:a16="http://schemas.microsoft.com/office/drawing/2014/main" id="{74BB3A12-F4F4-422D-9958-90F2C0BBF25A}"/>
               </a:ext>
             </a:extLst>
           </p:cNvPr>
@@ -14869,7 +14869,7 @@
           <p:cNvPr id="8" name="">
             <a:extLst xmlns:a="http://schemas.openxmlformats.org/drawingml/2006/main">
               <a:ext uri="{FF2B5EF4-FFF2-40B4-BE49-F238E27FC236}">
-                <a16:creationId xmlns:a16="http://schemas.microsoft.com/office/drawing/2014/main" id="{A3DD0D04-3DE1-4E2C-85A6-45047ACC0149}"/>
+                <a16:creationId xmlns:a16="http://schemas.microsoft.com/office/drawing/2014/main" id="{B431F4D9-4C2F-42BC-8DE9-DB698E092641}"/>
               </a:ext>
             </a:extLst>
           </p:cNvPr>
@@ -14919,7 +14919,7 @@
           <p:cNvPr id="9" name="">
             <a:extLst xmlns:a="http://schemas.openxmlformats.org/drawingml/2006/main">
               <a:ext uri="{FF2B5EF4-FFF2-40B4-BE49-F238E27FC236}">
-                <a16:creationId xmlns:a16="http://schemas.microsoft.com/office/drawing/2014/main" id="{F3FFFBEA-B0E8-47B8-B6B2-720B20B8FA03}"/>
+                <a16:creationId xmlns:a16="http://schemas.microsoft.com/office/drawing/2014/main" id="{6B8CE927-5AD7-4979-839F-360D626BA302}"/>
               </a:ext>
             </a:extLst>
           </p:cNvPr>
@@ -14969,7 +14969,7 @@
           <p:cNvPr id="10" name="">
             <a:extLst xmlns:a="http://schemas.openxmlformats.org/drawingml/2006/main">
               <a:ext uri="{FF2B5EF4-FFF2-40B4-BE49-F238E27FC236}">
-                <a16:creationId xmlns:a16="http://schemas.microsoft.com/office/drawing/2014/main" id="{BF2372F0-AC52-4759-9F81-CA53501A602F}"/>
+                <a16:creationId xmlns:a16="http://schemas.microsoft.com/office/drawing/2014/main" id="{7ED5B94D-3DD1-4052-BA3A-7499882350F0}"/>
               </a:ext>
             </a:extLst>
           </p:cNvPr>
@@ -15002,7 +15002,7 @@
           <p:cNvPr id="11" name="">
             <a:extLst xmlns:a="http://schemas.openxmlformats.org/drawingml/2006/main">
               <a:ext uri="{FF2B5EF4-FFF2-40B4-BE49-F238E27FC236}">
-                <a16:creationId xmlns:a16="http://schemas.microsoft.com/office/drawing/2014/main" id="{5BB31179-8352-4DEE-8C3F-4ECAF86E575B}"/>
+                <a16:creationId xmlns:a16="http://schemas.microsoft.com/office/drawing/2014/main" id="{0310CE44-F995-45C7-B81F-D95E9886D4E4}"/>
               </a:ext>
             </a:extLst>
           </p:cNvPr>
@@ -15035,7 +15035,7 @@
           <p:cNvPr id="12" name="">
             <a:extLst xmlns:a="http://schemas.openxmlformats.org/drawingml/2006/main">
               <a:ext uri="{FF2B5EF4-FFF2-40B4-BE49-F238E27FC236}">
-                <a16:creationId xmlns:a16="http://schemas.microsoft.com/office/drawing/2014/main" id="{BB8F2BFA-CD50-4A2C-B4DD-7250B2EBB6F3}"/>
+                <a16:creationId xmlns:a16="http://schemas.microsoft.com/office/drawing/2014/main" id="{A0EC9860-DD8B-4DC6-9298-8B51B09267FA}"/>
               </a:ext>
             </a:extLst>
           </p:cNvPr>
@@ -15085,7 +15085,7 @@
           <p:cNvPr id="13" name="">
             <a:extLst xmlns:a="http://schemas.openxmlformats.org/drawingml/2006/main">
               <a:ext uri="{FF2B5EF4-FFF2-40B4-BE49-F238E27FC236}">
-                <a16:creationId xmlns:a16="http://schemas.microsoft.com/office/drawing/2014/main" id="{1F234D4B-B316-4521-AE56-14B3D1C4A309}"/>
+                <a16:creationId xmlns:a16="http://schemas.microsoft.com/office/drawing/2014/main" id="{CECD840C-753C-45C2-AE4D-C04074C0832D}"/>
               </a:ext>
             </a:extLst>
           </p:cNvPr>
@@ -15135,7 +15135,7 @@
           <p:cNvPr id="14" name="">
             <a:extLst xmlns:a="http://schemas.openxmlformats.org/drawingml/2006/main">
               <a:ext uri="{FF2B5EF4-FFF2-40B4-BE49-F238E27FC236}">
-                <a16:creationId xmlns:a16="http://schemas.microsoft.com/office/drawing/2014/main" id="{64B40280-E9AE-4121-9AD3-70BDFE1BF864}"/>
+                <a16:creationId xmlns:a16="http://schemas.microsoft.com/office/drawing/2014/main" id="{2BFD7C3F-1DCF-441E-8542-09219AD3F2CF}"/>
               </a:ext>
             </a:extLst>
           </p:cNvPr>
@@ -15168,7 +15168,7 @@
           <p:cNvPr id="15" name="">
             <a:extLst xmlns:a="http://schemas.openxmlformats.org/drawingml/2006/main">
               <a:ext uri="{FF2B5EF4-FFF2-40B4-BE49-F238E27FC236}">
-                <a16:creationId xmlns:a16="http://schemas.microsoft.com/office/drawing/2014/main" id="{7F599A37-B416-4DA2-BF87-A02CC312813B}"/>
+                <a16:creationId xmlns:a16="http://schemas.microsoft.com/office/drawing/2014/main" id="{57D9BA3A-5A0E-4092-8502-210AD6FF5EA7}"/>
               </a:ext>
             </a:extLst>
           </p:cNvPr>
@@ -15201,7 +15201,7 @@
           <p:cNvPr id="16" name="">
             <a:extLst xmlns:a="http://schemas.openxmlformats.org/drawingml/2006/main">
               <a:ext uri="{FF2B5EF4-FFF2-40B4-BE49-F238E27FC236}">
-                <a16:creationId xmlns:a16="http://schemas.microsoft.com/office/drawing/2014/main" id="{1589491F-C9D0-4787-8DCD-AEE9C18A823D}"/>
+                <a16:creationId xmlns:a16="http://schemas.microsoft.com/office/drawing/2014/main" id="{3A0D5688-3C71-445D-8B01-6C5EE98FDFE5}"/>
               </a:ext>
             </a:extLst>
           </p:cNvPr>
@@ -15251,7 +15251,7 @@
           <p:cNvPr id="17" name="">
             <a:extLst xmlns:a="http://schemas.openxmlformats.org/drawingml/2006/main">
               <a:ext uri="{FF2B5EF4-FFF2-40B4-BE49-F238E27FC236}">
-                <a16:creationId xmlns:a16="http://schemas.microsoft.com/office/drawing/2014/main" id="{5CFEC22E-FE37-4F5C-BC00-FBE8EDD8C505}"/>
+                <a16:creationId xmlns:a16="http://schemas.microsoft.com/office/drawing/2014/main" id="{65F6ACD9-0FAA-4F19-9A77-0E549E0D75B3}"/>
               </a:ext>
             </a:extLst>
           </p:cNvPr>
@@ -15301,7 +15301,7 @@
           <p:cNvPr id="18" name="">
             <a:extLst xmlns:a="http://schemas.openxmlformats.org/drawingml/2006/main">
               <a:ext uri="{FF2B5EF4-FFF2-40B4-BE49-F238E27FC236}">
-                <a16:creationId xmlns:a16="http://schemas.microsoft.com/office/drawing/2014/main" id="{503D8F56-FB8E-454D-8B44-9C6EC87BCD1A}"/>
+                <a16:creationId xmlns:a16="http://schemas.microsoft.com/office/drawing/2014/main" id="{2A9945C3-38F1-4B9A-8CEC-6355773DDD1D}"/>
               </a:ext>
             </a:extLst>
           </p:cNvPr>
@@ -15351,7 +15351,7 @@
           <p:cNvPr id="19" name="">
             <a:extLst xmlns:a="http://schemas.openxmlformats.org/drawingml/2006/main">
               <a:ext uri="{FF2B5EF4-FFF2-40B4-BE49-F238E27FC236}">
-                <a16:creationId xmlns:a16="http://schemas.microsoft.com/office/drawing/2014/main" id="{404954CD-E693-4615-9664-CDB410AAB891}"/>
+                <a16:creationId xmlns:a16="http://schemas.microsoft.com/office/drawing/2014/main" id="{5C1019EB-C4BE-4353-A98C-3554945F282C}"/>
               </a:ext>
             </a:extLst>
           </p:cNvPr>
@@ -15384,7 +15384,7 @@
           <p:cNvPr id="20" name="">
             <a:extLst xmlns:a="http://schemas.openxmlformats.org/drawingml/2006/main">
               <a:ext uri="{FF2B5EF4-FFF2-40B4-BE49-F238E27FC236}">
-                <a16:creationId xmlns:a16="http://schemas.microsoft.com/office/drawing/2014/main" id="{AA0D59CD-DF12-4CE2-BE05-8B10B28F309C}"/>
+                <a16:creationId xmlns:a16="http://schemas.microsoft.com/office/drawing/2014/main" id="{A7A8AF2F-9994-4E49-815D-FE030BEC5F57}"/>
               </a:ext>
             </a:extLst>
           </p:cNvPr>
@@ -15424,7 +15424,7 @@
                   <a:srgbClr val="1877F2"/>
                 </a:solidFill>
               </a:rPr>
-              <a:t>214 TESTS</a:t>
+              <a:t>215 TESTS</a:t>
             </a:r>
           </a:p>
         </p:txBody>
@@ -15434,7 +15434,7 @@
           <p:cNvPr id="21" name="">
             <a:extLst xmlns:a="http://schemas.openxmlformats.org/drawingml/2006/main">
               <a:ext uri="{FF2B5EF4-FFF2-40B4-BE49-F238E27FC236}">
-                <a16:creationId xmlns:a16="http://schemas.microsoft.com/office/drawing/2014/main" id="{3D1A1592-E721-4877-A710-9AEEFAD1B630}"/>
+                <a16:creationId xmlns:a16="http://schemas.microsoft.com/office/drawing/2014/main" id="{6D7F42E0-384E-440A-8B86-EBF39F1E0B8A}"/>
               </a:ext>
             </a:extLst>
           </p:cNvPr>
@@ -15467,7 +15467,7 @@
           <p:cNvPr id="22" name="">
             <a:extLst xmlns:a="http://schemas.openxmlformats.org/drawingml/2006/main">
               <a:ext uri="{FF2B5EF4-FFF2-40B4-BE49-F238E27FC236}">
-                <a16:creationId xmlns:a16="http://schemas.microsoft.com/office/drawing/2014/main" id="{C3B1087A-6168-4628-B0A9-FAD89EB5A30F}"/>
+                <a16:creationId xmlns:a16="http://schemas.microsoft.com/office/drawing/2014/main" id="{DF2B2838-E0F6-4E6C-912A-E3F37031EDFB}"/>
               </a:ext>
             </a:extLst>
           </p:cNvPr>
@@ -15517,7 +15517,7 @@
           <p:cNvPr id="23" name="">
             <a:extLst xmlns:a="http://schemas.openxmlformats.org/drawingml/2006/main">
               <a:ext uri="{FF2B5EF4-FFF2-40B4-BE49-F238E27FC236}">
-                <a16:creationId xmlns:a16="http://schemas.microsoft.com/office/drawing/2014/main" id="{32374BD4-787B-4F6E-8E50-D3E4A26F5882}"/>
+                <a16:creationId xmlns:a16="http://schemas.microsoft.com/office/drawing/2014/main" id="{57B436F5-49C1-4122-99EC-44D396610BCA}"/>
               </a:ext>
             </a:extLst>
           </p:cNvPr>
@@ -15550,7 +15550,7 @@
           <p:cNvPr id="24" name="">
             <a:extLst xmlns:a="http://schemas.openxmlformats.org/drawingml/2006/main">
               <a:ext uri="{FF2B5EF4-FFF2-40B4-BE49-F238E27FC236}">
-                <a16:creationId xmlns:a16="http://schemas.microsoft.com/office/drawing/2014/main" id="{01003CD8-6ACD-46FE-829B-1A467705A8A6}"/>
+                <a16:creationId xmlns:a16="http://schemas.microsoft.com/office/drawing/2014/main" id="{7228C966-C42F-4803-A3D9-F0F2FF2AA8DF}"/>
               </a:ext>
             </a:extLst>
           </p:cNvPr>
@@ -15598,7 +15598,7 @@
     </p:spTree>
     <p:extLst>
       <p:ext uri="{BB962C8B-B14F-4D97-AF65-F5344CB8AC3E}">
-        <p14:creationId xmlns:p14="http://schemas.microsoft.com/office/powerpoint/2010/main" val="1846433498"/>
+        <p14:creationId xmlns:p14="http://schemas.microsoft.com/office/powerpoint/2010/main" val="1457764319"/>
       </p:ext>
     </p:extLst>
   </p:cSld>
@@ -15629,7 +15629,7 @@
           <p:cNvPr id="19" name="">
             <a:extLst xmlns:a="http://schemas.openxmlformats.org/drawingml/2006/main">
               <a:ext uri="{FF2B5EF4-FFF2-40B4-BE49-F238E27FC236}">
-                <a16:creationId xmlns:a16="http://schemas.microsoft.com/office/drawing/2014/main" id="{0AF33840-264B-48D8-A4B8-AEE89F9B1957}"/>
+                <a16:creationId xmlns:a16="http://schemas.microsoft.com/office/drawing/2014/main" id="{E25675A5-6115-457B-9F1B-02C61A17136F}"/>
               </a:ext>
             </a:extLst>
           </p:cNvPr>
@@ -15679,7 +15679,7 @@
           <p:cNvPr id="2" name="">
             <a:extLst xmlns:a="http://schemas.openxmlformats.org/drawingml/2006/main">
               <a:ext uri="{FF2B5EF4-FFF2-40B4-BE49-F238E27FC236}">
-                <a16:creationId xmlns:a16="http://schemas.microsoft.com/office/drawing/2014/main" id="{C404BE0B-65B0-4DF1-B348-D65F647956D8}"/>
+                <a16:creationId xmlns:a16="http://schemas.microsoft.com/office/drawing/2014/main" id="{5DB4B067-70AE-4459-BDC8-812FEE60016D}"/>
               </a:ext>
             </a:extLst>
           </p:cNvPr>
@@ -15729,7 +15729,7 @@
           <p:cNvPr id="3" name="">
             <a:extLst xmlns:a="http://schemas.openxmlformats.org/drawingml/2006/main">
               <a:ext uri="{FF2B5EF4-FFF2-40B4-BE49-F238E27FC236}">
-                <a16:creationId xmlns:a16="http://schemas.microsoft.com/office/drawing/2014/main" id="{5F2D4BE7-B34D-43D3-9811-A9778FA74623}"/>
+                <a16:creationId xmlns:a16="http://schemas.microsoft.com/office/drawing/2014/main" id="{8B1432F4-DE1E-424D-9A5C-97279097CFEA}"/>
               </a:ext>
             </a:extLst>
           </p:cNvPr>
@@ -15779,7 +15779,7 @@
           <p:cNvPr id="4" name="">
             <a:extLst xmlns:a="http://schemas.openxmlformats.org/drawingml/2006/main">
               <a:ext uri="{FF2B5EF4-FFF2-40B4-BE49-F238E27FC236}">
-                <a16:creationId xmlns:a16="http://schemas.microsoft.com/office/drawing/2014/main" id="{FCF32C09-10FD-4765-A80F-280BE5B83705}"/>
+                <a16:creationId xmlns:a16="http://schemas.microsoft.com/office/drawing/2014/main" id="{68C77586-D6D1-4E16-9C47-3A4990D0A7E2}"/>
               </a:ext>
             </a:extLst>
           </p:cNvPr>
@@ -15829,7 +15829,7 @@
           <p:cNvPr id="5" name="">
             <a:extLst xmlns:a="http://schemas.openxmlformats.org/drawingml/2006/main">
               <a:ext uri="{FF2B5EF4-FFF2-40B4-BE49-F238E27FC236}">
-                <a16:creationId xmlns:a16="http://schemas.microsoft.com/office/drawing/2014/main" id="{3D89532E-789D-4FBF-8C83-125763D7E5E9}"/>
+                <a16:creationId xmlns:a16="http://schemas.microsoft.com/office/drawing/2014/main" id="{EE728111-A5C1-4CD3-8580-0866CF4473FC}"/>
               </a:ext>
             </a:extLst>
           </p:cNvPr>
@@ -15879,7 +15879,7 @@
           <p:cNvPr id="6" name="">
             <a:extLst xmlns:a="http://schemas.openxmlformats.org/drawingml/2006/main">
               <a:ext uri="{FF2B5EF4-FFF2-40B4-BE49-F238E27FC236}">
-                <a16:creationId xmlns:a16="http://schemas.microsoft.com/office/drawing/2014/main" id="{EA2DF39A-6A5F-4421-99C4-7B77EF0A3D42}"/>
+                <a16:creationId xmlns:a16="http://schemas.microsoft.com/office/drawing/2014/main" id="{C3057F8A-0894-4A24-B6C2-15459A37780D}"/>
               </a:ext>
             </a:extLst>
           </p:cNvPr>
@@ -15912,7 +15912,7 @@
           <p:cNvPr id="7" name="">
             <a:extLst xmlns:a="http://schemas.openxmlformats.org/drawingml/2006/main">
               <a:ext uri="{FF2B5EF4-FFF2-40B4-BE49-F238E27FC236}">
-                <a16:creationId xmlns:a16="http://schemas.microsoft.com/office/drawing/2014/main" id="{0D00EC5F-F971-4EA6-BE75-674133DBE42E}"/>
+                <a16:creationId xmlns:a16="http://schemas.microsoft.com/office/drawing/2014/main" id="{76647FFA-530C-4D50-9D4F-F6B2E2714DEA}"/>
               </a:ext>
             </a:extLst>
           </p:cNvPr>
@@ -15945,7 +15945,7 @@
           <p:cNvPr id="8" name="">
             <a:extLst xmlns:a="http://schemas.openxmlformats.org/drawingml/2006/main">
               <a:ext uri="{FF2B5EF4-FFF2-40B4-BE49-F238E27FC236}">
-                <a16:creationId xmlns:a16="http://schemas.microsoft.com/office/drawing/2014/main" id="{D67D27FD-E532-49FE-B19E-AF67E398D92A}"/>
+                <a16:creationId xmlns:a16="http://schemas.microsoft.com/office/drawing/2014/main" id="{644CDDCD-CE27-483A-B546-5B45B3A16801}"/>
               </a:ext>
             </a:extLst>
           </p:cNvPr>
@@ -15995,7 +15995,7 @@
           <p:cNvPr id="9" name="">
             <a:extLst xmlns:a="http://schemas.openxmlformats.org/drawingml/2006/main">
               <a:ext uri="{FF2B5EF4-FFF2-40B4-BE49-F238E27FC236}">
-                <a16:creationId xmlns:a16="http://schemas.microsoft.com/office/drawing/2014/main" id="{A7A56934-3703-4653-AAFC-B1408AD70CA5}"/>
+                <a16:creationId xmlns:a16="http://schemas.microsoft.com/office/drawing/2014/main" id="{C4438BE9-524F-4112-8909-D844E9B52F86}"/>
               </a:ext>
             </a:extLst>
           </p:cNvPr>
@@ -16096,7 +16096,7 @@
           <p:cNvPr id="10" name="">
             <a:extLst xmlns:a="http://schemas.openxmlformats.org/drawingml/2006/main">
               <a:ext uri="{FF2B5EF4-FFF2-40B4-BE49-F238E27FC236}">
-                <a16:creationId xmlns:a16="http://schemas.microsoft.com/office/drawing/2014/main" id="{6C4E45BA-248F-490C-A055-1DF2B1C615FA}"/>
+                <a16:creationId xmlns:a16="http://schemas.microsoft.com/office/drawing/2014/main" id="{18FB5671-AAE5-446E-98A1-808996DDED3E}"/>
               </a:ext>
             </a:extLst>
           </p:cNvPr>
@@ -16129,7 +16129,7 @@
           <p:cNvPr id="11" name="">
             <a:extLst xmlns:a="http://schemas.openxmlformats.org/drawingml/2006/main">
               <a:ext uri="{FF2B5EF4-FFF2-40B4-BE49-F238E27FC236}">
-                <a16:creationId xmlns:a16="http://schemas.microsoft.com/office/drawing/2014/main" id="{6BBD15EE-B68F-46BD-9879-4865FEFC256C}"/>
+                <a16:creationId xmlns:a16="http://schemas.microsoft.com/office/drawing/2014/main" id="{FF7F9D54-CB30-4FC2-B200-70D84D6797F3}"/>
               </a:ext>
             </a:extLst>
           </p:cNvPr>
@@ -16162,7 +16162,7 @@
           <p:cNvPr id="12" name="">
             <a:extLst xmlns:a="http://schemas.openxmlformats.org/drawingml/2006/main">
               <a:ext uri="{FF2B5EF4-FFF2-40B4-BE49-F238E27FC236}">
-                <a16:creationId xmlns:a16="http://schemas.microsoft.com/office/drawing/2014/main" id="{B0A2988E-0CD5-4171-8D48-E789B4C916C9}"/>
+                <a16:creationId xmlns:a16="http://schemas.microsoft.com/office/drawing/2014/main" id="{50AD5E50-2B42-4216-93D0-385261F86C1E}"/>
               </a:ext>
             </a:extLst>
           </p:cNvPr>
@@ -16212,7 +16212,7 @@
           <p:cNvPr id="13" name="">
             <a:extLst xmlns:a="http://schemas.openxmlformats.org/drawingml/2006/main">
               <a:ext uri="{FF2B5EF4-FFF2-40B4-BE49-F238E27FC236}">
-                <a16:creationId xmlns:a16="http://schemas.microsoft.com/office/drawing/2014/main" id="{632A0BD1-7074-4558-921A-D88EF02DEA14}"/>
+                <a16:creationId xmlns:a16="http://schemas.microsoft.com/office/drawing/2014/main" id="{38947842-EF9F-4634-A681-D97C1A5DABC0}"/>
               </a:ext>
             </a:extLst>
           </p:cNvPr>
@@ -16296,7 +16296,7 @@
           <p:cNvPr id="14" name="">
             <a:extLst xmlns:a="http://schemas.openxmlformats.org/drawingml/2006/main">
               <a:ext uri="{FF2B5EF4-FFF2-40B4-BE49-F238E27FC236}">
-                <a16:creationId xmlns:a16="http://schemas.microsoft.com/office/drawing/2014/main" id="{471248BE-848A-4ACB-9AC3-665D37D80D66}"/>
+                <a16:creationId xmlns:a16="http://schemas.microsoft.com/office/drawing/2014/main" id="{C7F28ADD-D7E5-4438-B787-2F7BB25F9960}"/>
               </a:ext>
             </a:extLst>
           </p:cNvPr>
@@ -16329,7 +16329,7 @@
           <p:cNvPr id="15" name="">
             <a:extLst xmlns:a="http://schemas.openxmlformats.org/drawingml/2006/main">
               <a:ext uri="{FF2B5EF4-FFF2-40B4-BE49-F238E27FC236}">
-                <a16:creationId xmlns:a16="http://schemas.microsoft.com/office/drawing/2014/main" id="{CF44A5A1-48C3-417D-9CC5-E435E30ADC47}"/>
+                <a16:creationId xmlns:a16="http://schemas.microsoft.com/office/drawing/2014/main" id="{E5B47789-2330-4078-9E9A-E2ACBF7D359C}"/>
               </a:ext>
             </a:extLst>
           </p:cNvPr>
@@ -16362,7 +16362,7 @@
           <p:cNvPr id="16" name="">
             <a:extLst xmlns:a="http://schemas.openxmlformats.org/drawingml/2006/main">
               <a:ext uri="{FF2B5EF4-FFF2-40B4-BE49-F238E27FC236}">
-                <a16:creationId xmlns:a16="http://schemas.microsoft.com/office/drawing/2014/main" id="{A0104FB7-E51C-4BD6-9AE5-344AD697CB4D}"/>
+                <a16:creationId xmlns:a16="http://schemas.microsoft.com/office/drawing/2014/main" id="{4B7588ED-8B44-4661-8542-AD76ACD993A3}"/>
               </a:ext>
             </a:extLst>
           </p:cNvPr>
@@ -16412,7 +16412,7 @@
           <p:cNvPr id="17" name="">
             <a:extLst xmlns:a="http://schemas.openxmlformats.org/drawingml/2006/main">
               <a:ext uri="{FF2B5EF4-FFF2-40B4-BE49-F238E27FC236}">
-                <a16:creationId xmlns:a16="http://schemas.microsoft.com/office/drawing/2014/main" id="{F995715E-FB38-4E61-9F51-CB5A8A8782A3}"/>
+                <a16:creationId xmlns:a16="http://schemas.microsoft.com/office/drawing/2014/main" id="{EA6619D8-E803-42B5-94EA-4673A3EB337C}"/>
               </a:ext>
             </a:extLst>
           </p:cNvPr>
@@ -16513,7 +16513,7 @@
           <p:cNvPr id="18" name="">
             <a:extLst xmlns:a="http://schemas.openxmlformats.org/drawingml/2006/main">
               <a:ext uri="{FF2B5EF4-FFF2-40B4-BE49-F238E27FC236}">
-                <a16:creationId xmlns:a16="http://schemas.microsoft.com/office/drawing/2014/main" id="{91BB6298-BDC3-47AB-BC16-BE1DC9485EBF}"/>
+                <a16:creationId xmlns:a16="http://schemas.microsoft.com/office/drawing/2014/main" id="{E56846BA-5C2A-49C8-8FC5-FC422CB4614D}"/>
               </a:ext>
             </a:extLst>
           </p:cNvPr>
@@ -16561,7 +16561,7 @@
     </p:spTree>
     <p:extLst>
       <p:ext uri="{BB962C8B-B14F-4D97-AF65-F5344CB8AC3E}">
-        <p14:creationId xmlns:p14="http://schemas.microsoft.com/office/powerpoint/2010/main" val="1115183015"/>
+        <p14:creationId xmlns:p14="http://schemas.microsoft.com/office/powerpoint/2010/main" val="735011666"/>
       </p:ext>
     </p:extLst>
   </p:cSld>

</xml_diff>